<commit_message>
Finalize submission artifacts and publish technical book
</commit_message>
<xml_diff>
--- a/outputs/presentation/ad_safety_management_presentation.pptx
+++ b/outputs/presentation/ad_safety_management_presentation.pptx
@@ -2,27 +2,27 @@
 <file path=ppt/presentation.xml><?xml version="1.0" encoding="utf-8"?>
 <p:presentation xmlns:p="http://schemas.openxmlformats.org/presentationml/2006/main">
   <p:sldMasterIdLst>
-    <p:sldMasterId xmlns:r="http://schemas.openxmlformats.org/officeDocument/2006/relationships" id="2147483648" r:id="R9ab7e9d1c0e4406c"/>
+    <p:sldMasterId xmlns:r="http://schemas.openxmlformats.org/officeDocument/2006/relationships" id="2147483648" r:id="R9257e630ef6f4511"/>
   </p:sldMasterIdLst>
   <p:notesMasterIdLst>
-    <p:notesMasterId xmlns:r="http://schemas.openxmlformats.org/officeDocument/2006/relationships" r:id="Rc03d91404ff645bc"/>
+    <p:notesMasterId xmlns:r="http://schemas.openxmlformats.org/officeDocument/2006/relationships" r:id="R9b5642d6fd0c492d"/>
   </p:notesMasterIdLst>
   <p:sldIdLst>
-    <p:sldId xmlns:r="http://schemas.openxmlformats.org/officeDocument/2006/relationships" id="256" r:id="R7eafb40ad8bf489c"/>
-    <p:sldId xmlns:r="http://schemas.openxmlformats.org/officeDocument/2006/relationships" id="257" r:id="Rbda0fcb9a3794cd7"/>
-    <p:sldId xmlns:r="http://schemas.openxmlformats.org/officeDocument/2006/relationships" id="258" r:id="Rb791c7866ded4ef5"/>
-    <p:sldId xmlns:r="http://schemas.openxmlformats.org/officeDocument/2006/relationships" id="259" r:id="R1f478de0006e4237"/>
-    <p:sldId xmlns:r="http://schemas.openxmlformats.org/officeDocument/2006/relationships" id="260" r:id="R349913da469f4efe"/>
-    <p:sldId xmlns:r="http://schemas.openxmlformats.org/officeDocument/2006/relationships" id="261" r:id="Rc41818e64b2c4de2"/>
-    <p:sldId xmlns:r="http://schemas.openxmlformats.org/officeDocument/2006/relationships" id="262" r:id="Re5a5ddd803884a47"/>
-    <p:sldId xmlns:r="http://schemas.openxmlformats.org/officeDocument/2006/relationships" id="263" r:id="R3b34bf4532174e8f"/>
-    <p:sldId xmlns:r="http://schemas.openxmlformats.org/officeDocument/2006/relationships" id="264" r:id="Raa898651360848db"/>
-    <p:sldId xmlns:r="http://schemas.openxmlformats.org/officeDocument/2006/relationships" id="265" r:id="Rfc2262a12cf9441a"/>
-    <p:sldId xmlns:r="http://schemas.openxmlformats.org/officeDocument/2006/relationships" id="266" r:id="R1977108032da445a"/>
-    <p:sldId xmlns:r="http://schemas.openxmlformats.org/officeDocument/2006/relationships" id="267" r:id="R90f9ed259ff0482e"/>
-    <p:sldId xmlns:r="http://schemas.openxmlformats.org/officeDocument/2006/relationships" id="268" r:id="R8ef678d5078f4167"/>
-    <p:sldId xmlns:r="http://schemas.openxmlformats.org/officeDocument/2006/relationships" id="269" r:id="Rf3cfbd49168849fa"/>
-    <p:sldId xmlns:r="http://schemas.openxmlformats.org/officeDocument/2006/relationships" id="270" r:id="R45560397c4344b46"/>
+    <p:sldId xmlns:r="http://schemas.openxmlformats.org/officeDocument/2006/relationships" id="256" r:id="Rd9a11146e44f41ae"/>
+    <p:sldId xmlns:r="http://schemas.openxmlformats.org/officeDocument/2006/relationships" id="257" r:id="R574ccac31f144bfe"/>
+    <p:sldId xmlns:r="http://schemas.openxmlformats.org/officeDocument/2006/relationships" id="258" r:id="R9594063be6014e3d"/>
+    <p:sldId xmlns:r="http://schemas.openxmlformats.org/officeDocument/2006/relationships" id="259" r:id="R7628d38a36f341ad"/>
+    <p:sldId xmlns:r="http://schemas.openxmlformats.org/officeDocument/2006/relationships" id="260" r:id="R7968b0affc6140ec"/>
+    <p:sldId xmlns:r="http://schemas.openxmlformats.org/officeDocument/2006/relationships" id="261" r:id="R64f6afe3730346b4"/>
+    <p:sldId xmlns:r="http://schemas.openxmlformats.org/officeDocument/2006/relationships" id="262" r:id="R0443ebba4bc745ad"/>
+    <p:sldId xmlns:r="http://schemas.openxmlformats.org/officeDocument/2006/relationships" id="263" r:id="Rc8e808f0f6724bd3"/>
+    <p:sldId xmlns:r="http://schemas.openxmlformats.org/officeDocument/2006/relationships" id="264" r:id="Rbd8923c45c8f470e"/>
+    <p:sldId xmlns:r="http://schemas.openxmlformats.org/officeDocument/2006/relationships" id="265" r:id="R28e9a9d1a0204a28"/>
+    <p:sldId xmlns:r="http://schemas.openxmlformats.org/officeDocument/2006/relationships" id="266" r:id="R3ab8f807fd294ce8"/>
+    <p:sldId xmlns:r="http://schemas.openxmlformats.org/officeDocument/2006/relationships" id="267" r:id="Ra44aaf3176de4318"/>
+    <p:sldId xmlns:r="http://schemas.openxmlformats.org/officeDocument/2006/relationships" id="268" r:id="R0877d198892145b0"/>
+    <p:sldId xmlns:r="http://schemas.openxmlformats.org/officeDocument/2006/relationships" id="269" r:id="R1636a0112fb04707"/>
+    <p:sldId xmlns:r="http://schemas.openxmlformats.org/officeDocument/2006/relationships" id="270" r:id="Ra183c444236545e8"/>
   </p:sldIdLst>
   <p:sldSz cx="12192000" cy="6858000"/>
   <p:notesSz cx="6858000" cy="9144000"/>
@@ -172,9 +172,9 @@
 </file>
 
 <file path=ppt/notesMasters/theme/theme3.xml><?xml version="1.0" encoding="utf-8"?>
-<a:theme xmlns:a="http://schemas.openxmlformats.org/drawingml/2006/main" name="ChatGPT">
+<a:theme xmlns:a="http://schemas.openxmlformats.org/drawingml/2006/main" name="Ad Safety Project">
   <a:themeElements>
-    <a:clrScheme name="ChatGPT">
+    <a:clrScheme name="Ad Safety Project">
       <a:dk1>
         <a:srgbClr val="000000"/>
       </a:dk1>
@@ -224,7 +224,7 @@
         <a:cs typeface="Calibri"/>
       </a:minorFont>
     </a:fontScheme>
-    <a:fmtScheme name="ChatGPT">
+    <a:fmtScheme name="Ad Safety Project">
       <a:fillStyleLst>
         <a:solidFill>
           <a:schemeClr val="phClr"/>
@@ -461,7 +461,27 @@
           </a:p>
           <a:p xmlns:a="http://schemas.openxmlformats.org/drawingml/2006/main">
             <a:r>
-              <a:t>Key message: The formal pilot is strong, but the external audit shows that the present evidence is not production-grade.</a:t>
+              <a:t>Target time: 50 seconds</a:t>
+            </a:r>
+          </a:p>
+          <a:p xmlns:a="http://schemas.openxmlformats.org/drawingml/2006/main">
+            <a:r>
+              <a:t>Key message: The demo can help reviewers sort cases, but the external check shows that it is not ready to decide cases on its own.</a:t>
+            </a:r>
+          </a:p>
+          <a:p xmlns:a="http://schemas.openxmlformats.org/drawingml/2006/main">
+            <a:r>
+              <a:t/>
+            </a:r>
+          </a:p>
+          <a:p xmlns:a="http://schemas.openxmlformats.org/drawingml/2006/main">
+            <a:r>
+              <a:t>[Speaker script]</a:t>
+            </a:r>
+          </a:p>
+          <a:p xmlns:a="http://schemas.openxmlformats.org/drawingml/2006/main">
+            <a:r>
+              <a:t>Good afternoon. We built Ad Safety Studio as a decision-support tool for a reviewer, not as an automatic policy judge. On our formal 48-image test, the model reached 0.979 macro F1, where 1 is best and every class counts equally. On a small external diagnostic set, that score fell to 0.555. That gap is the main story today. The local demo works, records the evidence behind each decision, and can help sort a review queue. It is not ready to make enforcement decisions on its own. I will return to that recommendation at the end. First, Vijay will introduce the team.</a:t>
             </a:r>
           </a:p>
           <a:p xmlns:a="http://schemas.openxmlformats.org/drawingml/2006/main">
@@ -571,7 +591,27 @@
           </a:p>
           <a:p xmlns:a="http://schemas.openxmlformats.org/drawingml/2006/main">
             <a:r>
+              <a:t>Target time: 70 seconds</a:t>
+            </a:r>
+          </a:p>
+          <a:p xmlns:a="http://schemas.openxmlformats.org/drawingml/2006/main">
+            <a:r>
               <a:t>Key message: The ViT leads the ResNet baseline on the untouched 48-image test. Safe precision is 1.0, so the proposal's &gt;0.98 Safe-class precision benchmark passes. Recall semantics differ: 0.97222 is multiclass-argmax restricted class-average recall, while validation-threshold operating recall averages 0.94444 and has a 0.91667 worst class. The threshold code used a validation tuning floor of &gt;=0.90; that is not the proposal acceptance target of per-class restricted recall &gt;0.95, which fails on the untouched test for firearms and explosives. ViT classifier-path p95 is 71.527 ms, above 50 ms; full end-to-end p95 is unassessed.</a:t>
+            </a:r>
+          </a:p>
+          <a:p xmlns:a="http://schemas.openxmlformats.org/drawingml/2006/main">
+            <a:r>
+              <a:t/>
+            </a:r>
+          </a:p>
+          <a:p xmlns:a="http://schemas.openxmlformats.org/drawingml/2006/main">
+            <a:r>
+              <a:t>[Speaker script]</a:t>
+            </a:r>
+          </a:p>
+          <a:p xmlns:a="http://schemas.openxmlformats.org/drawingml/2006/main">
+            <a:r>
+              <a:t>On the untouched 48-image test, ViT reached 0.97913 macro F1, compared with 0.87315 for the ResNet-50 baseline. Safe precision was 1.0, so it passed the proposal target above 0.98, and none of the 12 safe test images crossed into a restricted class. The main caveat is recall. Under the operating thresholds, restricted-class recall averaged 0.94444, with a low value of 0.91667. Firearms and explosives were both below the proposal target of greater than 0.95 for every restricted class. The 0.97222 number uses simple highest-score classification, so it is a different metric. Speed also favors ResNet. ViT classifier-path p95 was 71.527 milliseconds, above the 50-millisecond target, while ResNet was 40.064. This benchmark excludes decoding, OCR, detection, network time, and rendering, so full end-to-end p95 is still unknown. Vijay will look at the one formal error.</a:t>
             </a:r>
           </a:p>
           <a:p xmlns:a="http://schemas.openxmlformats.org/drawingml/2006/main">
@@ -686,7 +726,27 @@
           </a:p>
           <a:p xmlns:a="http://schemas.openxmlformats.org/drawingml/2006/main">
             <a:r>
-              <a:t>Key message: The single formal failure is restricted-to-restricted, but it exposes weak explosives separation and did not meet either automatic block threshold.</a:t>
+              <a:t>Target time: 45 seconds</a:t>
+            </a:r>
+          </a:p>
+          <a:p xmlns:a="http://schemas.openxmlformats.org/drawingml/2006/main">
+            <a:r>
+              <a:t>Key message: The only wrong class label went to REVIEW, but it still exposes fragile separation between firearms and explosives.</a:t>
+            </a:r>
+          </a:p>
+          <a:p xmlns:a="http://schemas.openxmlformats.org/drawingml/2006/main">
+            <a:r>
+              <a:t/>
+            </a:r>
+          </a:p>
+          <a:p xmlns:a="http://schemas.openxmlformats.org/drawingml/2006/main">
+            <a:r>
+              <a:t>[Speaker script]</a:t>
+            </a:r>
+          </a:p>
+          <a:p xmlns:a="http://schemas.openxmlformats.org/drawingml/2006/main">
+            <a:r>
+              <a:t>The formal test had one wrong class label. A grenade image labeled explosives was predicted as firearms, while the other 47 labels were correct. More importantly, its firearm and explosive scores did not cross either class-specific block threshold. In the saved policy run, the case went to REVIEW rather than an automatic block or approval. The optional detector found restricted-object cues, but the class separation was still fragile. This is exactly the kind of edge case that makes the human review step necessary. Myetchae will now show what happened outside the pilot sources.</a:t>
             </a:r>
           </a:p>
           <a:p xmlns:a="http://schemas.openxmlformats.org/drawingml/2006/main">
@@ -791,7 +851,27 @@
           </a:p>
           <a:p xmlns:a="http://schemas.openxmlformats.org/drawingml/2006/main">
             <a:r>
-              <a:t>Key message: The 26-image Wikimedia diagnostic exposes domain shift: classifier macro F1 falls to 0.55489 and the detector flags 90 percent of nonweapon images.</a:t>
+              <a:t>Target time: 60 seconds</a:t>
+            </a:r>
+          </a:p>
+          <a:p xmlns:a="http://schemas.openxmlformats.org/drawingml/2006/main">
+            <a:r>
+              <a:t>Key message: In the small selected Wikimedia diagnostic, macro F1 falls to 0.55489 and 90 percent of nonweapon images receive a false detector signal.</a:t>
+            </a:r>
+          </a:p>
+          <a:p xmlns:a="http://schemas.openxmlformats.org/drawingml/2006/main">
+            <a:r>
+              <a:t/>
+            </a:r>
+          </a:p>
+          <a:p xmlns:a="http://schemas.openxmlformats.org/drawingml/2006/main">
+            <a:r>
+              <a:t>[Speaker script]</a:t>
+            </a:r>
+          </a:p>
+          <a:p xmlns:a="http://schemas.openxmlformats.org/drawingml/2006/main">
+            <a:r>
+              <a:t>The external check used 26 manually reviewed Wikimedia images for diagnosis, not as a second formal test set. Macro F1 fell to 0.55489. At the current detector threshold, 90 percent of the nonweapon images in this small sample received a false detector signal. The examples show the pattern. A historical safe ad was blocked, one explosives image was classified as safe, and a financial example received a false box even though its policy route remained review. These images have different languages, layouts, ages, and photographic context from our training sources. The sample is small and selected, so this is not a population estimate. It is still enough to show that the formal score does not generalize reliably. Bickramjit will show what the app already does well.</a:t>
             </a:r>
           </a:p>
           <a:p xmlns:a="http://schemas.openxmlformats.org/drawingml/2006/main">
@@ -901,7 +981,27 @@
           </a:p>
           <a:p xmlns:a="http://schemas.openxmlformats.org/drawingml/2006/main">
             <a:r>
+              <a:t>Target time: 50 seconds</a:t>
+            </a:r>
+          </a:p>
+          <a:p xmlns:a="http://schemas.openxmlformats.org/drawingml/2006/main">
+            <a:r>
               <a:t>Key message: The browser-validated workspace keeps the decision, evidence, timing, and exact audit record together while preserving human control over review cases.</a:t>
+            </a:r>
+          </a:p>
+          <a:p xmlns:a="http://schemas.openxmlformats.org/drawingml/2006/main">
+            <a:r>
+              <a:t/>
+            </a:r>
+          </a:p>
+          <a:p xmlns:a="http://schemas.openxmlformats.org/drawingml/2006/main">
+            <a:r>
+              <a:t>[Speaker script]</a:t>
+            </a:r>
+          </a:p>
+          <a:p xmlns:a="http://schemas.openxmlformats.org/drawingml/2006/main">
+            <a:r>
+              <a:t>The working app keeps one case in one place. A reviewer uploads an image, turns optional evidence on or off, reviews the decision and the raw versus fused scores, and exports an audit record with hashes, model versions, options, and thresholds. This screenshot is a browser-validated firearm case that returned BLOCK. The 2,448-millisecond total shown here is one app run with optional stages. It is not the same measurement as the classifier-only p95 on slide 10. The session charts summarize cases from the current session only. They are not production monitoring or population evidence. Myetchae will connect those limits to the controls we still need.</a:t>
             </a:r>
           </a:p>
           <a:p xmlns:a="http://schemas.openxmlformats.org/drawingml/2006/main">
@@ -1011,7 +1111,27 @@
           </a:p>
           <a:p xmlns:a="http://schemas.openxmlformats.org/drawingml/2006/main">
             <a:r>
-              <a:t>Key message: The main risks are source confounding, an uncalibrated detector, and classifier-only latency evidence. Full end-to-end p95, concurrent throughput, and MPS CPU/GPU/RAM use were not measured; each needs an explicit control before a trial.</a:t>
+              <a:t>Target time: 50 seconds</a:t>
+            </a:r>
+          </a:p>
+          <a:p xmlns:a="http://schemas.openxmlformats.org/drawingml/2006/main">
+            <a:r>
+              <a:t>Key message: The main risks are source confounding, an uncalibrated detector, and classifier-only latency evidence. Full end-to-end p95, concurrent throughput, CPU and GPU load, MPS acceleration, and memory use were not measured; each needs an explicit control before a trial.</a:t>
+            </a:r>
+          </a:p>
+          <a:p xmlns:a="http://schemas.openxmlformats.org/drawingml/2006/main">
+            <a:r>
+              <a:t/>
+            </a:r>
+          </a:p>
+          <a:p xmlns:a="http://schemas.openxmlformats.org/drawingml/2006/main">
+            <a:r>
+              <a:t>[Speaker script]</a:t>
+            </a:r>
+          </a:p>
+          <a:p xmlns:a="http://schemas.openxmlformats.org/drawingml/2006/main">
+            <a:r>
+              <a:t>Before a real pilot, we need controls in three areas. For data, we need diverse real campaigns and independent annotation, not source-linked synthetic shortcuts. For the detector, we need local box labels and recalibration, and we should not let the detector block by itself. For operations, we still need full end-to-end p95, concurrent throughput, and CPU, Apple GPU, and memory measurements. Today's controls reduce the chance of harm, but they do not remove the uncertainty. Our decision is no-go for autonomous use and go only for further human-reviewed validation. Swarnaditya will close with that path.</a:t>
             </a:r>
           </a:p>
           <a:p xmlns:a="http://schemas.openxmlformats.org/drawingml/2006/main">
@@ -1116,7 +1236,27 @@
           </a:p>
           <a:p xmlns:a="http://schemas.openxmlformats.org/drawingml/2006/main">
             <a:r>
+              <a:t>Target time: 55 seconds</a:t>
+            </a:r>
+          </a:p>
+          <a:p xmlns:a="http://schemas.openxmlformats.org/drawingml/2006/main">
+            <a:r>
               <a:t>Key message: This is a recommended 10-week plan and staffing assumption, not a measured commitment. A human-gated pilot starts only after evidence, quality, and explicit capacity gates pass.</a:t>
+            </a:r>
+          </a:p>
+          <a:p xmlns:a="http://schemas.openxmlformats.org/drawingml/2006/main">
+            <a:r>
+              <a:t/>
+            </a:r>
+          </a:p>
+          <a:p xmlns:a="http://schemas.openxmlformats.org/drawingml/2006/main">
+            <a:r>
+              <a:t>[Speaker script]</a:t>
+            </a:r>
+          </a:p>
+          <a:p xmlns:a="http://schemas.openxmlformats.org/drawingml/2006/main">
+            <a:r>
+              <a:t>The 10-week roadmap is our planning recommendation, not a measured delivery promise. In weeks one through three, we would collect at least 1,000 real ads and lock an independent campaign-grouped holdout. In weeks four through six, we would recalibrate and require greater than 0.95 recall for every restricted class, with fewer than 2 percent safe crossings. In weeks seven through ten, we would run a shadow, human-reviewed pilot and test 10 concurrent requests with full end-to-end latency and resource tracking. If any gate fails, we stop and fix it before scaling. The project is complete as a reproducible demo, but the evidence tells us that the responsible next step is stronger validation, not autonomous enforcement. Thank you. We are ready for questions.</a:t>
             </a:r>
           </a:p>
           <a:p xmlns:a="http://schemas.openxmlformats.org/drawingml/2006/main">
@@ -1221,7 +1361,27 @@
           </a:p>
           <a:p xmlns:a="http://schemas.openxmlformats.org/drawingml/2006/main">
             <a:r>
-              <a:t>Key message: Every team member owns a visible presentation section; the sequence follows one evidence chain from problem to MVP gate.</a:t>
+              <a:t>Target time: 25 seconds</a:t>
+            </a:r>
+          </a:p>
+          <a:p xmlns:a="http://schemas.openxmlformats.org/drawingml/2006/main">
+            <a:r>
+              <a:t>Key message: All four team members present named sections, moving from the problem and data to results, limits, and next steps.</a:t>
+            </a:r>
+          </a:p>
+          <a:p xmlns:a="http://schemas.openxmlformats.org/drawingml/2006/main">
+            <a:r>
+              <a:t/>
+            </a:r>
+          </a:p>
+          <a:p xmlns:a="http://schemas.openxmlformats.org/drawingml/2006/main">
+            <a:r>
+              <a:t>[Speaker script]</a:t>
+            </a:r>
+          </a:p>
+          <a:p xmlns:a="http://schemas.openxmlformats.org/drawingml/2006/main">
+            <a:r>
+              <a:t>We divided the presentation by responsibility, while keeping one shared story. I am Vijay, covering the data and error analysis. Swarnaditya covers the problem, formal results, and recommendation. Myetchae covers policy, architecture, the external check, and risk. Bickramjit covers method, prior research, and the working app. Swarnaditya will now frame the review problem.</a:t>
             </a:r>
           </a:p>
           <a:p xmlns:a="http://schemas.openxmlformats.org/drawingml/2006/main">
@@ -1316,7 +1476,27 @@
           </a:p>
           <a:p xmlns:a="http://schemas.openxmlformats.org/drawingml/2006/main">
             <a:r>
+              <a:t>Target time: 40 seconds</a:t>
+            </a:r>
+          </a:p>
+          <a:p xmlns:a="http://schemas.openxmlformats.org/drawingml/2006/main">
+            <a:r>
               <a:t>Key message: The product goal is triage consistency, not a claim that one image can establish legality or fraud.</a:t>
+            </a:r>
+          </a:p>
+          <a:p xmlns:a="http://schemas.openxmlformats.org/drawingml/2006/main">
+            <a:r>
+              <a:t/>
+            </a:r>
+          </a:p>
+          <a:p xmlns:a="http://schemas.openxmlformats.org/drawingml/2006/main">
+            <a:r>
+              <a:t>[Speaker script]</a:t>
+            </a:r>
+          </a:p>
+          <a:p xmlns:a="http://schemas.openxmlformats.org/drawingml/2006/main">
+            <a:r>
+              <a:t>Ad review is difficult because one creative can mix several kinds of evidence. A weapon may be obvious, important text may be small, and context can change what an image means. Our goal was not to replace a policy reviewer. We wanted to help a queue move faster, apply the same first-pass process to every image, and send uncertain cases to a person. Myetchae will now set the boundary around what the prototype can actually decide.</a:t>
             </a:r>
           </a:p>
           <a:p xmlns:a="http://schemas.openxmlformats.org/drawingml/2006/main">
@@ -1416,7 +1596,27 @@
           </a:p>
           <a:p xmlns:a="http://schemas.openxmlformats.org/drawingml/2006/main">
             <a:r>
+              <a:t>Target time: 45 seconds</a:t>
+            </a:r>
+          </a:p>
+          <a:p xmlns:a="http://schemas.openxmlformats.org/drawingml/2006/main">
+            <a:r>
               <a:t>Key message: The current prototype covers four visual labels and three workflow outcomes; it does not cover the full ad policy surface.</a:t>
+            </a:r>
+          </a:p>
+          <a:p xmlns:a="http://schemas.openxmlformats.org/drawingml/2006/main">
+            <a:r>
+              <a:t/>
+            </a:r>
+          </a:p>
+          <a:p xmlns:a="http://schemas.openxmlformats.org/drawingml/2006/main">
+            <a:r>
+              <a:t>[Speaker script]</a:t>
+            </a:r>
+          </a:p>
+          <a:p xmlns:a="http://schemas.openxmlformats.org/drawingml/2006/main">
+            <a:r>
+              <a:t>We deliberately kept the scope narrow: safe, firearms, explosives, and visible financial-promotion cues. The financial label does not mean fraud or illegality. It means the image appears promotional, so our rules always send it to review. For the other labels, a readable policy file maps evidence to approve, review, or block. We do not cover landing pages, advertiser identity, geography, age rules, alcohol, tobacco, or the rest of the ad-policy surface. This is a triage prototype, not a complete policy engine. Vijay will show the data behind it.</a:t>
             </a:r>
           </a:p>
           <a:p xmlns:a="http://schemas.openxmlformats.org/drawingml/2006/main">
@@ -1521,7 +1721,27 @@
           </a:p>
           <a:p xmlns:a="http://schemas.openxmlformats.org/drawingml/2006/main">
             <a:r>
+              <a:t>Target time: 45 seconds</a:t>
+            </a:r>
+          </a:p>
+          <a:p xmlns:a="http://schemas.openxmlformats.org/drawingml/2006/main">
+            <a:r>
               <a:t>Key message: The split is leakage-aware, but the label-to-source mapping still creates a shortcut risk.</a:t>
+            </a:r>
+          </a:p>
+          <a:p xmlns:a="http://schemas.openxmlformats.org/drawingml/2006/main">
+            <a:r>
+              <a:t/>
+            </a:r>
+          </a:p>
+          <a:p xmlns:a="http://schemas.openxmlformats.org/drawingml/2006/main">
+            <a:r>
+              <a:t>[Speaker script]</a:t>
+            </a:r>
+          </a:p>
+          <a:p xmlns:a="http://schemas.openxmlformats.org/drawingml/2006/main">
+            <a:r>
+              <a:t>The pilot contains 288 JPEG images. Every class has 48 training images, 12 validation images, and 12 final test images. We also kept each of the 215 source groups inside one split and checked that file hashes do not overlap. That reduces leakage, meaning the same campaign or exact image cannot appear on both sides of the evaluation. The weakness is source diversity. Safe and financial images are synthetic, while both weapon classes come from one weapons dataset. The counts are balanced, but the visual sources are not. The next slide makes that problem visible.</a:t>
             </a:r>
           </a:p>
           <a:p xmlns:a="http://schemas.openxmlformats.org/drawingml/2006/main">
@@ -1626,7 +1846,27 @@
           </a:p>
           <a:p xmlns:a="http://schemas.openxmlformats.org/drawingml/2006/main">
             <a:r>
+              <a:t>Target time: 40 seconds</a:t>
+            </a:r>
+          </a:p>
+          <a:p xmlns:a="http://schemas.openxmlformats.org/drawingml/2006/main">
+            <a:r>
               <a:t>Key message: The contact sheet makes the confounding visible: source style and class are tightly linked despite group-safe splitting.</a:t>
+            </a:r>
+          </a:p>
+          <a:p xmlns:a="http://schemas.openxmlformats.org/drawingml/2006/main">
+            <a:r>
+              <a:t/>
+            </a:r>
+          </a:p>
+          <a:p xmlns:a="http://schemas.openxmlformats.org/drawingml/2006/main">
+            <a:r>
+              <a:t>[Speaker script]</a:t>
+            </a:r>
+          </a:p>
+          <a:p xmlns:a="http://schemas.openxmlformats.org/drawingml/2006/main">
+            <a:r>
+              <a:t>The contact sheet shows the shortcut risk more clearly than a metric can. Safe images look like generated product scenes. Weapon images are often isolated objects. Financial images repeat synthetic layouts. Even with a clean group split, a classifier can learn the look of the source instead of the policy concept itself. That does not make the formal result useless, but it limits the claim to this pilot domain. Myetchae will now show how the system keeps different kinds of evidence separate.</a:t>
             </a:r>
           </a:p>
           <a:p xmlns:a="http://schemas.openxmlformats.org/drawingml/2006/main">
@@ -1726,7 +1966,27 @@
           </a:p>
           <a:p xmlns:a="http://schemas.openxmlformats.org/drawingml/2006/main">
             <a:r>
-              <a:t>Key message: The architecture avoids collapsing evidence into one opaque score; the policy layer can explain which signal changed a verdict.</a:t>
+              <a:t>Target time: 50 seconds</a:t>
+            </a:r>
+          </a:p>
+          <a:p xmlns:a="http://schemas.openxmlformats.org/drawingml/2006/main">
+            <a:r>
+              <a:t>Key message: The local stack keeps model, detector, OCR, policy, and audit evidence separate so a reviewer can inspect each contribution.</a:t>
+            </a:r>
+          </a:p>
+          <a:p xmlns:a="http://schemas.openxmlformats.org/drawingml/2006/main">
+            <a:r>
+              <a:t/>
+            </a:r>
+          </a:p>
+          <a:p xmlns:a="http://schemas.openxmlformats.org/drawingml/2006/main">
+            <a:r>
+              <a:t>[Speaker script]</a:t>
+            </a:r>
+          </a:p>
+          <a:p xmlns:a="http://schemas.openxmlformats.org/drawingml/2006/main">
+            <a:r>
+              <a:t>The system runs locally and has three parts. PyTorch and timm run a frozen vision transformer, while Grounding DINO and Tesseract add optional object and text evidence. FastAPI coordinates those services, and Streamlit gives the reviewer one workspace for the image, scores, boxes, text, and timing. A versioned YAML policy then returns approve, review, or block with reason codes and a JSON audit record. Keeping the signals separate lets a reviewer inspect what each component contributed. It does not prove causation, but it is clearer than one unexplained score. Bickramjit will explain how we trained and tested the models.</a:t>
             </a:r>
           </a:p>
           <a:p xmlns:a="http://schemas.openxmlformats.org/drawingml/2006/main">
@@ -1836,7 +2096,27 @@
           </a:p>
           <a:p xmlns:a="http://schemas.openxmlformats.org/drawingml/2006/main">
             <a:r>
+              <a:t>Target time: 50 seconds</a:t>
+            </a:r>
+          </a:p>
+          <a:p xmlns:a="http://schemas.openxmlformats.org/drawingml/2006/main">
+            <a:r>
               <a:t>Key message: Model selection and threshold calibration use validation data only; the final 48-image test remains untouched until evaluation.</a:t>
+            </a:r>
+          </a:p>
+          <a:p xmlns:a="http://schemas.openxmlformats.org/drawingml/2006/main">
+            <a:r>
+              <a:t/>
+            </a:r>
+          </a:p>
+          <a:p xmlns:a="http://schemas.openxmlformats.org/drawingml/2006/main">
+            <a:r>
+              <a:t>[Speaker script]</a:t>
+            </a:r>
+          </a:p>
+          <a:p xmlns:a="http://schemas.openxmlformats.org/drawingml/2006/main">
+            <a:r>
+              <a:t>Because the dataset is small, we froze the ViT and ResNet-50 backbones instead of fine-tuning millions of weights. We then trained small logistic classifiers on training embeddings. We chose class thresholds only with the validation split. The 48-image test split was not used to train, choose a model, or tune a threshold, and we ran the final evaluation after those choices were locked. The chart shows the validation-only explosives threshold, about 0.173, with recall and precision both at 1.0 on that small validation sample. I will stay on for one slide to explain how prior research shaped the design.</a:t>
             </a:r>
           </a:p>
           <a:p xmlns:a="http://schemas.openxmlformats.org/drawingml/2006/main">
@@ -1951,7 +2231,27 @@
           </a:p>
           <a:p xmlns:a="http://schemas.openxmlformats.org/drawingml/2006/main">
             <a:r>
+              <a:t>Target time: 40 seconds</a:t>
+            </a:r>
+          </a:p>
+          <a:p xmlns:a="http://schemas.openxmlformats.org/drawingml/2006/main">
+            <a:r>
               <a:t>Key message: The literature justifies the selected mechanisms, but it does not transfer benchmark performance to our dataset or policy task.</a:t>
+            </a:r>
+          </a:p>
+          <a:p xmlns:a="http://schemas.openxmlformats.org/drawingml/2006/main">
+            <a:r>
+              <a:t/>
+            </a:r>
+          </a:p>
+          <a:p xmlns:a="http://schemas.openxmlformats.org/drawingml/2006/main">
+            <a:r>
+              <a:t>[Speaker script]</a:t>
+            </a:r>
+          </a:p>
+          <a:p xmlns:a="http://schemas.openxmlformats.org/drawingml/2006/main">
+            <a:r>
+              <a:t>Prior work helped us choose credible building blocks. The Vision Transformer paper supports transferable whole-image features. Grounding DINO supports text-guided object localization, and Tesseract provides visible-text extraction. We did not find an outside benchmark that was directly comparable to our four-label policy task, so the proposal targets are the benchmarks we report against. The papers explain why the components are reasonable choices. Only our saved evaluation supports the numbers in this presentation. Swarnaditya will now take us through those results.</a:t>
             </a:r>
           </a:p>
           <a:p xmlns:a="http://schemas.openxmlformats.org/drawingml/2006/main">
@@ -2054,7 +2354,7 @@
   </p:cSld>
   <p:clrMap bg1="lt1" tx1="dk1" bg2="lt2" tx2="dk2" accent1="accent1" accent2="accent2" accent3="accent3" accent4="accent4" accent5="accent5" accent6="accent6" hlink="hlink" folHlink="folHlink"/>
   <p:sldLayoutIdLst>
-    <p:sldLayoutId xmlns:r="http://schemas.openxmlformats.org/officeDocument/2006/relationships" id="2147483649" r:id="R4fac53775f0c4436"/>
+    <p:sldLayoutId xmlns:r="http://schemas.openxmlformats.org/officeDocument/2006/relationships" id="2147483649" r:id="R922a4b4503914669"/>
   </p:sldLayoutIdLst>
   <p:txStyles>
     <p:titleStyle>
@@ -2337,9 +2637,9 @@
 </file>
 
 <file path=ppt/slideMasters/theme/theme2.xml><?xml version="1.0" encoding="utf-8"?>
-<a:theme xmlns:a="http://schemas.openxmlformats.org/drawingml/2006/main" name="ChatGPT">
+<a:theme xmlns:a="http://schemas.openxmlformats.org/drawingml/2006/main" name="Ad Safety Project">
   <a:themeElements>
-    <a:clrScheme name="ChatGPT">
+    <a:clrScheme name="Ad Safety Project">
       <a:dk1>
         <a:srgbClr val="000000"/>
       </a:dk1>
@@ -2389,7 +2689,7 @@
         <a:cs typeface="Calibri"/>
       </a:minorFont>
     </a:fontScheme>
-    <a:fmtScheme name="ChatGPT">
+    <a:fmtScheme name="Ad Safety Project">
       <a:fillStyleLst>
         <a:solidFill>
           <a:schemeClr val="phClr"/>
@@ -3376,7 +3676,7 @@
           <p:cNvPr id="20" name="Google-Shape-532-p58-2">
             <a:extLst xmlns:a="http://schemas.openxmlformats.org/drawingml/2006/main">
               <a:ext uri="{FF2B5EF4-FFF2-40B4-BE49-F238E27FC236}">
-                <a16:creationId xmlns:a16="http://schemas.microsoft.com/office/drawing/2014/main" id="{9AB7EEF6-62CD-498E-85C8-6221E11CDA5A}"/>
+                <a16:creationId xmlns:a16="http://schemas.microsoft.com/office/drawing/2014/main" id="{0A95DE35-8D1A-4D7F-8164-85638184EAC9}"/>
               </a:ext>
             </a:extLst>
           </p:cNvPr>
@@ -3421,7 +3721,7 @@
           <p:cNvPr id="2" name="Google-Shape-533-p58-3">
             <a:extLst xmlns:a="http://schemas.openxmlformats.org/drawingml/2006/main">
               <a:ext uri="{FF2B5EF4-FFF2-40B4-BE49-F238E27FC236}">
-                <a16:creationId xmlns:a16="http://schemas.microsoft.com/office/drawing/2014/main" id="{1608AA33-BB10-4DCD-B389-D4C1827EB39A}"/>
+                <a16:creationId xmlns:a16="http://schemas.microsoft.com/office/drawing/2014/main" id="{198619D2-D20A-4BB8-A85B-69B295C23F4A}"/>
               </a:ext>
             </a:extLst>
           </p:cNvPr>
@@ -3468,7 +3768,7 @@
                 <a:ea typeface="Arial"/>
                 <a:cs typeface="Arial"/>
               </a:rPr>
-              <a:t>MS_DSP_462 · MANAGEMENT REVIEW</a:t>
+              <a:t>MS_DSP_462 · REVIEW QUEUE DECISION SUPPORT</a:t>
             </a:r>
           </a:p>
         </p:txBody>
@@ -3478,7 +3778,7 @@
           <p:cNvPr id="3" name="Picture-3-4-backing">
             <a:extLst xmlns:a="http://schemas.openxmlformats.org/drawingml/2006/main">
               <a:ext uri="{FF2B5EF4-FFF2-40B4-BE49-F238E27FC236}">
-                <a16:creationId xmlns:a16="http://schemas.microsoft.com/office/drawing/2014/main" id="{23203D0B-9960-4275-A26E-8D25B73C664D}"/>
+                <a16:creationId xmlns:a16="http://schemas.microsoft.com/office/drawing/2014/main" id="{E1AEBF40-B241-4D17-9652-FBB013EC1041}"/>
               </a:ext>
             </a:extLst>
           </p:cNvPr>
@@ -3517,7 +3817,7 @@
           <p:nvPr/>
         </p:nvPicPr>
         <p:blipFill>
-          <a:blip xmlns:r="http://schemas.openxmlformats.org/officeDocument/2006/relationships" xmlns:a="http://schemas.openxmlformats.org/drawingml/2006/main" r:embed="R7ec0ae52b4da4e05"/>
+          <a:blip xmlns:r="http://schemas.openxmlformats.org/officeDocument/2006/relationships" xmlns:a="http://schemas.openxmlformats.org/drawingml/2006/main" r:embed="Rf4b5061aa20f41cd"/>
           <a:srcRect xmlns:a="http://schemas.openxmlformats.org/drawingml/2006/main" l="0" t="0" r="0" b="0"/>
           <a:stretch xmlns:a="http://schemas.openxmlformats.org/drawingml/2006/main">
             <a:fillRect l="0" t="0" r="0" b="0"/>
@@ -3538,7 +3838,7 @@
           <p:cNvPr id="5" name="Google-Shape-534-p58-5">
             <a:extLst xmlns:a="http://schemas.openxmlformats.org/drawingml/2006/main">
               <a:ext uri="{FF2B5EF4-FFF2-40B4-BE49-F238E27FC236}">
-                <a16:creationId xmlns:a16="http://schemas.microsoft.com/office/drawing/2014/main" id="{C8D6E68E-BBBE-4755-99BB-FE2A08BABD42}"/>
+                <a16:creationId xmlns:a16="http://schemas.microsoft.com/office/drawing/2014/main" id="{3CD64203-8C49-49AF-B445-1A88D940B14C}"/>
               </a:ext>
             </a:extLst>
           </p:cNvPr>
@@ -3622,7 +3922,7 @@
           <p:cNvPr id="6" name="">
             <a:extLst xmlns:a="http://schemas.openxmlformats.org/drawingml/2006/main">
               <a:ext uri="{FF2B5EF4-FFF2-40B4-BE49-F238E27FC236}">
-                <a16:creationId xmlns:a16="http://schemas.microsoft.com/office/drawing/2014/main" id="{BCA88A02-894F-4AAC-B789-81A890802835}"/>
+                <a16:creationId xmlns:a16="http://schemas.microsoft.com/office/drawing/2014/main" id="{7FA93B07-58FA-4C81-A0F3-E9BB1008D9E0}"/>
               </a:ext>
             </a:extLst>
           </p:cNvPr>
@@ -3634,7 +3934,7 @@
         <p:spPr>
           <a:xfrm xmlns:a="http://schemas.openxmlformats.org/drawingml/2006/main">
             <a:off x="393668" y="1066800"/>
-            <a:ext cx="5381625" cy="2171700"/>
+            <a:ext cx="5381625" cy="2095500"/>
           </a:xfrm>
           <a:prstGeom xmlns:a="http://schemas.openxmlformats.org/drawingml/2006/main" prst="rect">
             <a:avLst/>
@@ -3650,71 +3950,48 @@
           <a:lstStyle xmlns:a="http://schemas.openxmlformats.org/drawingml/2006/main"/>
           <a:p xmlns:a="http://schemas.openxmlformats.org/drawingml/2006/main">
             <a:pPr algn="l">
-              <a:defRPr sz="5100" b="0">
-                <a:solidFill>
-                  <a:srgbClr val="000000"/>
-                </a:solidFill>
-                <a:latin typeface="Arial"/>
-                <a:ea typeface="Arial"/>
-                <a:cs typeface="Arial"/>
-              </a:defRPr>
-            </a:pPr>
-            <a:r>
-              <a:rPr sz="5100" b="0">
-                <a:solidFill>
-                  <a:srgbClr val="000000"/>
-                </a:solidFill>
-                <a:latin typeface="Arial"/>
-                <a:ea typeface="Arial"/>
-                <a:cs typeface="Arial"/>
-              </a:rPr>
-              <a:t>Ad safety</a:t>
+              <a:defRPr sz="4050" b="0">
+                <a:solidFill>
+                  <a:srgbClr val="000000"/>
+                </a:solidFill>
+                <a:latin typeface="Arial"/>
+                <a:ea typeface="Arial"/>
+                <a:cs typeface="Arial"/>
+              </a:defRPr>
+            </a:pPr>
+            <a:r>
+              <a:rPr sz="4050" b="0">
+                <a:solidFill>
+                  <a:srgbClr val="000000"/>
+                </a:solidFill>
+                <a:latin typeface="Arial"/>
+                <a:ea typeface="Arial"/>
+                <a:cs typeface="Arial"/>
+              </a:rPr>
+              <a:t>Ad Safety Moderation</a:t>
             </a:r>
           </a:p>
           <a:p xmlns:a="http://schemas.openxmlformats.org/drawingml/2006/main">
             <a:pPr algn="l">
-              <a:defRPr sz="5100" b="0">
-                <a:solidFill>
-                  <a:srgbClr val="000000"/>
-                </a:solidFill>
-                <a:latin typeface="Arial"/>
-                <a:ea typeface="Arial"/>
-                <a:cs typeface="Arial"/>
-              </a:defRPr>
-            </a:pPr>
-            <a:r>
-              <a:rPr sz="5100" b="0">
-                <a:solidFill>
-                  <a:srgbClr val="000000"/>
-                </a:solidFill>
-                <a:latin typeface="Arial"/>
-                <a:ea typeface="Arial"/>
-                <a:cs typeface="Arial"/>
-              </a:rPr>
-              <a:t>at a decision</a:t>
-            </a:r>
-          </a:p>
-          <a:p xmlns:a="http://schemas.openxmlformats.org/drawingml/2006/main">
-            <a:pPr algn="l">
-              <a:defRPr sz="5100" b="0">
-                <a:solidFill>
-                  <a:srgbClr val="000000"/>
-                </a:solidFill>
-                <a:latin typeface="Arial"/>
-                <a:ea typeface="Arial"/>
-                <a:cs typeface="Arial"/>
-              </a:defRPr>
-            </a:pPr>
-            <a:r>
-              <a:rPr sz="5100" b="0">
-                <a:solidFill>
-                  <a:srgbClr val="000000"/>
-                </a:solidFill>
-                <a:latin typeface="Arial"/>
-                <a:ea typeface="Arial"/>
-                <a:cs typeface="Arial"/>
-              </a:rPr>
-              <a:t>point</a:t>
+              <a:defRPr sz="4050" b="0">
+                <a:solidFill>
+                  <a:srgbClr val="000000"/>
+                </a:solidFill>
+                <a:latin typeface="Arial"/>
+                <a:ea typeface="Arial"/>
+                <a:cs typeface="Arial"/>
+              </a:defRPr>
+            </a:pPr>
+            <a:r>
+              <a:rPr sz="4050" b="0">
+                <a:solidFill>
+                  <a:srgbClr val="000000"/>
+                </a:solidFill>
+                <a:latin typeface="Arial"/>
+                <a:ea typeface="Arial"/>
+                <a:cs typeface="Arial"/>
+              </a:rPr>
+              <a:t>Pilot results and next steps</a:t>
             </a:r>
           </a:p>
         </p:txBody>
@@ -3724,19 +4001,19 @@
           <p:cNvPr id="7" name="">
             <a:extLst xmlns:a="http://schemas.openxmlformats.org/drawingml/2006/main">
               <a:ext uri="{FF2B5EF4-FFF2-40B4-BE49-F238E27FC236}">
-                <a16:creationId xmlns:a16="http://schemas.microsoft.com/office/drawing/2014/main" id="{9FD93F5A-0BF8-445C-8713-029652A1CF28}"/>
-              </a:ext>
-            </a:extLst>
-          </p:cNvPr>
-          <p:cNvSpPr>
-            <a:spLocks xmlns:a="http://schemas.openxmlformats.org/drawingml/2006/main" noGrp="1"/>
-          </p:cNvSpPr>
-          <p:nvPr/>
-        </p:nvSpPr>
-        <p:spPr>
-          <a:xfrm xmlns:a="http://schemas.openxmlformats.org/drawingml/2006/main">
-            <a:off x="393668" y="3476625"/>
-            <a:ext cx="5381625" cy="781050"/>
+                <a16:creationId xmlns:a16="http://schemas.microsoft.com/office/drawing/2014/main" id="{BB1A3AD1-DB7F-423E-9E57-5CC2E8F852A2}"/>
+              </a:ext>
+            </a:extLst>
+          </p:cNvPr>
+          <p:cNvSpPr>
+            <a:spLocks xmlns:a="http://schemas.openxmlformats.org/drawingml/2006/main" noGrp="1"/>
+          </p:cNvSpPr>
+          <p:nvPr/>
+        </p:nvSpPr>
+        <p:spPr>
+          <a:xfrm xmlns:a="http://schemas.openxmlformats.org/drawingml/2006/main">
+            <a:off x="393668" y="3333750"/>
+            <a:ext cx="5381625" cy="723900"/>
           </a:xfrm>
           <a:prstGeom xmlns:a="http://schemas.openxmlformats.org/drawingml/2006/main" prst="rect">
             <a:avLst/>
@@ -3752,48 +4029,48 @@
           <a:lstStyle xmlns:a="http://schemas.openxmlformats.org/drawingml/2006/main"/>
           <a:p xmlns:a="http://schemas.openxmlformats.org/drawingml/2006/main">
             <a:pPr algn="l">
-              <a:defRPr sz="2100" b="1">
-                <a:solidFill>
-                  <a:srgbClr val="000000"/>
-                </a:solidFill>
-                <a:latin typeface="Arial"/>
-                <a:ea typeface="Arial"/>
-                <a:cs typeface="Arial"/>
-              </a:defRPr>
-            </a:pPr>
-            <a:r>
-              <a:rPr sz="2100" b="1">
-                <a:solidFill>
-                  <a:srgbClr val="000000"/>
-                </a:solidFill>
-                <a:latin typeface="Arial"/>
-                <a:ea typeface="Arial"/>
-                <a:cs typeface="Arial"/>
-              </a:rPr>
-              <a:t>0.979 formal macro F1</a:t>
+              <a:defRPr sz="1725" b="1">
+                <a:solidFill>
+                  <a:srgbClr val="000000"/>
+                </a:solidFill>
+                <a:latin typeface="Arial"/>
+                <a:ea typeface="Arial"/>
+                <a:cs typeface="Arial"/>
+              </a:defRPr>
+            </a:pPr>
+            <a:r>
+              <a:rPr sz="1725" b="1">
+                <a:solidFill>
+                  <a:srgbClr val="000000"/>
+                </a:solidFill>
+                <a:latin typeface="Arial"/>
+                <a:ea typeface="Arial"/>
+                <a:cs typeface="Arial"/>
+              </a:rPr>
+              <a:t>0.979 macro F1 on our 48-image test</a:t>
             </a:r>
           </a:p>
           <a:p xmlns:a="http://schemas.openxmlformats.org/drawingml/2006/main">
             <a:pPr algn="l">
-              <a:defRPr sz="2100" b="1">
-                <a:solidFill>
-                  <a:srgbClr val="000000"/>
-                </a:solidFill>
-                <a:latin typeface="Arial"/>
-                <a:ea typeface="Arial"/>
-                <a:cs typeface="Arial"/>
-              </a:defRPr>
-            </a:pPr>
-            <a:r>
-              <a:rPr sz="2100" b="1">
-                <a:solidFill>
-                  <a:srgbClr val="000000"/>
-                </a:solidFill>
-                <a:latin typeface="Arial"/>
-                <a:ea typeface="Arial"/>
-                <a:cs typeface="Arial"/>
-              </a:rPr>
-              <a:t>0.555 external macro F1</a:t>
+              <a:defRPr sz="1725" b="1">
+                <a:solidFill>
+                  <a:srgbClr val="000000"/>
+                </a:solidFill>
+                <a:latin typeface="Arial"/>
+                <a:ea typeface="Arial"/>
+                <a:cs typeface="Arial"/>
+              </a:defRPr>
+            </a:pPr>
+            <a:r>
+              <a:rPr sz="1725" b="1">
+                <a:solidFill>
+                  <a:srgbClr val="000000"/>
+                </a:solidFill>
+                <a:latin typeface="Arial"/>
+                <a:ea typeface="Arial"/>
+                <a:cs typeface="Arial"/>
+              </a:rPr>
+              <a:t>0.555 macro F1 on the external check</a:t>
             </a:r>
           </a:p>
         </p:txBody>
@@ -3803,7 +4080,7 @@
           <p:cNvPr id="8" name="">
             <a:extLst xmlns:a="http://schemas.openxmlformats.org/drawingml/2006/main">
               <a:ext uri="{FF2B5EF4-FFF2-40B4-BE49-F238E27FC236}">
-                <a16:creationId xmlns:a16="http://schemas.microsoft.com/office/drawing/2014/main" id="{B9D845C3-717D-41D0-A3BA-C06BD110B6FA}"/>
+                <a16:creationId xmlns:a16="http://schemas.microsoft.com/office/drawing/2014/main" id="{89A04D98-8B08-48F5-8FCA-9F0FEF8B8682}"/>
               </a:ext>
             </a:extLst>
           </p:cNvPr>
@@ -3836,19 +4113,19 @@
           <p:cNvPr id="9" name="">
             <a:extLst xmlns:a="http://schemas.openxmlformats.org/drawingml/2006/main">
               <a:ext uri="{FF2B5EF4-FFF2-40B4-BE49-F238E27FC236}">
-                <a16:creationId xmlns:a16="http://schemas.microsoft.com/office/drawing/2014/main" id="{50D05039-A75B-45A4-AD3D-FEE6E792502C}"/>
-              </a:ext>
-            </a:extLst>
-          </p:cNvPr>
-          <p:cNvSpPr>
-            <a:spLocks xmlns:a="http://schemas.openxmlformats.org/drawingml/2006/main" noGrp="1"/>
-          </p:cNvSpPr>
-          <p:nvPr/>
-        </p:nvSpPr>
-        <p:spPr>
-          <a:xfrm xmlns:a="http://schemas.openxmlformats.org/drawingml/2006/main">
-            <a:off x="581025" y="4772025"/>
-            <a:ext cx="5000625" cy="733425"/>
+                <a16:creationId xmlns:a16="http://schemas.microsoft.com/office/drawing/2014/main" id="{B2719DEA-DAA8-4431-BF0D-FB89EA6E4E89}"/>
+              </a:ext>
+            </a:extLst>
+          </p:cNvPr>
+          <p:cNvSpPr>
+            <a:spLocks xmlns:a="http://schemas.openxmlformats.org/drawingml/2006/main" noGrp="1"/>
+          </p:cNvSpPr>
+          <p:nvPr/>
+        </p:nvSpPr>
+        <p:spPr>
+          <a:xfrm xmlns:a="http://schemas.openxmlformats.org/drawingml/2006/main">
+            <a:off x="581025" y="4733925"/>
+            <a:ext cx="5000625" cy="790575"/>
           </a:xfrm>
           <a:prstGeom xmlns:a="http://schemas.openxmlformats.org/drawingml/2006/main" prst="rect">
             <a:avLst/>
@@ -3864,48 +4141,48 @@
           <a:lstStyle xmlns:a="http://schemas.openxmlformats.org/drawingml/2006/main"/>
           <a:p xmlns:a="http://schemas.openxmlformats.org/drawingml/2006/main">
             <a:pPr algn="l">
-              <a:defRPr sz="1600" b="1">
-                <a:solidFill>
-                  <a:srgbClr val="000000"/>
-                </a:solidFill>
-                <a:latin typeface="Arial"/>
-                <a:ea typeface="Arial"/>
-                <a:cs typeface="Arial"/>
-              </a:defRPr>
-            </a:pPr>
-            <a:r>
-              <a:rPr sz="1600" b="1">
-                <a:solidFill>
-                  <a:srgbClr val="000000"/>
-                </a:solidFill>
-                <a:latin typeface="Arial"/>
-                <a:ea typeface="Arial"/>
-                <a:cs typeface="Arial"/>
-              </a:rPr>
-              <a:t>Decision</a:t>
+              <a:defRPr sz="1500" b="1">
+                <a:solidFill>
+                  <a:srgbClr val="000000"/>
+                </a:solidFill>
+                <a:latin typeface="Arial"/>
+                <a:ea typeface="Arial"/>
+                <a:cs typeface="Arial"/>
+              </a:defRPr>
+            </a:pPr>
+            <a:r>
+              <a:rPr sz="1500" b="1">
+                <a:solidFill>
+                  <a:srgbClr val="000000"/>
+                </a:solidFill>
+                <a:latin typeface="Arial"/>
+                <a:ea typeface="Arial"/>
+                <a:cs typeface="Arial"/>
+              </a:rPr>
+              <a:t>Recommendation</a:t>
             </a:r>
           </a:p>
           <a:p xmlns:a="http://schemas.openxmlformats.org/drawingml/2006/main">
             <a:pPr algn="l">
-              <a:defRPr sz="1600" b="1">
-                <a:solidFill>
-                  <a:srgbClr val="000000"/>
-                </a:solidFill>
-                <a:latin typeface="Arial"/>
-                <a:ea typeface="Arial"/>
-                <a:cs typeface="Arial"/>
-              </a:defRPr>
-            </a:pPr>
-            <a:r>
-              <a:rPr sz="1600" b="1">
-                <a:solidFill>
-                  <a:srgbClr val="000000"/>
-                </a:solidFill>
-                <a:latin typeface="Arial"/>
-                <a:ea typeface="Arial"/>
-                <a:cs typeface="Arial"/>
-              </a:rPr>
-              <a:t>Advance the bounded demo. Do not approve autonomous deployment.</a:t>
+              <a:defRPr sz="1500" b="1">
+                <a:solidFill>
+                  <a:srgbClr val="000000"/>
+                </a:solidFill>
+                <a:latin typeface="Arial"/>
+                <a:ea typeface="Arial"/>
+                <a:cs typeface="Arial"/>
+              </a:defRPr>
+            </a:pPr>
+            <a:r>
+              <a:rPr sz="1500" b="1">
+                <a:solidFill>
+                  <a:srgbClr val="000000"/>
+                </a:solidFill>
+                <a:latin typeface="Arial"/>
+                <a:ea typeface="Arial"/>
+                <a:cs typeface="Arial"/>
+              </a:rPr>
+              <a:t>Keep this as a human-reviewed demo. It is not ready to make decisions on its own.</a:t>
             </a:r>
           </a:p>
         </p:txBody>
@@ -3915,7 +4192,7 @@
           <p:cNvPr id="10" name="">
             <a:extLst xmlns:a="http://schemas.openxmlformats.org/drawingml/2006/main">
               <a:ext uri="{FF2B5EF4-FFF2-40B4-BE49-F238E27FC236}">
-                <a16:creationId xmlns:a16="http://schemas.microsoft.com/office/drawing/2014/main" id="{B0B55543-8436-4751-B8A2-DADC6134028A}"/>
+                <a16:creationId xmlns:a16="http://schemas.microsoft.com/office/drawing/2014/main" id="{22FB7AEC-1C77-405F-B6BE-B5CAE1B96ABB}"/>
               </a:ext>
             </a:extLst>
           </p:cNvPr>
@@ -3948,19 +4225,19 @@
           <p:cNvPr id="11" name="">
             <a:extLst xmlns:a="http://schemas.openxmlformats.org/drawingml/2006/main">
               <a:ext uri="{FF2B5EF4-FFF2-40B4-BE49-F238E27FC236}">
-                <a16:creationId xmlns:a16="http://schemas.microsoft.com/office/drawing/2014/main" id="{CC9754AA-9ACD-434F-B031-7BFA9035B026}"/>
-              </a:ext>
-            </a:extLst>
-          </p:cNvPr>
-          <p:cNvSpPr>
-            <a:spLocks xmlns:a="http://schemas.openxmlformats.org/drawingml/2006/main" noGrp="1"/>
-          </p:cNvSpPr>
-          <p:nvPr/>
-        </p:nvSpPr>
-        <p:spPr>
-          <a:xfrm xmlns:a="http://schemas.openxmlformats.org/drawingml/2006/main">
-            <a:off x="6457950" y="4619625"/>
-            <a:ext cx="1562100" cy="266700"/>
+                <a16:creationId xmlns:a16="http://schemas.microsoft.com/office/drawing/2014/main" id="{E5780A0C-6115-4F6A-9306-3A0351E24460}"/>
+              </a:ext>
+            </a:extLst>
+          </p:cNvPr>
+          <p:cNvSpPr>
+            <a:spLocks xmlns:a="http://schemas.openxmlformats.org/drawingml/2006/main" noGrp="1"/>
+          </p:cNvSpPr>
+          <p:nvPr/>
+        </p:nvSpPr>
+        <p:spPr>
+          <a:xfrm xmlns:a="http://schemas.openxmlformats.org/drawingml/2006/main">
+            <a:off x="6419850" y="4619625"/>
+            <a:ext cx="1657350" cy="266700"/>
           </a:xfrm>
           <a:prstGeom xmlns:a="http://schemas.openxmlformats.org/drawingml/2006/main" prst="rect">
             <a:avLst/>
@@ -3976,7 +4253,7 @@
           <a:lstStyle xmlns:a="http://schemas.openxmlformats.org/drawingml/2006/main"/>
           <a:p xmlns:a="http://schemas.openxmlformats.org/drawingml/2006/main">
             <a:pPr algn="ctr">
-              <a:defRPr sz="1300" b="1">
+              <a:defRPr sz="1200" b="1">
                 <a:solidFill>
                   <a:srgbClr val="3D8DFF"/>
                 </a:solidFill>
@@ -3986,7 +4263,7 @@
               </a:defRPr>
             </a:pPr>
             <a:r>
-              <a:rPr sz="1300" b="1">
+              <a:rPr sz="1200" b="1">
                 <a:solidFill>
                   <a:srgbClr val="3D8DFF"/>
                 </a:solidFill>
@@ -3994,7 +4271,7 @@
                 <a:ea typeface="Arial"/>
                 <a:cs typeface="Arial"/>
               </a:rPr>
-              <a:t>LOCAL PILOT</a:t>
+              <a:t>FASTER FIRST PASS</a:t>
             </a:r>
           </a:p>
         </p:txBody>
@@ -4004,19 +4281,19 @@
           <p:cNvPr id="12" name="">
             <a:extLst xmlns:a="http://schemas.openxmlformats.org/drawingml/2006/main">
               <a:ext uri="{FF2B5EF4-FFF2-40B4-BE49-F238E27FC236}">
-                <a16:creationId xmlns:a16="http://schemas.microsoft.com/office/drawing/2014/main" id="{82BFEF75-352A-4C50-A54B-D93207F5FABC}"/>
-              </a:ext>
-            </a:extLst>
-          </p:cNvPr>
-          <p:cNvSpPr>
-            <a:spLocks xmlns:a="http://schemas.openxmlformats.org/drawingml/2006/main" noGrp="1"/>
-          </p:cNvSpPr>
-          <p:nvPr/>
-        </p:nvSpPr>
-        <p:spPr>
-          <a:xfrm xmlns:a="http://schemas.openxmlformats.org/drawingml/2006/main">
-            <a:off x="8229600" y="4619625"/>
-            <a:ext cx="1562100" cy="266700"/>
+                <a16:creationId xmlns:a16="http://schemas.microsoft.com/office/drawing/2014/main" id="{61FC13B4-6BF2-4798-B918-C8579BB5B65C}"/>
+              </a:ext>
+            </a:extLst>
+          </p:cNvPr>
+          <p:cNvSpPr>
+            <a:spLocks xmlns:a="http://schemas.openxmlformats.org/drawingml/2006/main" noGrp="1"/>
+          </p:cNvSpPr>
+          <p:nvPr/>
+        </p:nvSpPr>
+        <p:spPr>
+          <a:xfrm xmlns:a="http://schemas.openxmlformats.org/drawingml/2006/main">
+            <a:off x="8191500" y="4619625"/>
+            <a:ext cx="1657350" cy="266700"/>
           </a:xfrm>
           <a:prstGeom xmlns:a="http://schemas.openxmlformats.org/drawingml/2006/main" prst="rect">
             <a:avLst/>
@@ -4032,7 +4309,7 @@
           <a:lstStyle xmlns:a="http://schemas.openxmlformats.org/drawingml/2006/main"/>
           <a:p xmlns:a="http://schemas.openxmlformats.org/drawingml/2006/main">
             <a:pPr algn="ctr">
-              <a:defRPr sz="1300" b="1">
+              <a:defRPr sz="1200" b="1">
                 <a:solidFill>
                   <a:srgbClr val="3D8DFF"/>
                 </a:solidFill>
@@ -4042,7 +4319,7 @@
               </a:defRPr>
             </a:pPr>
             <a:r>
-              <a:rPr sz="1300" b="1">
+              <a:rPr sz="1200" b="1">
                 <a:solidFill>
                   <a:srgbClr val="3D8DFF"/>
                 </a:solidFill>
@@ -4050,7 +4327,7 @@
                 <a:ea typeface="Arial"/>
                 <a:cs typeface="Arial"/>
               </a:rPr>
-              <a:t>AUDIT-READY</a:t>
+              <a:t>CLEARER REVIEW</a:t>
             </a:r>
           </a:p>
         </p:txBody>
@@ -4060,19 +4337,19 @@
           <p:cNvPr id="13" name="">
             <a:extLst xmlns:a="http://schemas.openxmlformats.org/drawingml/2006/main">
               <a:ext uri="{FF2B5EF4-FFF2-40B4-BE49-F238E27FC236}">
-                <a16:creationId xmlns:a16="http://schemas.microsoft.com/office/drawing/2014/main" id="{0C014827-D4B6-4A60-9AD4-4639490D97E0}"/>
-              </a:ext>
-            </a:extLst>
-          </p:cNvPr>
-          <p:cNvSpPr>
-            <a:spLocks xmlns:a="http://schemas.openxmlformats.org/drawingml/2006/main" noGrp="1"/>
-          </p:cNvSpPr>
-          <p:nvPr/>
-        </p:nvSpPr>
-        <p:spPr>
-          <a:xfrm xmlns:a="http://schemas.openxmlformats.org/drawingml/2006/main">
-            <a:off x="10001250" y="4619625"/>
-            <a:ext cx="1562100" cy="266700"/>
+                <a16:creationId xmlns:a16="http://schemas.microsoft.com/office/drawing/2014/main" id="{C93CDCF2-7DEC-4D47-B9B1-3720560D061E}"/>
+              </a:ext>
+            </a:extLst>
+          </p:cNvPr>
+          <p:cNvSpPr>
+            <a:spLocks xmlns:a="http://schemas.openxmlformats.org/drawingml/2006/main" noGrp="1"/>
+          </p:cNvSpPr>
+          <p:nvPr/>
+        </p:nvSpPr>
+        <p:spPr>
+          <a:xfrm xmlns:a="http://schemas.openxmlformats.org/drawingml/2006/main">
+            <a:off x="9963150" y="4619625"/>
+            <a:ext cx="1657350" cy="266700"/>
           </a:xfrm>
           <a:prstGeom xmlns:a="http://schemas.openxmlformats.org/drawingml/2006/main" prst="rect">
             <a:avLst/>
@@ -4088,7 +4365,7 @@
           <a:lstStyle xmlns:a="http://schemas.openxmlformats.org/drawingml/2006/main"/>
           <a:p xmlns:a="http://schemas.openxmlformats.org/drawingml/2006/main">
             <a:pPr algn="ctr">
-              <a:defRPr sz="1300" b="1">
+              <a:defRPr sz="1200" b="1">
                 <a:solidFill>
                   <a:srgbClr val="3D8DFF"/>
                 </a:solidFill>
@@ -4098,7 +4375,7 @@
               </a:defRPr>
             </a:pPr>
             <a:r>
-              <a:rPr sz="1300" b="1">
+              <a:rPr sz="1200" b="1">
                 <a:solidFill>
                   <a:srgbClr val="3D8DFF"/>
                 </a:solidFill>
@@ -4106,7 +4383,7 @@
                 <a:ea typeface="Arial"/>
                 <a:cs typeface="Arial"/>
               </a:rPr>
-              <a:t>HUMAN-GATED</a:t>
+              <a:t>HUMAN CONTROL</a:t>
             </a:r>
           </a:p>
         </p:txBody>
@@ -4116,7 +4393,7 @@
           <p:cNvPr id="14" name="">
             <a:extLst xmlns:a="http://schemas.openxmlformats.org/drawingml/2006/main">
               <a:ext uri="{FF2B5EF4-FFF2-40B4-BE49-F238E27FC236}">
-                <a16:creationId xmlns:a16="http://schemas.microsoft.com/office/drawing/2014/main" id="{A8CC165D-60BC-46D2-A171-5DA6907E84DE}"/>
+                <a16:creationId xmlns:a16="http://schemas.microsoft.com/office/drawing/2014/main" id="{7137EB8F-60B7-44BE-B947-3BBE8A4A86EE}"/>
               </a:ext>
             </a:extLst>
           </p:cNvPr>
@@ -4162,7 +4439,7 @@
                 <a:ea typeface="Arial"/>
                 <a:cs typeface="Arial"/>
               </a:rPr>
-              <a:t>No cloud upload</a:t>
+              <a:t>Sorts the queue</a:t>
             </a:r>
           </a:p>
         </p:txBody>
@@ -4172,19 +4449,19 @@
           <p:cNvPr id="15" name="">
             <a:extLst xmlns:a="http://schemas.openxmlformats.org/drawingml/2006/main">
               <a:ext uri="{FF2B5EF4-FFF2-40B4-BE49-F238E27FC236}">
-                <a16:creationId xmlns:a16="http://schemas.microsoft.com/office/drawing/2014/main" id="{0D52A1BD-B162-4568-BEE8-BF59C6BA9367}"/>
-              </a:ext>
-            </a:extLst>
-          </p:cNvPr>
-          <p:cNvSpPr>
-            <a:spLocks xmlns:a="http://schemas.openxmlformats.org/drawingml/2006/main" noGrp="1"/>
-          </p:cNvSpPr>
-          <p:nvPr/>
-        </p:nvSpPr>
-        <p:spPr>
-          <a:xfrm xmlns:a="http://schemas.openxmlformats.org/drawingml/2006/main">
-            <a:off x="8229600" y="5019675"/>
-            <a:ext cx="1562100" cy="228600"/>
+                <a16:creationId xmlns:a16="http://schemas.microsoft.com/office/drawing/2014/main" id="{71490BCD-7107-49E7-81A6-28AE195C18D9}"/>
+              </a:ext>
+            </a:extLst>
+          </p:cNvPr>
+          <p:cNvSpPr>
+            <a:spLocks xmlns:a="http://schemas.openxmlformats.org/drawingml/2006/main" noGrp="1"/>
+          </p:cNvSpPr>
+          <p:nvPr/>
+        </p:nvSpPr>
+        <p:spPr>
+          <a:xfrm xmlns:a="http://schemas.openxmlformats.org/drawingml/2006/main">
+            <a:off x="8172450" y="5019675"/>
+            <a:ext cx="1771650" cy="228600"/>
           </a:xfrm>
           <a:prstGeom xmlns:a="http://schemas.openxmlformats.org/drawingml/2006/main" prst="rect">
             <a:avLst/>
@@ -4218,7 +4495,7 @@
                 <a:ea typeface="Arial"/>
                 <a:cs typeface="Arial"/>
               </a:rPr>
-              <a:t>Exact run record</a:t>
+              <a:t>Keeps scores + reasons</a:t>
             </a:r>
           </a:p>
         </p:txBody>
@@ -4228,19 +4505,19 @@
           <p:cNvPr id="16" name="">
             <a:extLst xmlns:a="http://schemas.openxmlformats.org/drawingml/2006/main">
               <a:ext uri="{FF2B5EF4-FFF2-40B4-BE49-F238E27FC236}">
-                <a16:creationId xmlns:a16="http://schemas.microsoft.com/office/drawing/2014/main" id="{0A508D88-9092-41B8-87D0-8732E3F3BB3B}"/>
-              </a:ext>
-            </a:extLst>
-          </p:cNvPr>
-          <p:cNvSpPr>
-            <a:spLocks xmlns:a="http://schemas.openxmlformats.org/drawingml/2006/main" noGrp="1"/>
-          </p:cNvSpPr>
-          <p:nvPr/>
-        </p:nvSpPr>
-        <p:spPr>
-          <a:xfrm xmlns:a="http://schemas.openxmlformats.org/drawingml/2006/main">
-            <a:off x="10001250" y="5019675"/>
-            <a:ext cx="1562100" cy="228600"/>
+                <a16:creationId xmlns:a16="http://schemas.microsoft.com/office/drawing/2014/main" id="{07754771-6463-41EB-B5B5-78251A427A12}"/>
+              </a:ext>
+            </a:extLst>
+          </p:cNvPr>
+          <p:cNvSpPr>
+            <a:spLocks xmlns:a="http://schemas.openxmlformats.org/drawingml/2006/main" noGrp="1"/>
+          </p:cNvSpPr>
+          <p:nvPr/>
+        </p:nvSpPr>
+        <p:spPr>
+          <a:xfrm xmlns:a="http://schemas.openxmlformats.org/drawingml/2006/main">
+            <a:off x="9906000" y="5019675"/>
+            <a:ext cx="1752600" cy="228600"/>
           </a:xfrm>
           <a:prstGeom xmlns:a="http://schemas.openxmlformats.org/drawingml/2006/main" prst="rect">
             <a:avLst/>
@@ -4274,7 +4551,7 @@
                 <a:ea typeface="Arial"/>
                 <a:cs typeface="Arial"/>
               </a:rPr>
-              <a:t>Review stays human</a:t>
+              <a:t>Reviewer makes final call</a:t>
             </a:r>
           </a:p>
         </p:txBody>
@@ -4284,7 +4561,7 @@
           <p:cNvPr id="17" name="">
             <a:extLst xmlns:a="http://schemas.openxmlformats.org/drawingml/2006/main">
               <a:ext uri="{FF2B5EF4-FFF2-40B4-BE49-F238E27FC236}">
-                <a16:creationId xmlns:a16="http://schemas.microsoft.com/office/drawing/2014/main" id="{96724B0B-D880-45A2-8869-47DE0C5A7760}"/>
+                <a16:creationId xmlns:a16="http://schemas.microsoft.com/office/drawing/2014/main" id="{37A3FB37-603F-462A-ADAD-F8005C4FAD35}"/>
               </a:ext>
             </a:extLst>
           </p:cNvPr>
@@ -4317,7 +4594,7 @@
           <p:cNvPr id="18" name="">
             <a:extLst xmlns:a="http://schemas.openxmlformats.org/drawingml/2006/main">
               <a:ext uri="{FF2B5EF4-FFF2-40B4-BE49-F238E27FC236}">
-                <a16:creationId xmlns:a16="http://schemas.microsoft.com/office/drawing/2014/main" id="{9CD018E2-CA19-4CAA-B3F3-00ACCAF8C310}"/>
+                <a16:creationId xmlns:a16="http://schemas.microsoft.com/office/drawing/2014/main" id="{D8615916-56D6-4DD8-A9E9-3DE8EADE6265}"/>
               </a:ext>
             </a:extLst>
           </p:cNvPr>
@@ -4373,7 +4650,7 @@
           <p:cNvPr id="19" name="">
             <a:extLst xmlns:a="http://schemas.openxmlformats.org/drawingml/2006/main">
               <a:ext uri="{FF2B5EF4-FFF2-40B4-BE49-F238E27FC236}">
-                <a16:creationId xmlns:a16="http://schemas.microsoft.com/office/drawing/2014/main" id="{D7F96938-60AB-4D45-9981-26AE391FC537}"/>
+                <a16:creationId xmlns:a16="http://schemas.microsoft.com/office/drawing/2014/main" id="{F96DBB86-F37F-49D2-A174-F786ED1A7211}"/>
               </a:ext>
             </a:extLst>
           </p:cNvPr>
@@ -4427,7 +4704,7 @@
     </p:spTree>
     <p:extLst>
       <p:ext uri="{BB962C8B-B14F-4D97-AF65-F5344CB8AC3E}">
-        <p14:creationId xmlns:p14="http://schemas.microsoft.com/office/powerpoint/2010/main" val="1535434387"/>
+        <p14:creationId xmlns:p14="http://schemas.microsoft.com/office/powerpoint/2010/main" val="25228211"/>
       </p:ext>
     </p:extLst>
   </p:cSld>
@@ -4458,7 +4735,7 @@
           <p:cNvPr id="19" name="Google-Shape-532-p58-2">
             <a:extLst xmlns:a="http://schemas.openxmlformats.org/drawingml/2006/main">
               <a:ext uri="{FF2B5EF4-FFF2-40B4-BE49-F238E27FC236}">
-                <a16:creationId xmlns:a16="http://schemas.microsoft.com/office/drawing/2014/main" id="{47261FE0-1C9C-478B-A5D0-4B5238383453}"/>
+                <a16:creationId xmlns:a16="http://schemas.microsoft.com/office/drawing/2014/main" id="{D238A860-5E51-4D59-BCE8-1BBA23BA7F85}"/>
               </a:ext>
             </a:extLst>
           </p:cNvPr>
@@ -4503,7 +4780,7 @@
           <p:cNvPr id="2" name="Google-Shape-533-p58-3">
             <a:extLst xmlns:a="http://schemas.openxmlformats.org/drawingml/2006/main">
               <a:ext uri="{FF2B5EF4-FFF2-40B4-BE49-F238E27FC236}">
-                <a16:creationId xmlns:a16="http://schemas.microsoft.com/office/drawing/2014/main" id="{64F5CB72-AE1E-4F73-BD24-65B92F6AED20}"/>
+                <a16:creationId xmlns:a16="http://schemas.microsoft.com/office/drawing/2014/main" id="{9DC52606-8973-4059-9C16-AD0F57703E6D}"/>
               </a:ext>
             </a:extLst>
           </p:cNvPr>
@@ -4561,7 +4838,7 @@
           <p:cNvPr id="3" name="Picture-3-4-backing">
             <a:extLst xmlns:a="http://schemas.openxmlformats.org/drawingml/2006/main">
               <a:ext uri="{FF2B5EF4-FFF2-40B4-BE49-F238E27FC236}">
-                <a16:creationId xmlns:a16="http://schemas.microsoft.com/office/drawing/2014/main" id="{68F1CDCE-2190-4D8A-A66A-753694B60A64}"/>
+                <a16:creationId xmlns:a16="http://schemas.microsoft.com/office/drawing/2014/main" id="{446C45E4-4DEC-47F7-9823-B0D4512B1C10}"/>
               </a:ext>
             </a:extLst>
           </p:cNvPr>
@@ -4600,7 +4877,7 @@
           <p:nvPr/>
         </p:nvPicPr>
         <p:blipFill>
-          <a:blip xmlns:r="http://schemas.openxmlformats.org/officeDocument/2006/relationships" xmlns:a="http://schemas.openxmlformats.org/drawingml/2006/main" r:embed="Rf19eaffc0c6e4057"/>
+          <a:blip xmlns:r="http://schemas.openxmlformats.org/officeDocument/2006/relationships" xmlns:a="http://schemas.openxmlformats.org/drawingml/2006/main" r:embed="R90e706e5f58e48be"/>
           <a:stretch xmlns:a="http://schemas.openxmlformats.org/drawingml/2006/main"/>
         </p:blipFill>
         <p:spPr>
@@ -4618,7 +4895,7 @@
           <p:cNvPr id="5" name="Google-Shape-534-p58-5">
             <a:extLst xmlns:a="http://schemas.openxmlformats.org/drawingml/2006/main">
               <a:ext uri="{FF2B5EF4-FFF2-40B4-BE49-F238E27FC236}">
-                <a16:creationId xmlns:a16="http://schemas.microsoft.com/office/drawing/2014/main" id="{41E81F33-70FA-4693-8A55-870498987ED2}"/>
+                <a16:creationId xmlns:a16="http://schemas.microsoft.com/office/drawing/2014/main" id="{0735CE4D-570C-4BF4-AFEF-982E143FC510}"/>
               </a:ext>
             </a:extLst>
           </p:cNvPr>
@@ -4702,7 +4979,7 @@
           <p:cNvPr id="6" name="">
             <a:extLst xmlns:a="http://schemas.openxmlformats.org/drawingml/2006/main">
               <a:ext uri="{FF2B5EF4-FFF2-40B4-BE49-F238E27FC236}">
-                <a16:creationId xmlns:a16="http://schemas.microsoft.com/office/drawing/2014/main" id="{7337ECB2-3529-47CF-B7DB-436F25B7DB67}"/>
+                <a16:creationId xmlns:a16="http://schemas.microsoft.com/office/drawing/2014/main" id="{AFAF6733-2920-4E3F-86D3-3E09F137FD72}"/>
               </a:ext>
             </a:extLst>
           </p:cNvPr>
@@ -4735,7 +5012,7 @@
           <p:cNvPr id="7" name="">
             <a:extLst xmlns:a="http://schemas.openxmlformats.org/drawingml/2006/main">
               <a:ext uri="{FF2B5EF4-FFF2-40B4-BE49-F238E27FC236}">
-                <a16:creationId xmlns:a16="http://schemas.microsoft.com/office/drawing/2014/main" id="{83D8A82A-E18F-47C1-BF88-F814A68A6C9E}"/>
+                <a16:creationId xmlns:a16="http://schemas.microsoft.com/office/drawing/2014/main" id="{72343105-3259-4F51-9A1A-51E97B028506}"/>
               </a:ext>
             </a:extLst>
           </p:cNvPr>
@@ -4791,7 +5068,7 @@
           <p:cNvPr id="8" name="">
             <a:extLst xmlns:a="http://schemas.openxmlformats.org/drawingml/2006/main">
               <a:ext uri="{FF2B5EF4-FFF2-40B4-BE49-F238E27FC236}">
-                <a16:creationId xmlns:a16="http://schemas.microsoft.com/office/drawing/2014/main" id="{63990033-5624-42D0-A5F3-E3AE587ECC7C}"/>
+                <a16:creationId xmlns:a16="http://schemas.microsoft.com/office/drawing/2014/main" id="{3D0C631E-B362-40B7-8138-4E46D279D025}"/>
               </a:ext>
             </a:extLst>
           </p:cNvPr>
@@ -4847,7 +5124,7 @@
           <p:cNvPr id="9" name="">
             <a:extLst xmlns:a="http://schemas.openxmlformats.org/drawingml/2006/main">
               <a:ext uri="{FF2B5EF4-FFF2-40B4-BE49-F238E27FC236}">
-                <a16:creationId xmlns:a16="http://schemas.microsoft.com/office/drawing/2014/main" id="{17A71636-4726-4EB1-900D-401F78519855}"/>
+                <a16:creationId xmlns:a16="http://schemas.microsoft.com/office/drawing/2014/main" id="{39980088-B2E6-4EDB-8A04-7FB66BAB650E}"/>
               </a:ext>
             </a:extLst>
           </p:cNvPr>
@@ -4880,7 +5157,7 @@
           <p:cNvPr id="10" name="">
             <a:extLst xmlns:a="http://schemas.openxmlformats.org/drawingml/2006/main">
               <a:ext uri="{FF2B5EF4-FFF2-40B4-BE49-F238E27FC236}">
-                <a16:creationId xmlns:a16="http://schemas.microsoft.com/office/drawing/2014/main" id="{4684F553-B43F-4C94-8C12-F49C347B76F0}"/>
+                <a16:creationId xmlns:a16="http://schemas.microsoft.com/office/drawing/2014/main" id="{88EC834E-A2E1-4E23-9552-CC6EBDFF335E}"/>
               </a:ext>
             </a:extLst>
           </p:cNvPr>
@@ -4936,7 +5213,7 @@
           <p:cNvPr id="11" name="">
             <a:extLst xmlns:a="http://schemas.openxmlformats.org/drawingml/2006/main">
               <a:ext uri="{FF2B5EF4-FFF2-40B4-BE49-F238E27FC236}">
-                <a16:creationId xmlns:a16="http://schemas.microsoft.com/office/drawing/2014/main" id="{2C3543E6-4E9A-46B6-987D-47840465B8B1}"/>
+                <a16:creationId xmlns:a16="http://schemas.microsoft.com/office/drawing/2014/main" id="{DBBFE39E-7311-437F-868D-FE0ACC8B36E9}"/>
               </a:ext>
             </a:extLst>
           </p:cNvPr>
@@ -4992,7 +5269,7 @@
           <p:cNvPr id="12" name="">
             <a:extLst xmlns:a="http://schemas.openxmlformats.org/drawingml/2006/main">
               <a:ext uri="{FF2B5EF4-FFF2-40B4-BE49-F238E27FC236}">
-                <a16:creationId xmlns:a16="http://schemas.microsoft.com/office/drawing/2014/main" id="{B45B20EE-29ED-4C84-B718-B4CAD6E0DB8D}"/>
+                <a16:creationId xmlns:a16="http://schemas.microsoft.com/office/drawing/2014/main" id="{1A9BD54B-BF64-42B6-AC26-6ABCDD95FD25}"/>
               </a:ext>
             </a:extLst>
           </p:cNvPr>
@@ -5025,7 +5302,7 @@
           <p:cNvPr id="13" name="">
             <a:extLst xmlns:a="http://schemas.openxmlformats.org/drawingml/2006/main">
               <a:ext uri="{FF2B5EF4-FFF2-40B4-BE49-F238E27FC236}">
-                <a16:creationId xmlns:a16="http://schemas.microsoft.com/office/drawing/2014/main" id="{BC24A7D8-B438-4C68-BC60-FE1FE8A985BE}"/>
+                <a16:creationId xmlns:a16="http://schemas.microsoft.com/office/drawing/2014/main" id="{D14D9962-3803-4B38-AC37-3CEBCF7455C7}"/>
               </a:ext>
             </a:extLst>
           </p:cNvPr>
@@ -5081,7 +5358,7 @@
           <p:cNvPr id="14" name="">
             <a:extLst xmlns:a="http://schemas.openxmlformats.org/drawingml/2006/main">
               <a:ext uri="{FF2B5EF4-FFF2-40B4-BE49-F238E27FC236}">
-                <a16:creationId xmlns:a16="http://schemas.microsoft.com/office/drawing/2014/main" id="{E21241FC-FA18-42E2-B26D-9F7ECA68FB96}"/>
+                <a16:creationId xmlns:a16="http://schemas.microsoft.com/office/drawing/2014/main" id="{F368F525-F44F-415E-A9FB-757B459B6361}"/>
               </a:ext>
             </a:extLst>
           </p:cNvPr>
@@ -5150,7 +5427,7 @@
                 <a:ea typeface="Arial"/>
                 <a:cs typeface="Arial"/>
               </a:rPr>
-              <a:t>ViT &gt;50 ms; end-to-end p95 unassessed</a:t>
+              <a:t>ViT exceeds 50 ms; full-pipeline timing is unknown</a:t>
             </a:r>
           </a:p>
         </p:txBody>
@@ -5160,7 +5437,7 @@
           <p:cNvPr id="15" name="">
             <a:extLst xmlns:a="http://schemas.openxmlformats.org/drawingml/2006/main">
               <a:ext uri="{FF2B5EF4-FFF2-40B4-BE49-F238E27FC236}">
-                <a16:creationId xmlns:a16="http://schemas.microsoft.com/office/drawing/2014/main" id="{BCA4E2B5-0E18-4291-AE41-72B828B70AB3}"/>
+                <a16:creationId xmlns:a16="http://schemas.microsoft.com/office/drawing/2014/main" id="{D6E38B80-3168-4889-8BEE-24E0C292CA1B}"/>
               </a:ext>
             </a:extLst>
           </p:cNvPr>
@@ -5229,7 +5506,7 @@
                 <a:ea typeface="Arial"/>
                 <a:cs typeface="Arial"/>
               </a:rPr>
-              <a:t>Safe false-flag rate: 0 (1 − recall)</a:t>
+              <a:t>Safe false-flag rate: 0.0%</a:t>
             </a:r>
           </a:p>
           <a:p xmlns:a="http://schemas.openxmlformats.org/drawingml/2006/main">
@@ -5252,7 +5529,7 @@
                 <a:ea typeface="Arial"/>
                 <a:cs typeface="Arial"/>
               </a:rPr>
-              <a:t>Argmax restricted recall: 0.97222</a:t>
+              <a:t>Restricted recall, argmax mean: 0.97222</a:t>
             </a:r>
           </a:p>
           <a:p xmlns:a="http://schemas.openxmlformats.org/drawingml/2006/main">
@@ -5275,7 +5552,7 @@
                 <a:ea typeface="Arial"/>
                 <a:cs typeface="Arial"/>
               </a:rPr>
-              <a:t>Threshold recall mean / min: 0.94444 / 0.91667</a:t>
+              <a:t>Restricted recall, threshold mean / minimum: 0.94444 / 0.91667</a:t>
             </a:r>
           </a:p>
           <a:p xmlns:a="http://schemas.openxmlformats.org/drawingml/2006/main">
@@ -5298,7 +5575,7 @@
                 <a:ea typeface="Arial"/>
                 <a:cs typeface="Arial"/>
               </a:rPr>
-              <a:t>&gt;0.95 per-class target: FAIL · calibration floor ≥0.90</a:t>
+              <a:t>Result: two restricted classes miss the &gt;0.95 proposal target</a:t>
             </a:r>
           </a:p>
         </p:txBody>
@@ -5308,7 +5585,7 @@
           <p:cNvPr id="16" name="">
             <a:extLst xmlns:a="http://schemas.openxmlformats.org/drawingml/2006/main">
               <a:ext uri="{FF2B5EF4-FFF2-40B4-BE49-F238E27FC236}">
-                <a16:creationId xmlns:a16="http://schemas.microsoft.com/office/drawing/2014/main" id="{C1C0E705-1BFF-4EFB-969C-7D799EF6CF91}"/>
+                <a16:creationId xmlns:a16="http://schemas.microsoft.com/office/drawing/2014/main" id="{14191F86-DA2B-481B-9597-9BE3C0AC26D3}"/>
               </a:ext>
             </a:extLst>
           </p:cNvPr>
@@ -5341,7 +5618,7 @@
           <p:cNvPr id="17" name="">
             <a:extLst xmlns:a="http://schemas.openxmlformats.org/drawingml/2006/main">
               <a:ext uri="{FF2B5EF4-FFF2-40B4-BE49-F238E27FC236}">
-                <a16:creationId xmlns:a16="http://schemas.microsoft.com/office/drawing/2014/main" id="{692BBBE0-ABD7-40AF-B12A-19D9739C5A84}"/>
+                <a16:creationId xmlns:a16="http://schemas.microsoft.com/office/drawing/2014/main" id="{73B1EF65-F196-4BB2-B2A4-A737F1670D5C}"/>
               </a:ext>
             </a:extLst>
           </p:cNvPr>
@@ -5397,7 +5674,7 @@
           <p:cNvPr id="18" name="">
             <a:extLst xmlns:a="http://schemas.openxmlformats.org/drawingml/2006/main">
               <a:ext uri="{FF2B5EF4-FFF2-40B4-BE49-F238E27FC236}">
-                <a16:creationId xmlns:a16="http://schemas.microsoft.com/office/drawing/2014/main" id="{3F40C5C7-9386-459F-A806-1024F333F477}"/>
+                <a16:creationId xmlns:a16="http://schemas.microsoft.com/office/drawing/2014/main" id="{B9DE2851-F862-4D51-99D3-26434504822F}"/>
               </a:ext>
             </a:extLst>
           </p:cNvPr>
@@ -5451,7 +5728,7 @@
     </p:spTree>
     <p:extLst>
       <p:ext uri="{BB962C8B-B14F-4D97-AF65-F5344CB8AC3E}">
-        <p14:creationId xmlns:p14="http://schemas.microsoft.com/office/powerpoint/2010/main" val="965408376"/>
+        <p14:creationId xmlns:p14="http://schemas.microsoft.com/office/powerpoint/2010/main" val="1133997761"/>
       </p:ext>
     </p:extLst>
   </p:cSld>
@@ -5482,7 +5759,7 @@
           <p:cNvPr id="14" name="Google-Shape-532-p58-2">
             <a:extLst xmlns:a="http://schemas.openxmlformats.org/drawingml/2006/main">
               <a:ext uri="{FF2B5EF4-FFF2-40B4-BE49-F238E27FC236}">
-                <a16:creationId xmlns:a16="http://schemas.microsoft.com/office/drawing/2014/main" id="{ECAAD542-46FC-4E40-80E3-3CFA51108A53}"/>
+                <a16:creationId xmlns:a16="http://schemas.microsoft.com/office/drawing/2014/main" id="{60A55289-CD59-4BF6-BD68-917FE2F964D3}"/>
               </a:ext>
             </a:extLst>
           </p:cNvPr>
@@ -5527,7 +5804,7 @@
           <p:cNvPr id="2" name="Google-Shape-533-p58-3">
             <a:extLst xmlns:a="http://schemas.openxmlformats.org/drawingml/2006/main">
               <a:ext uri="{FF2B5EF4-FFF2-40B4-BE49-F238E27FC236}">
-                <a16:creationId xmlns:a16="http://schemas.microsoft.com/office/drawing/2014/main" id="{337449A1-2A4D-43B2-8DDD-5902F247389A}"/>
+                <a16:creationId xmlns:a16="http://schemas.microsoft.com/office/drawing/2014/main" id="{F38C00EF-8FF9-42E4-81D0-D3C0AE297952}"/>
               </a:ext>
             </a:extLst>
           </p:cNvPr>
@@ -5574,8 +5851,8 @@
                 <a:ea typeface="Arial"/>
                 <a:cs typeface="Arial"/>
               </a:rPr>
-              <a:t>One grenade crossed
-the class boundary</a:t>
+              <a:t>One grenade was classified
+as a firearm</a:t>
             </a:r>
           </a:p>
         </p:txBody>
@@ -5585,7 +5862,7 @@
           <p:cNvPr id="3" name="Rounded-Rectangle-6-4">
             <a:extLst xmlns:a="http://schemas.openxmlformats.org/drawingml/2006/main">
               <a:ext uri="{FF2B5EF4-FFF2-40B4-BE49-F238E27FC236}">
-                <a16:creationId xmlns:a16="http://schemas.microsoft.com/office/drawing/2014/main" id="{166F8B5D-7752-48B0-AE00-5EF78EC5A8DC}"/>
+                <a16:creationId xmlns:a16="http://schemas.microsoft.com/office/drawing/2014/main" id="{464C3BB0-9B65-426D-BCF8-16906D21DCAC}"/>
               </a:ext>
             </a:extLst>
           </p:cNvPr>
@@ -5614,7 +5891,7 @@
           <p:cNvPr id="4" name="Content-Placeholder-10-5">
             <a:extLst xmlns:a="http://schemas.openxmlformats.org/drawingml/2006/main">
               <a:ext uri="{FF2B5EF4-FFF2-40B4-BE49-F238E27FC236}">
-                <a16:creationId xmlns:a16="http://schemas.microsoft.com/office/drawing/2014/main" id="{6F18AA1A-7894-486A-A644-D26B7DDF03E2}"/>
+                <a16:creationId xmlns:a16="http://schemas.microsoft.com/office/drawing/2014/main" id="{C28B0F83-A059-48B8-AA7B-B2977CAF6CE7}"/>
               </a:ext>
             </a:extLst>
           </p:cNvPr>
@@ -5661,7 +5938,7 @@
                 <a:ea typeface="Arial"/>
                 <a:cs typeface="Arial"/>
               </a:rPr>
-              <a:t>NO AUTO-BLOCK</a:t>
+              <a:t>POLICY RESULT</a:t>
             </a:r>
           </a:p>
           <a:p xmlns:a="http://schemas.openxmlformats.org/drawingml/2006/main">
@@ -5688,7 +5965,7 @@
                 <a:ea typeface="Arial"/>
                 <a:cs typeface="Arial"/>
               </a:rPr>
-              <a:t>Neither class-specific block threshold fired for that image; a restricted error still needs review.</a:t>
+              <a:t>Neither block threshold fired, so the saved case went to REVIEW rather than automatic enforcement.</a:t>
             </a:r>
           </a:p>
         </p:txBody>
@@ -5698,7 +5975,7 @@
           <p:cNvPr id="5" name="Rounded-Rectangle-8-6">
             <a:extLst xmlns:a="http://schemas.openxmlformats.org/drawingml/2006/main">
               <a:ext uri="{FF2B5EF4-FFF2-40B4-BE49-F238E27FC236}">
-                <a16:creationId xmlns:a16="http://schemas.microsoft.com/office/drawing/2014/main" id="{8523218F-AC36-4A9B-B816-1D2B65569A09}"/>
+                <a16:creationId xmlns:a16="http://schemas.microsoft.com/office/drawing/2014/main" id="{A8350272-FD1D-423C-9333-0E65FD98155A}"/>
               </a:ext>
             </a:extLst>
           </p:cNvPr>
@@ -5727,7 +6004,7 @@
           <p:cNvPr id="6" name="Content-Placeholder-10-7">
             <a:extLst xmlns:a="http://schemas.openxmlformats.org/drawingml/2006/main">
               <a:ext uri="{FF2B5EF4-FFF2-40B4-BE49-F238E27FC236}">
-                <a16:creationId xmlns:a16="http://schemas.microsoft.com/office/drawing/2014/main" id="{0D4DED48-C78E-4D35-B5A2-ACB4BA445B50}"/>
+                <a16:creationId xmlns:a16="http://schemas.microsoft.com/office/drawing/2014/main" id="{0FCE86A7-0206-489A-9D3C-E611F5DACDB3}"/>
               </a:ext>
             </a:extLst>
           </p:cNvPr>
@@ -5774,7 +6051,7 @@
                 <a:ea typeface="Arial"/>
                 <a:cs typeface="Arial"/>
               </a:rPr>
-              <a:t>FORMAL ERROR</a:t>
+              <a:t>WHAT HAPPENED</a:t>
             </a:r>
           </a:p>
           <a:p xmlns:a="http://schemas.openxmlformats.org/drawingml/2006/main">
@@ -5801,7 +6078,7 @@
                 <a:ea typeface="Arial"/>
                 <a:cs typeface="Arial"/>
               </a:rPr>
-              <a:t>One explosives image was predicted as firearms. All other 47 labels were correct.</a:t>
+              <a:t>One explosives image was predicted as firearms. The other 47 labels were correct.</a:t>
             </a:r>
           </a:p>
         </p:txBody>
@@ -5811,7 +6088,7 @@
           <p:cNvPr id="7" name="Rounded-Rectangle-1-8">
             <a:extLst xmlns:a="http://schemas.openxmlformats.org/drawingml/2006/main">
               <a:ext uri="{FF2B5EF4-FFF2-40B4-BE49-F238E27FC236}">
-                <a16:creationId xmlns:a16="http://schemas.microsoft.com/office/drawing/2014/main" id="{0059E5D2-713F-47EA-AEF8-F3E19A98DB0C}"/>
+                <a16:creationId xmlns:a16="http://schemas.microsoft.com/office/drawing/2014/main" id="{837DB3F7-181B-4E1A-97F2-4796321E978F}"/>
               </a:ext>
             </a:extLst>
           </p:cNvPr>
@@ -5840,7 +6117,7 @@
           <p:cNvPr id="8" name="Content-Placeholder-10-9">
             <a:extLst xmlns:a="http://schemas.openxmlformats.org/drawingml/2006/main">
               <a:ext uri="{FF2B5EF4-FFF2-40B4-BE49-F238E27FC236}">
-                <a16:creationId xmlns:a16="http://schemas.microsoft.com/office/drawing/2014/main" id="{B4E92120-F8D4-4C13-B309-9A38DEB8ECAE}"/>
+                <a16:creationId xmlns:a16="http://schemas.microsoft.com/office/drawing/2014/main" id="{695F24EC-08EB-46DD-9C3D-86D3B06F9E07}"/>
               </a:ext>
             </a:extLst>
           </p:cNvPr>
@@ -5887,7 +6164,7 @@
                 <a:ea typeface="Arial"/>
                 <a:cs typeface="Arial"/>
               </a:rPr>
-              <a:t>WEAKEST CLASS</a:t>
+              <a:t>WHY IT MATTERS</a:t>
             </a:r>
           </a:p>
           <a:p xmlns:a="http://schemas.openxmlformats.org/drawingml/2006/main">
@@ -5914,8 +6191,9 @@
                 <a:ea typeface="Arial"/>
                 <a:cs typeface="Arial"/>
               </a:rPr>
-              <a:t>ViT F1 0.957 · ResNet F1 0.750.
-Separation remains fragile.</a:t>
+              <a:t>Lowest class: explosives.
+ViT F1 0.957
+ResNet F1 0.750</a:t>
             </a:r>
           </a:p>
         </p:txBody>
@@ -5932,7 +6210,7 @@
         </p:xfrm>
         <a:graphic xmlns:a="http://schemas.openxmlformats.org/drawingml/2006/main">
           <a:graphicData uri="http://schemas.openxmlformats.org/drawingml/2006/chart">
-            <c:chart xmlns:r="http://schemas.openxmlformats.org/officeDocument/2006/relationships" xmlns:c="http://schemas.openxmlformats.org/drawingml/2006/chart" r:id="R91b3c207fbb540a7"/>
+            <c:chart xmlns:r="http://schemas.openxmlformats.org/officeDocument/2006/relationships" xmlns:c="http://schemas.openxmlformats.org/drawingml/2006/chart" r:id="Rea05b542081344e2"/>
           </a:graphicData>
         </a:graphic>
       </p:graphicFrame>
@@ -5945,16 +6223,16 @@
           <p:nvPr/>
         </p:nvPicPr>
         <p:blipFill>
-          <a:blip xmlns:r="http://schemas.openxmlformats.org/officeDocument/2006/relationships" xmlns:a="http://schemas.openxmlformats.org/drawingml/2006/main" r:embed="R31c0597616a94017"/>
-          <a:srcRect xmlns:a="http://schemas.openxmlformats.org/drawingml/2006/main" l="0" t="15909" r="0" b="15909"/>
+          <a:blip xmlns:r="http://schemas.openxmlformats.org/officeDocument/2006/relationships" xmlns:a="http://schemas.openxmlformats.org/drawingml/2006/main" r:embed="Ra8ee64158c0c4b29"/>
+          <a:srcRect xmlns:a="http://schemas.openxmlformats.org/drawingml/2006/main" l="0" t="9091" r="0" b="9091"/>
           <a:stretch xmlns:a="http://schemas.openxmlformats.org/drawingml/2006/main">
             <a:fillRect l="0" t="0" r="0" b="0"/>
           </a:stretch>
         </p:blipFill>
         <p:spPr>
           <a:xfrm xmlns:a="http://schemas.openxmlformats.org/drawingml/2006/main">
-            <a:off x="10287000" y="4762500"/>
-            <a:ext cx="1257300" cy="857250"/>
+            <a:off x="10458450" y="4762500"/>
+            <a:ext cx="1047750" cy="857250"/>
           </a:xfrm>
           <a:prstGeom xmlns:a="http://schemas.openxmlformats.org/drawingml/2006/main" prst="rect">
             <a:avLst/>
@@ -5966,7 +6244,7 @@
           <p:cNvPr id="11" name="">
             <a:extLst xmlns:a="http://schemas.openxmlformats.org/drawingml/2006/main">
               <a:ext uri="{FF2B5EF4-FFF2-40B4-BE49-F238E27FC236}">
-                <a16:creationId xmlns:a16="http://schemas.microsoft.com/office/drawing/2014/main" id="{F306B4B7-8109-46AD-87CA-4E7613A1DBA8}"/>
+                <a16:creationId xmlns:a16="http://schemas.microsoft.com/office/drawing/2014/main" id="{E349E243-A293-4AC0-833B-2E2C113425E8}"/>
               </a:ext>
             </a:extLst>
           </p:cNvPr>
@@ -5999,7 +6277,7 @@
           <p:cNvPr id="12" name="">
             <a:extLst xmlns:a="http://schemas.openxmlformats.org/drawingml/2006/main">
               <a:ext uri="{FF2B5EF4-FFF2-40B4-BE49-F238E27FC236}">
-                <a16:creationId xmlns:a16="http://schemas.microsoft.com/office/drawing/2014/main" id="{637E98BD-BEA6-4440-BEE7-A0B2365EC06A}"/>
+                <a16:creationId xmlns:a16="http://schemas.microsoft.com/office/drawing/2014/main" id="{69C7E3BB-618E-4DD8-85A9-FF6FA4D35E8F}"/>
               </a:ext>
             </a:extLst>
           </p:cNvPr>
@@ -6055,7 +6333,7 @@
           <p:cNvPr id="13" name="">
             <a:extLst xmlns:a="http://schemas.openxmlformats.org/drawingml/2006/main">
               <a:ext uri="{FF2B5EF4-FFF2-40B4-BE49-F238E27FC236}">
-                <a16:creationId xmlns:a16="http://schemas.microsoft.com/office/drawing/2014/main" id="{D141EA0E-8EC2-4A08-A187-445A3F98D3D0}"/>
+                <a16:creationId xmlns:a16="http://schemas.microsoft.com/office/drawing/2014/main" id="{4D00EE9E-CB79-40EE-93E4-45440997C675}"/>
               </a:ext>
             </a:extLst>
           </p:cNvPr>
@@ -6109,7 +6387,7 @@
     </p:spTree>
     <p:extLst>
       <p:ext uri="{BB962C8B-B14F-4D97-AF65-F5344CB8AC3E}">
-        <p14:creationId xmlns:p14="http://schemas.microsoft.com/office/powerpoint/2010/main" val="190912248"/>
+        <p14:creationId xmlns:p14="http://schemas.microsoft.com/office/powerpoint/2010/main" val="305405906"/>
       </p:ext>
     </p:extLst>
   </p:cSld>
@@ -6140,7 +6418,7 @@
           <p:cNvPr id="14" name="Google-Shape-532-p58-2">
             <a:extLst xmlns:a="http://schemas.openxmlformats.org/drawingml/2006/main">
               <a:ext uri="{FF2B5EF4-FFF2-40B4-BE49-F238E27FC236}">
-                <a16:creationId xmlns:a16="http://schemas.microsoft.com/office/drawing/2014/main" id="{EB77A394-A7D7-4AC6-995C-F0134F048DEA}"/>
+                <a16:creationId xmlns:a16="http://schemas.microsoft.com/office/drawing/2014/main" id="{2B3CFA79-E3E4-463F-A408-87A1958616A8}"/>
               </a:ext>
             </a:extLst>
           </p:cNvPr>
@@ -6185,7 +6463,7 @@
           <p:cNvPr id="2" name="Google-Shape-533-p58-3">
             <a:extLst xmlns:a="http://schemas.openxmlformats.org/drawingml/2006/main">
               <a:ext uri="{FF2B5EF4-FFF2-40B4-BE49-F238E27FC236}">
-                <a16:creationId xmlns:a16="http://schemas.microsoft.com/office/drawing/2014/main" id="{E3D44B50-DDCC-41FC-979C-10A461C84F16}"/>
+                <a16:creationId xmlns:a16="http://schemas.microsoft.com/office/drawing/2014/main" id="{A749BF78-45A2-4410-93D0-2513874934B3}"/>
               </a:ext>
             </a:extLst>
           </p:cNvPr>
@@ -6232,8 +6510,8 @@
                 <a:ea typeface="Arial"/>
                 <a:cs typeface="Arial"/>
               </a:rPr>
-              <a:t>External audit
-breaks confidence</a:t>
+              <a:t>External images exposed
+weak generalization</a:t>
             </a:r>
           </a:p>
         </p:txBody>
@@ -6243,7 +6521,7 @@
           <p:cNvPr id="3" name="Picture-3-4-backing">
             <a:extLst xmlns:a="http://schemas.openxmlformats.org/drawingml/2006/main">
               <a:ext uri="{FF2B5EF4-FFF2-40B4-BE49-F238E27FC236}">
-                <a16:creationId xmlns:a16="http://schemas.microsoft.com/office/drawing/2014/main" id="{832F9BDA-F2BA-4DB9-B113-9D209A7F2F11}"/>
+                <a16:creationId xmlns:a16="http://schemas.microsoft.com/office/drawing/2014/main" id="{E3833ED0-D2F2-43B2-B1D2-F97E0EB4190E}"/>
               </a:ext>
             </a:extLst>
           </p:cNvPr>
@@ -6282,7 +6560,7 @@
           <p:nvPr/>
         </p:nvPicPr>
         <p:blipFill>
-          <a:blip xmlns:r="http://schemas.openxmlformats.org/officeDocument/2006/relationships" xmlns:a="http://schemas.openxmlformats.org/drawingml/2006/main" r:embed="Rb41fd411a165481f"/>
+          <a:blip xmlns:r="http://schemas.openxmlformats.org/officeDocument/2006/relationships" xmlns:a="http://schemas.openxmlformats.org/drawingml/2006/main" r:embed="Rb087a065f4414ee3"/>
           <a:srcRect xmlns:a="http://schemas.openxmlformats.org/drawingml/2006/main" l="18403" t="0" r="18403" b="0"/>
           <a:stretch xmlns:a="http://schemas.openxmlformats.org/drawingml/2006/main">
             <a:fillRect l="0" t="0" r="0" b="0"/>
@@ -6303,7 +6581,7 @@
           <p:cNvPr id="5" name="Google-Shape-534-p58-5">
             <a:extLst xmlns:a="http://schemas.openxmlformats.org/drawingml/2006/main">
               <a:ext uri="{FF2B5EF4-FFF2-40B4-BE49-F238E27FC236}">
-                <a16:creationId xmlns:a16="http://schemas.microsoft.com/office/drawing/2014/main" id="{1216CE7F-BFB3-4CA9-89A3-E1BC445EB885}"/>
+                <a16:creationId xmlns:a16="http://schemas.microsoft.com/office/drawing/2014/main" id="{F3AC287F-F5CC-4EE7-AB77-8D5BFCEB40F7}"/>
               </a:ext>
             </a:extLst>
           </p:cNvPr>
@@ -6379,7 +6657,7 @@
               </a:rPr>
               <a:t>0.55489 classifier macro F1
 0.90 detector nonweapon FPR
-Historical layouts, languages, and photographic context differ sharply from the pilot sources. This is a diagnostic spot check, not a formal test set.</a:t>
+The images use different layouts, languages, ages, and photographic contexts. This small selected diagnostic is a warning, not a formal test set or population estimate.</a:t>
             </a:r>
           </a:p>
         </p:txBody>
@@ -6393,7 +6671,7 @@
           <p:nvPr/>
         </p:nvPicPr>
         <p:blipFill>
-          <a:blip xmlns:r="http://schemas.openxmlformats.org/officeDocument/2006/relationships" xmlns:a="http://schemas.openxmlformats.org/drawingml/2006/main" r:embed="R637fcb9869924063"/>
+          <a:blip xmlns:r="http://schemas.openxmlformats.org/officeDocument/2006/relationships" xmlns:a="http://schemas.openxmlformats.org/drawingml/2006/main" r:embed="Rc0979efeb96743b7"/>
           <a:srcRect xmlns:a="http://schemas.openxmlformats.org/drawingml/2006/main" l="1572" t="0" r="1572" b="0"/>
           <a:stretch xmlns:a="http://schemas.openxmlformats.org/drawingml/2006/main">
             <a:fillRect l="0" t="0" r="0" b="0"/>
@@ -6418,7 +6696,7 @@
           <p:nvPr/>
         </p:nvPicPr>
         <p:blipFill>
-          <a:blip xmlns:r="http://schemas.openxmlformats.org/officeDocument/2006/relationships" xmlns:a="http://schemas.openxmlformats.org/drawingml/2006/main" r:embed="R5817a9e1d1e346bc"/>
+          <a:blip xmlns:r="http://schemas.openxmlformats.org/officeDocument/2006/relationships" xmlns:a="http://schemas.openxmlformats.org/drawingml/2006/main" r:embed="Rafff97483a46433f"/>
           <a:srcRect xmlns:a="http://schemas.openxmlformats.org/drawingml/2006/main" l="12237" t="0" r="12237" b="0"/>
           <a:stretch xmlns:a="http://schemas.openxmlformats.org/drawingml/2006/main">
             <a:fillRect l="0" t="0" r="0" b="0"/>
@@ -6439,7 +6717,7 @@
           <p:cNvPr id="8" name="">
             <a:extLst xmlns:a="http://schemas.openxmlformats.org/drawingml/2006/main">
               <a:ext uri="{FF2B5EF4-FFF2-40B4-BE49-F238E27FC236}">
-                <a16:creationId xmlns:a16="http://schemas.microsoft.com/office/drawing/2014/main" id="{DE509F21-E428-42F3-B8D9-6BCD4E45A142}"/>
+                <a16:creationId xmlns:a16="http://schemas.microsoft.com/office/drawing/2014/main" id="{C4EB42C2-5CFF-468E-9B5D-AC1CE44019DA}"/>
               </a:ext>
             </a:extLst>
           </p:cNvPr>
@@ -6497,7 +6775,7 @@
           <p:cNvPr id="9" name="">
             <a:extLst xmlns:a="http://schemas.openxmlformats.org/drawingml/2006/main">
               <a:ext uri="{FF2B5EF4-FFF2-40B4-BE49-F238E27FC236}">
-                <a16:creationId xmlns:a16="http://schemas.microsoft.com/office/drawing/2014/main" id="{2436B15E-F2DC-4F1F-A714-F8B61395394A}"/>
+                <a16:creationId xmlns:a16="http://schemas.microsoft.com/office/drawing/2014/main" id="{48E5A729-41ED-4B08-AD33-E1E1901187AF}"/>
               </a:ext>
             </a:extLst>
           </p:cNvPr>
@@ -6555,7 +6833,7 @@
           <p:cNvPr id="10" name="">
             <a:extLst xmlns:a="http://schemas.openxmlformats.org/drawingml/2006/main">
               <a:ext uri="{FF2B5EF4-FFF2-40B4-BE49-F238E27FC236}">
-                <a16:creationId xmlns:a16="http://schemas.microsoft.com/office/drawing/2014/main" id="{14AA9E9B-3B8C-45FB-B6C9-23D235B1D203}"/>
+                <a16:creationId xmlns:a16="http://schemas.microsoft.com/office/drawing/2014/main" id="{404DB2FC-8CA8-40F4-B91A-051AF8B160F2}"/>
               </a:ext>
             </a:extLst>
           </p:cNvPr>
@@ -6613,7 +6891,7 @@
           <p:cNvPr id="11" name="">
             <a:extLst xmlns:a="http://schemas.openxmlformats.org/drawingml/2006/main">
               <a:ext uri="{FF2B5EF4-FFF2-40B4-BE49-F238E27FC236}">
-                <a16:creationId xmlns:a16="http://schemas.microsoft.com/office/drawing/2014/main" id="{1FACAA0D-FBC6-4555-B49B-92A46788BEB5}"/>
+                <a16:creationId xmlns:a16="http://schemas.microsoft.com/office/drawing/2014/main" id="{DBBDC3B2-CE50-40E2-81F2-4DC6ABA1546D}"/>
               </a:ext>
             </a:extLst>
           </p:cNvPr>
@@ -6646,7 +6924,7 @@
           <p:cNvPr id="12" name="">
             <a:extLst xmlns:a="http://schemas.openxmlformats.org/drawingml/2006/main">
               <a:ext uri="{FF2B5EF4-FFF2-40B4-BE49-F238E27FC236}">
-                <a16:creationId xmlns:a16="http://schemas.microsoft.com/office/drawing/2014/main" id="{FE63D728-454F-4E52-95FE-43AAE4FD40ED}"/>
+                <a16:creationId xmlns:a16="http://schemas.microsoft.com/office/drawing/2014/main" id="{73D6CD5D-2392-445E-81F1-3A5FDDE4B461}"/>
               </a:ext>
             </a:extLst>
           </p:cNvPr>
@@ -6702,7 +6980,7 @@
           <p:cNvPr id="13" name="">
             <a:extLst xmlns:a="http://schemas.openxmlformats.org/drawingml/2006/main">
               <a:ext uri="{FF2B5EF4-FFF2-40B4-BE49-F238E27FC236}">
-                <a16:creationId xmlns:a16="http://schemas.microsoft.com/office/drawing/2014/main" id="{21832D9D-E3B4-43D8-B71C-C091B8CBF0AF}"/>
+                <a16:creationId xmlns:a16="http://schemas.microsoft.com/office/drawing/2014/main" id="{EE594854-2954-45AE-8488-EF499E6F3F67}"/>
               </a:ext>
             </a:extLst>
           </p:cNvPr>
@@ -6756,7 +7034,7 @@
     </p:spTree>
     <p:extLst>
       <p:ext uri="{BB962C8B-B14F-4D97-AF65-F5344CB8AC3E}">
-        <p14:creationId xmlns:p14="http://schemas.microsoft.com/office/powerpoint/2010/main" val="1497489878"/>
+        <p14:creationId xmlns:p14="http://schemas.microsoft.com/office/powerpoint/2010/main" val="135612083"/>
       </p:ext>
     </p:extLst>
   </p:cSld>
@@ -6787,7 +7065,7 @@
           <p:cNvPr id="35" name="Slide-Number-Placeholder-3-2">
             <a:extLst xmlns:a="http://schemas.openxmlformats.org/drawingml/2006/main">
               <a:ext uri="{FF2B5EF4-FFF2-40B4-BE49-F238E27FC236}">
-                <a16:creationId xmlns:a16="http://schemas.microsoft.com/office/drawing/2014/main" id="{8EF92CC3-5F91-4675-89A4-C06FADE97A0A}"/>
+                <a16:creationId xmlns:a16="http://schemas.microsoft.com/office/drawing/2014/main" id="{FE06E7D8-88DE-4FF5-933F-C66E34AC5C52}"/>
               </a:ext>
             </a:extLst>
           </p:cNvPr>
@@ -6830,7 +7108,7 @@
           <p:cNvPr id="2" name="Title-10-3">
             <a:extLst xmlns:a="http://schemas.openxmlformats.org/drawingml/2006/main">
               <a:ext uri="{FF2B5EF4-FFF2-40B4-BE49-F238E27FC236}">
-                <a16:creationId xmlns:a16="http://schemas.microsoft.com/office/drawing/2014/main" id="{B4550CDB-C91F-48AB-BB2C-0C2B8F44FEA7}"/>
+                <a16:creationId xmlns:a16="http://schemas.microsoft.com/office/drawing/2014/main" id="{32418291-E604-481C-812E-A954C4D0A67F}"/>
               </a:ext>
             </a:extLst>
           </p:cNvPr>
@@ -6869,15 +7147,15 @@
               </a:defRPr>
             </a:pPr>
             <a:r>
-              <a:rPr sz="3450">
-                <a:solidFill>
-                  <a:srgbClr val="000000"/>
-                </a:solidFill>
-                <a:latin typeface="Arial"/>
-                <a:ea typeface="Arial"/>
-                <a:cs typeface="Arial"/>
-              </a:rPr>
-              <a:t>One workspace carries a case from upload to audit</a:t>
+              <a:rPr sz="3300">
+                <a:solidFill>
+                  <a:srgbClr val="000000"/>
+                </a:solidFill>
+                <a:latin typeface="Arial"/>
+                <a:ea typeface="Arial"/>
+                <a:cs typeface="Arial"/>
+              </a:rPr>
+              <a:t>A reviewer can follow one case from upload to audit</a:t>
             </a:r>
           </a:p>
         </p:txBody>
@@ -6909,7 +7187,7 @@
           <p:cNvPr id="4" name="Google-Shape-2260-p159-5">
             <a:extLst xmlns:a="http://schemas.openxmlformats.org/drawingml/2006/main">
               <a:ext uri="{FF2B5EF4-FFF2-40B4-BE49-F238E27FC236}">
-                <a16:creationId xmlns:a16="http://schemas.microsoft.com/office/drawing/2014/main" id="{955149D9-DA49-4BE3-BA09-CE9A1A9F5B9B}"/>
+                <a16:creationId xmlns:a16="http://schemas.microsoft.com/office/drawing/2014/main" id="{22DDB36A-612F-4B03-833E-21E9175BB47D}"/>
               </a:ext>
             </a:extLst>
           </p:cNvPr>
@@ -6936,7 +7214,7 @@
           <p:cNvPr id="5" name="Google-Shape-2261-p159-6">
             <a:extLst xmlns:a="http://schemas.openxmlformats.org/drawingml/2006/main">
               <a:ext uri="{FF2B5EF4-FFF2-40B4-BE49-F238E27FC236}">
-                <a16:creationId xmlns:a16="http://schemas.microsoft.com/office/drawing/2014/main" id="{AD7E5F99-D084-4FCE-AAFE-17FFA984F8A6}"/>
+                <a16:creationId xmlns:a16="http://schemas.microsoft.com/office/drawing/2014/main" id="{5E750A58-838A-44C8-A7D7-2B3DEDECCED4}"/>
               </a:ext>
             </a:extLst>
           </p:cNvPr>
@@ -6963,7 +7241,7 @@
           <p:cNvPr id="6" name="Google-Shape-2262-p159-7">
             <a:extLst xmlns:a="http://schemas.openxmlformats.org/drawingml/2006/main">
               <a:ext uri="{FF2B5EF4-FFF2-40B4-BE49-F238E27FC236}">
-                <a16:creationId xmlns:a16="http://schemas.microsoft.com/office/drawing/2014/main" id="{3107FF2E-0539-427A-BF88-424AE8F8492B}"/>
+                <a16:creationId xmlns:a16="http://schemas.microsoft.com/office/drawing/2014/main" id="{7DEF4C78-B16E-4FA5-9EED-9002996ED1A9}"/>
               </a:ext>
             </a:extLst>
           </p:cNvPr>
@@ -6990,7 +7268,7 @@
           <p:cNvPr id="7" name="Rounded-Rectangle-19-8">
             <a:extLst xmlns:a="http://schemas.openxmlformats.org/drawingml/2006/main">
               <a:ext uri="{FF2B5EF4-FFF2-40B4-BE49-F238E27FC236}">
-                <a16:creationId xmlns:a16="http://schemas.microsoft.com/office/drawing/2014/main" id="{DE1CF579-65CB-476E-8003-482508745843}"/>
+                <a16:creationId xmlns:a16="http://schemas.microsoft.com/office/drawing/2014/main" id="{C755BB31-D4AA-41A5-87C2-EC0F8875A573}"/>
               </a:ext>
             </a:extLst>
           </p:cNvPr>
@@ -7019,7 +7297,7 @@
           <p:cNvPr id="8" name="Content-Placeholder-8-9">
             <a:extLst xmlns:a="http://schemas.openxmlformats.org/drawingml/2006/main">
               <a:ext uri="{FF2B5EF4-FFF2-40B4-BE49-F238E27FC236}">
-                <a16:creationId xmlns:a16="http://schemas.microsoft.com/office/drawing/2014/main" id="{EE51A01F-24F2-4334-A10E-2E466ABD50BA}"/>
+                <a16:creationId xmlns:a16="http://schemas.microsoft.com/office/drawing/2014/main" id="{49369861-FDFB-4677-BF36-C14E8DCA7C33}"/>
               </a:ext>
             </a:extLst>
           </p:cNvPr>
@@ -7103,7 +7381,7 @@
           <p:cNvPr id="9" name="Rounded-Rectangle-21-10">
             <a:extLst xmlns:a="http://schemas.openxmlformats.org/drawingml/2006/main">
               <a:ext uri="{FF2B5EF4-FFF2-40B4-BE49-F238E27FC236}">
-                <a16:creationId xmlns:a16="http://schemas.microsoft.com/office/drawing/2014/main" id="{FE2DF149-FAA6-4578-B39D-6746D881BEED}"/>
+                <a16:creationId xmlns:a16="http://schemas.microsoft.com/office/drawing/2014/main" id="{060059FD-C985-46CE-ACD5-08C131DDA58F}"/>
               </a:ext>
             </a:extLst>
           </p:cNvPr>
@@ -7132,7 +7410,7 @@
           <p:cNvPr id="10" name="Content-Placeholder-8-11">
             <a:extLst xmlns:a="http://schemas.openxmlformats.org/drawingml/2006/main">
               <a:ext uri="{FF2B5EF4-FFF2-40B4-BE49-F238E27FC236}">
-                <a16:creationId xmlns:a16="http://schemas.microsoft.com/office/drawing/2014/main" id="{E3C1FB8C-4C50-442B-BFF6-A659C47AD269}"/>
+                <a16:creationId xmlns:a16="http://schemas.microsoft.com/office/drawing/2014/main" id="{6CD98215-37A3-46E8-B144-B21D879DB784}"/>
               </a:ext>
             </a:extLst>
           </p:cNvPr>
@@ -7216,7 +7494,7 @@
           <p:cNvPr id="11" name="Rounded-Rectangle-23-12">
             <a:extLst xmlns:a="http://schemas.openxmlformats.org/drawingml/2006/main">
               <a:ext uri="{FF2B5EF4-FFF2-40B4-BE49-F238E27FC236}">
-                <a16:creationId xmlns:a16="http://schemas.microsoft.com/office/drawing/2014/main" id="{5CD9479F-FB0B-4D25-BEAA-CEA3375823DA}"/>
+                <a16:creationId xmlns:a16="http://schemas.microsoft.com/office/drawing/2014/main" id="{04E56B88-A129-498C-9D2D-54063F5071D4}"/>
               </a:ext>
             </a:extLst>
           </p:cNvPr>
@@ -7245,7 +7523,7 @@
           <p:cNvPr id="12" name="Content-Placeholder-8-13">
             <a:extLst xmlns:a="http://schemas.openxmlformats.org/drawingml/2006/main">
               <a:ext uri="{FF2B5EF4-FFF2-40B4-BE49-F238E27FC236}">
-                <a16:creationId xmlns:a16="http://schemas.microsoft.com/office/drawing/2014/main" id="{84E7E69C-08B8-46F2-B764-231C00061323}"/>
+                <a16:creationId xmlns:a16="http://schemas.microsoft.com/office/drawing/2014/main" id="{94E1725E-0269-415F-A29A-2593DE8AE788}"/>
               </a:ext>
             </a:extLst>
           </p:cNvPr>
@@ -7329,7 +7607,7 @@
           <p:cNvPr id="13" name="Text-Placeholder-16-14">
             <a:extLst xmlns:a="http://schemas.openxmlformats.org/drawingml/2006/main">
               <a:ext uri="{FF2B5EF4-FFF2-40B4-BE49-F238E27FC236}">
-                <a16:creationId xmlns:a16="http://schemas.microsoft.com/office/drawing/2014/main" id="{D6E6C978-A999-41EC-8E4E-E6F0A5B088F0}"/>
+                <a16:creationId xmlns:a16="http://schemas.microsoft.com/office/drawing/2014/main" id="{24D92107-E88B-4842-9388-C646D3463EFA}"/>
               </a:ext>
             </a:extLst>
           </p:cNvPr>
@@ -7386,7 +7664,7 @@
           <p:cNvPr id="14" name="Text-Placeholder-16-15">
             <a:extLst xmlns:a="http://schemas.openxmlformats.org/drawingml/2006/main">
               <a:ext uri="{FF2B5EF4-FFF2-40B4-BE49-F238E27FC236}">
-                <a16:creationId xmlns:a16="http://schemas.microsoft.com/office/drawing/2014/main" id="{79025E1D-CBB1-4550-BDCF-0D8B0CF33ADC}"/>
+                <a16:creationId xmlns:a16="http://schemas.microsoft.com/office/drawing/2014/main" id="{5C7BE777-535C-4AB3-AFB8-36422D9801DF}"/>
               </a:ext>
             </a:extLst>
           </p:cNvPr>
@@ -7443,7 +7721,7 @@
           <p:cNvPr id="15" name="Text-Placeholder-16-16">
             <a:extLst xmlns:a="http://schemas.openxmlformats.org/drawingml/2006/main">
               <a:ext uri="{FF2B5EF4-FFF2-40B4-BE49-F238E27FC236}">
-                <a16:creationId xmlns:a16="http://schemas.microsoft.com/office/drawing/2014/main" id="{39BB8CB6-7CC4-44EA-8A9D-D84524BCFA28}"/>
+                <a16:creationId xmlns:a16="http://schemas.microsoft.com/office/drawing/2014/main" id="{C171A73F-E231-46DD-B8A1-4FA3FD4E92E2}"/>
               </a:ext>
             </a:extLst>
           </p:cNvPr>
@@ -7504,7 +7782,7 @@
           <p:nvPr/>
         </p:nvPicPr>
         <p:blipFill>
-          <a:blip xmlns:r="http://schemas.openxmlformats.org/officeDocument/2006/relationships" xmlns:a="http://schemas.openxmlformats.org/drawingml/2006/main" r:embed="R0cdc06e0fe57413d"/>
+          <a:blip xmlns:r="http://schemas.openxmlformats.org/officeDocument/2006/relationships" xmlns:a="http://schemas.openxmlformats.org/drawingml/2006/main" r:embed="R6d3ca943c86f4ab7"/>
           <a:srcRect xmlns:a="http://schemas.openxmlformats.org/drawingml/2006/main" l="0" t="3450" r="0" b="3450"/>
           <a:stretch xmlns:a="http://schemas.openxmlformats.org/drawingml/2006/main">
             <a:fillRect l="0" t="0" r="0" b="0"/>
@@ -7525,7 +7803,7 @@
           <p:cNvPr id="17" name="">
             <a:extLst xmlns:a="http://schemas.openxmlformats.org/drawingml/2006/main">
               <a:ext uri="{FF2B5EF4-FFF2-40B4-BE49-F238E27FC236}">
-                <a16:creationId xmlns:a16="http://schemas.microsoft.com/office/drawing/2014/main" id="{9FAC4832-9307-4807-9679-729C8A5DDA26}"/>
+                <a16:creationId xmlns:a16="http://schemas.microsoft.com/office/drawing/2014/main" id="{07B7DD6F-DD3B-4B7B-AA9E-1B8C909F2693}"/>
               </a:ext>
             </a:extLst>
           </p:cNvPr>
@@ -7558,7 +7836,7 @@
           <p:cNvPr id="18" name="">
             <a:extLst xmlns:a="http://schemas.openxmlformats.org/drawingml/2006/main">
               <a:ext uri="{FF2B5EF4-FFF2-40B4-BE49-F238E27FC236}">
-                <a16:creationId xmlns:a16="http://schemas.microsoft.com/office/drawing/2014/main" id="{306975EB-86D6-43D2-865A-E4295850CDD9}"/>
+                <a16:creationId xmlns:a16="http://schemas.microsoft.com/office/drawing/2014/main" id="{FB8BFAE7-6008-4884-8007-462F9DBAAF15}"/>
               </a:ext>
             </a:extLst>
           </p:cNvPr>
@@ -7614,7 +7892,7 @@
           <p:cNvPr id="19" name="">
             <a:extLst xmlns:a="http://schemas.openxmlformats.org/drawingml/2006/main">
               <a:ext uri="{FF2B5EF4-FFF2-40B4-BE49-F238E27FC236}">
-                <a16:creationId xmlns:a16="http://schemas.microsoft.com/office/drawing/2014/main" id="{DD2295BE-C510-4C4E-A256-B403BCB4C82E}"/>
+                <a16:creationId xmlns:a16="http://schemas.microsoft.com/office/drawing/2014/main" id="{BA5318E2-2E9D-4DCC-A1B7-19B193D52399}"/>
               </a:ext>
             </a:extLst>
           </p:cNvPr>
@@ -7670,7 +7948,7 @@
           <p:cNvPr id="20" name="">
             <a:extLst xmlns:a="http://schemas.openxmlformats.org/drawingml/2006/main">
               <a:ext uri="{FF2B5EF4-FFF2-40B4-BE49-F238E27FC236}">
-                <a16:creationId xmlns:a16="http://schemas.microsoft.com/office/drawing/2014/main" id="{2F47B890-E9BF-40ED-8A74-72BF09E8F9BF}"/>
+                <a16:creationId xmlns:a16="http://schemas.microsoft.com/office/drawing/2014/main" id="{86DEAE85-5303-4E97-863C-82D45665DE3C}"/>
               </a:ext>
             </a:extLst>
           </p:cNvPr>
@@ -7703,7 +7981,7 @@
           <p:cNvPr id="21" name="">
             <a:extLst xmlns:a="http://schemas.openxmlformats.org/drawingml/2006/main">
               <a:ext uri="{FF2B5EF4-FFF2-40B4-BE49-F238E27FC236}">
-                <a16:creationId xmlns:a16="http://schemas.microsoft.com/office/drawing/2014/main" id="{4CDA0FC3-8C0A-4726-AA15-500B19E09C55}"/>
+                <a16:creationId xmlns:a16="http://schemas.microsoft.com/office/drawing/2014/main" id="{62776F0A-819A-400C-ADD0-A46067E78186}"/>
               </a:ext>
             </a:extLst>
           </p:cNvPr>
@@ -7749,7 +8027,7 @@
                 <a:ea typeface="Arial"/>
                 <a:cs typeface="Arial"/>
               </a:rPr>
-              <a:t>SCORE PROVENANCE</a:t>
+              <a:t>WHERE THE SCORE CAME FROM</a:t>
             </a:r>
           </a:p>
         </p:txBody>
@@ -7759,7 +8037,7 @@
           <p:cNvPr id="22" name="">
             <a:extLst xmlns:a="http://schemas.openxmlformats.org/drawingml/2006/main">
               <a:ext uri="{FF2B5EF4-FFF2-40B4-BE49-F238E27FC236}">
-                <a16:creationId xmlns:a16="http://schemas.microsoft.com/office/drawing/2014/main" id="{341AF2B6-26E0-4171-844B-EDF0ECC1E690}"/>
+                <a16:creationId xmlns:a16="http://schemas.microsoft.com/office/drawing/2014/main" id="{E94F1077-C2C5-4B1F-984D-5DD413FC0DD4}"/>
               </a:ext>
             </a:extLst>
           </p:cNvPr>
@@ -7815,7 +8093,7 @@
           <p:cNvPr id="23" name="">
             <a:extLst xmlns:a="http://schemas.openxmlformats.org/drawingml/2006/main">
               <a:ext uri="{FF2B5EF4-FFF2-40B4-BE49-F238E27FC236}">
-                <a16:creationId xmlns:a16="http://schemas.microsoft.com/office/drawing/2014/main" id="{D44D2892-DB9E-456E-99C4-61041A7B2DAC}"/>
+                <a16:creationId xmlns:a16="http://schemas.microsoft.com/office/drawing/2014/main" id="{56972995-7DF2-4964-850E-409BB3B71AC7}"/>
               </a:ext>
             </a:extLst>
           </p:cNvPr>
@@ -7848,7 +8126,7 @@
           <p:cNvPr id="24" name="">
             <a:extLst xmlns:a="http://schemas.openxmlformats.org/drawingml/2006/main">
               <a:ext uri="{FF2B5EF4-FFF2-40B4-BE49-F238E27FC236}">
-                <a16:creationId xmlns:a16="http://schemas.microsoft.com/office/drawing/2014/main" id="{D7BFFC3A-3078-4B41-A3B1-7F2DCC23DCF8}"/>
+                <a16:creationId xmlns:a16="http://schemas.microsoft.com/office/drawing/2014/main" id="{BD2C7F18-54DE-4133-B18E-2331DA7CB061}"/>
               </a:ext>
             </a:extLst>
           </p:cNvPr>
@@ -7904,7 +8182,7 @@
           <p:cNvPr id="25" name="">
             <a:extLst xmlns:a="http://schemas.openxmlformats.org/drawingml/2006/main">
               <a:ext uri="{FF2B5EF4-FFF2-40B4-BE49-F238E27FC236}">
-                <a16:creationId xmlns:a16="http://schemas.microsoft.com/office/drawing/2014/main" id="{5536EC89-C4E9-4316-8947-C181B5E17574}"/>
+                <a16:creationId xmlns:a16="http://schemas.microsoft.com/office/drawing/2014/main" id="{115E7537-2CE6-4978-B800-9B8249C07D37}"/>
               </a:ext>
             </a:extLst>
           </p:cNvPr>
@@ -7960,7 +8238,7 @@
           <p:cNvPr id="26" name="">
             <a:extLst xmlns:a="http://schemas.openxmlformats.org/drawingml/2006/main">
               <a:ext uri="{FF2B5EF4-FFF2-40B4-BE49-F238E27FC236}">
-                <a16:creationId xmlns:a16="http://schemas.microsoft.com/office/drawing/2014/main" id="{9CF8D889-FAF0-42CE-91A2-FD00550329BC}"/>
+                <a16:creationId xmlns:a16="http://schemas.microsoft.com/office/drawing/2014/main" id="{688665FE-E3CD-4171-95F4-52E94996B8A1}"/>
               </a:ext>
             </a:extLst>
           </p:cNvPr>
@@ -7993,7 +8271,7 @@
           <p:cNvPr id="27" name="">
             <a:extLst xmlns:a="http://schemas.openxmlformats.org/drawingml/2006/main">
               <a:ext uri="{FF2B5EF4-FFF2-40B4-BE49-F238E27FC236}">
-                <a16:creationId xmlns:a16="http://schemas.microsoft.com/office/drawing/2014/main" id="{80954950-3F0F-420B-B0A5-11316A63A487}"/>
+                <a16:creationId xmlns:a16="http://schemas.microsoft.com/office/drawing/2014/main" id="{B852A28A-E531-4252-A61C-85BBCB24EB86}"/>
               </a:ext>
             </a:extLst>
           </p:cNvPr>
@@ -8049,7 +8327,7 @@
           <p:cNvPr id="28" name="">
             <a:extLst xmlns:a="http://schemas.openxmlformats.org/drawingml/2006/main">
               <a:ext uri="{FF2B5EF4-FFF2-40B4-BE49-F238E27FC236}">
-                <a16:creationId xmlns:a16="http://schemas.microsoft.com/office/drawing/2014/main" id="{44552317-D4C3-4D31-9859-B594B6F0E255}"/>
+                <a16:creationId xmlns:a16="http://schemas.microsoft.com/office/drawing/2014/main" id="{7A0D3D08-9A60-43C1-8611-843D84C06504}"/>
               </a:ext>
             </a:extLst>
           </p:cNvPr>
@@ -8105,7 +8383,7 @@
           <p:cNvPr id="29" name="">
             <a:extLst xmlns:a="http://schemas.openxmlformats.org/drawingml/2006/main">
               <a:ext uri="{FF2B5EF4-FFF2-40B4-BE49-F238E27FC236}">
-                <a16:creationId xmlns:a16="http://schemas.microsoft.com/office/drawing/2014/main" id="{12E36CAF-79B8-4052-8DBE-69ED8A2B241F}"/>
+                <a16:creationId xmlns:a16="http://schemas.microsoft.com/office/drawing/2014/main" id="{36EF74F8-2A95-4EA6-B351-2DA8B0276577}"/>
               </a:ext>
             </a:extLst>
           </p:cNvPr>
@@ -8138,7 +8416,7 @@
           <p:cNvPr id="30" name="">
             <a:extLst xmlns:a="http://schemas.openxmlformats.org/drawingml/2006/main">
               <a:ext uri="{FF2B5EF4-FFF2-40B4-BE49-F238E27FC236}">
-                <a16:creationId xmlns:a16="http://schemas.microsoft.com/office/drawing/2014/main" id="{0BFA15DD-7560-4F6E-BD66-E6E0E96522C9}"/>
+                <a16:creationId xmlns:a16="http://schemas.microsoft.com/office/drawing/2014/main" id="{D37D9CC6-F0DB-40E1-B245-43896B7D7F38}"/>
               </a:ext>
             </a:extLst>
           </p:cNvPr>
@@ -8171,7 +8449,7 @@
           <p:cNvPr id="31" name="">
             <a:extLst xmlns:a="http://schemas.openxmlformats.org/drawingml/2006/main">
               <a:ext uri="{FF2B5EF4-FFF2-40B4-BE49-F238E27FC236}">
-                <a16:creationId xmlns:a16="http://schemas.microsoft.com/office/drawing/2014/main" id="{C08865D1-D192-4D4C-A57D-5C660D9A7A62}"/>
+                <a16:creationId xmlns:a16="http://schemas.microsoft.com/office/drawing/2014/main" id="{9AB4AEF0-49B8-4A06-8FD1-21D8187F5472}"/>
               </a:ext>
             </a:extLst>
           </p:cNvPr>
@@ -8199,7 +8477,7 @@
           <a:lstStyle xmlns:a="http://schemas.openxmlformats.org/drawingml/2006/main"/>
           <a:p xmlns:a="http://schemas.openxmlformats.org/drawingml/2006/main">
             <a:pPr algn="l">
-              <a:defRPr sz="1600" b="1">
+              <a:defRPr sz="1350" b="1">
                 <a:solidFill>
                   <a:srgbClr val="D9485F"/>
                 </a:solidFill>
@@ -8209,7 +8487,7 @@
               </a:defRPr>
             </a:pPr>
             <a:r>
-              <a:rPr sz="1600" b="1">
+              <a:rPr sz="1350" b="1">
                 <a:solidFill>
                   <a:srgbClr val="D9485F"/>
                 </a:solidFill>
@@ -8217,12 +8495,12 @@
                 <a:ea typeface="Arial"/>
                 <a:cs typeface="Arial"/>
               </a:rPr>
-              <a:t>Session analytics describe review,</a:t>
+              <a:t>Session charts cover this session only.</a:t>
             </a:r>
           </a:p>
           <a:p xmlns:a="http://schemas.openxmlformats.org/drawingml/2006/main">
             <a:pPr algn="l">
-              <a:defRPr sz="1600" b="1">
+              <a:defRPr sz="1350" b="1">
                 <a:solidFill>
                   <a:srgbClr val="D9485F"/>
                 </a:solidFill>
@@ -8232,7 +8510,7 @@
               </a:defRPr>
             </a:pPr>
             <a:r>
-              <a:rPr sz="1600" b="1">
+              <a:rPr sz="1350" b="1">
                 <a:solidFill>
                   <a:srgbClr val="D9485F"/>
                 </a:solidFill>
@@ -8240,7 +8518,7 @@
                 <a:ea typeface="Arial"/>
                 <a:cs typeface="Arial"/>
               </a:rPr>
-              <a:t>not production or population evidence.</a:t>
+              <a:t>They are not production or population evidence.</a:t>
             </a:r>
           </a:p>
         </p:txBody>
@@ -8250,7 +8528,7 @@
           <p:cNvPr id="32" name="">
             <a:extLst xmlns:a="http://schemas.openxmlformats.org/drawingml/2006/main">
               <a:ext uri="{FF2B5EF4-FFF2-40B4-BE49-F238E27FC236}">
-                <a16:creationId xmlns:a16="http://schemas.microsoft.com/office/drawing/2014/main" id="{63084930-78B2-43E5-A91F-0AFC2830D42C}"/>
+                <a16:creationId xmlns:a16="http://schemas.microsoft.com/office/drawing/2014/main" id="{1B1439EE-D11E-4840-95AA-10B87966D50E}"/>
               </a:ext>
             </a:extLst>
           </p:cNvPr>
@@ -8283,7 +8561,7 @@
           <p:cNvPr id="33" name="">
             <a:extLst xmlns:a="http://schemas.openxmlformats.org/drawingml/2006/main">
               <a:ext uri="{FF2B5EF4-FFF2-40B4-BE49-F238E27FC236}">
-                <a16:creationId xmlns:a16="http://schemas.microsoft.com/office/drawing/2014/main" id="{14DDD164-8EDF-480F-8587-AC23DD54F539}"/>
+                <a16:creationId xmlns:a16="http://schemas.microsoft.com/office/drawing/2014/main" id="{0EB4C66F-3947-4909-BDF1-EC1B2038DCEA}"/>
               </a:ext>
             </a:extLst>
           </p:cNvPr>
@@ -8339,7 +8617,7 @@
           <p:cNvPr id="34" name="">
             <a:extLst xmlns:a="http://schemas.openxmlformats.org/drawingml/2006/main">
               <a:ext uri="{FF2B5EF4-FFF2-40B4-BE49-F238E27FC236}">
-                <a16:creationId xmlns:a16="http://schemas.microsoft.com/office/drawing/2014/main" id="{BA731F06-291A-46C4-823F-3498E3E9687C}"/>
+                <a16:creationId xmlns:a16="http://schemas.microsoft.com/office/drawing/2014/main" id="{28C19444-D8CE-4E74-8080-A5BE941629CE}"/>
               </a:ext>
             </a:extLst>
           </p:cNvPr>
@@ -8393,7 +8671,7 @@
     </p:spTree>
     <p:extLst>
       <p:ext uri="{BB962C8B-B14F-4D97-AF65-F5344CB8AC3E}">
-        <p14:creationId xmlns:p14="http://schemas.microsoft.com/office/powerpoint/2010/main" val="216509885"/>
+        <p14:creationId xmlns:p14="http://schemas.microsoft.com/office/powerpoint/2010/main" val="1849773031"/>
       </p:ext>
     </p:extLst>
   </p:cSld>
@@ -8424,7 +8702,7 @@
           <p:cNvPr id="16" name="Rounded-Rectangle-5-1">
             <a:extLst xmlns:a="http://schemas.openxmlformats.org/drawingml/2006/main">
               <a:ext uri="{FF2B5EF4-FFF2-40B4-BE49-F238E27FC236}">
-                <a16:creationId xmlns:a16="http://schemas.microsoft.com/office/drawing/2014/main" id="{4E663847-5534-42F8-8408-BDEF6A9E89DA}"/>
+                <a16:creationId xmlns:a16="http://schemas.microsoft.com/office/drawing/2014/main" id="{52E4AAE0-072B-4872-BBD3-9A473B651175}"/>
               </a:ext>
             </a:extLst>
           </p:cNvPr>
@@ -8453,7 +8731,7 @@
           <p:cNvPr id="2" name="Rounded-Rectangle-6-2">
             <a:extLst xmlns:a="http://schemas.openxmlformats.org/drawingml/2006/main">
               <a:ext uri="{FF2B5EF4-FFF2-40B4-BE49-F238E27FC236}">
-                <a16:creationId xmlns:a16="http://schemas.microsoft.com/office/drawing/2014/main" id="{5E154CCB-6F80-45E3-BBC9-1695CDAAE36B}"/>
+                <a16:creationId xmlns:a16="http://schemas.microsoft.com/office/drawing/2014/main" id="{8892DB14-BBDD-4896-A670-A2B29466B9B8}"/>
               </a:ext>
             </a:extLst>
           </p:cNvPr>
@@ -8482,7 +8760,7 @@
           <p:cNvPr id="3" name="Rounded-Rectangle-7-3">
             <a:extLst xmlns:a="http://schemas.openxmlformats.org/drawingml/2006/main">
               <a:ext uri="{FF2B5EF4-FFF2-40B4-BE49-F238E27FC236}">
-                <a16:creationId xmlns:a16="http://schemas.microsoft.com/office/drawing/2014/main" id="{A32C9A8F-1406-4340-9FC2-7AA54A2B8B88}"/>
+                <a16:creationId xmlns:a16="http://schemas.microsoft.com/office/drawing/2014/main" id="{6E6624C2-C90D-4D9E-B473-94448B5F1D94}"/>
               </a:ext>
             </a:extLst>
           </p:cNvPr>
@@ -8511,7 +8789,7 @@
           <p:cNvPr id="4" name="Slide-Number-Placeholder-1-4">
             <a:extLst xmlns:a="http://schemas.openxmlformats.org/drawingml/2006/main">
               <a:ext uri="{FF2B5EF4-FFF2-40B4-BE49-F238E27FC236}">
-                <a16:creationId xmlns:a16="http://schemas.microsoft.com/office/drawing/2014/main" id="{DB881C3A-74E1-401D-B33D-2A9DDF5BBBB5}"/>
+                <a16:creationId xmlns:a16="http://schemas.microsoft.com/office/drawing/2014/main" id="{F390DBDB-3E10-478C-B252-158BE7447D7D}"/>
               </a:ext>
             </a:extLst>
           </p:cNvPr>
@@ -8554,7 +8832,7 @@
           <p:cNvPr id="5" name="Title-2-5">
             <a:extLst xmlns:a="http://schemas.openxmlformats.org/drawingml/2006/main">
               <a:ext uri="{FF2B5EF4-FFF2-40B4-BE49-F238E27FC236}">
-                <a16:creationId xmlns:a16="http://schemas.microsoft.com/office/drawing/2014/main" id="{72B58A86-8E6E-4B0D-8B20-99C39A6FEBEF}"/>
+                <a16:creationId xmlns:a16="http://schemas.microsoft.com/office/drawing/2014/main" id="{7552240C-58B1-4D9B-9280-1F261C013FDF}"/>
               </a:ext>
             </a:extLst>
           </p:cNvPr>
@@ -8601,7 +8879,7 @@
                 <a:ea typeface="Arial"/>
                 <a:cs typeface="Arial"/>
               </a:rPr>
-              <a:t>Controls needed before an MVP trial</a:t>
+              <a:t>What must change before a pilot</a:t>
             </a:r>
           </a:p>
         </p:txBody>
@@ -8611,7 +8889,7 @@
           <p:cNvPr id="6" name="Content-Placeholder-9-6">
             <a:extLst xmlns:a="http://schemas.openxmlformats.org/drawingml/2006/main">
               <a:ext uri="{FF2B5EF4-FFF2-40B4-BE49-F238E27FC236}">
-                <a16:creationId xmlns:a16="http://schemas.microsoft.com/office/drawing/2014/main" id="{88A2964F-5A1E-48FF-BA44-906BE2BA1362}"/>
+                <a16:creationId xmlns:a16="http://schemas.microsoft.com/office/drawing/2014/main" id="{DCA172F9-BB93-454C-AA2E-6FFEC644CC4B}"/>
               </a:ext>
             </a:extLst>
           </p:cNvPr>
@@ -8631,7 +8909,7 @@
         </p:spPr>
         <p:txBody>
           <a:bodyPr xmlns:a="http://schemas.openxmlformats.org/drawingml/2006/main" lIns="91440" tIns="45720" rIns="91440" bIns="45720">
-            <a:normAutofit fontScale="96063"/>
+            <a:normAutofit fontScale="89529"/>
           </a:bodyPr>
           <a:lstStyle xmlns:a="http://schemas.openxmlformats.org/drawingml/2006/main"/>
           <a:p xmlns:a="http://schemas.openxmlformats.org/drawingml/2006/main">
@@ -8658,7 +8936,7 @@
                 <a:ea typeface="Arial"/>
                 <a:cs typeface="Arial"/>
               </a:rPr>
-              <a:t>Replace source-linked shortcuts with diverse, independently annotated real campaigns.</a:t>
+              <a:t>Collect diverse real campaigns and use independent labels instead of source-linked shortcuts.</a:t>
             </a:r>
           </a:p>
         </p:txBody>
@@ -8668,7 +8946,7 @@
           <p:cNvPr id="7" name="Content-Placeholder-10-7">
             <a:extLst xmlns:a="http://schemas.openxmlformats.org/drawingml/2006/main">
               <a:ext uri="{FF2B5EF4-FFF2-40B4-BE49-F238E27FC236}">
-                <a16:creationId xmlns:a16="http://schemas.microsoft.com/office/drawing/2014/main" id="{EFEC2D60-6B84-4138-B499-47BE0CEAA6C0}"/>
+                <a16:creationId xmlns:a16="http://schemas.microsoft.com/office/drawing/2014/main" id="{8E99A607-6391-4095-A3D8-4B01BCA19807}"/>
               </a:ext>
             </a:extLst>
           </p:cNvPr>
@@ -8688,7 +8966,7 @@
         </p:spPr>
         <p:txBody>
           <a:bodyPr xmlns:a="http://schemas.openxmlformats.org/drawingml/2006/main" lIns="91440" tIns="45720" rIns="91440" bIns="45720">
-            <a:normAutofit fontScale="94802"/>
+            <a:normAutofit fontScale="96190"/>
           </a:bodyPr>
           <a:lstStyle xmlns:a="http://schemas.openxmlformats.org/drawingml/2006/main"/>
           <a:p xmlns:a="http://schemas.openxmlformats.org/drawingml/2006/main">
@@ -8715,9 +8993,9 @@
                 <a:ea typeface="Arial"/>
                 <a:cs typeface="Arial"/>
               </a:rPr>
-              <a:t>Unmeasured: end-to-end p95,
-concurrency, and MPS use.
-Retain telemetry and escalation.</a:t>
+              <a:t>Measure end-to-end p95,
+concurrency, CPU/GPU load,
+MPS acceleration, and memory.</a:t>
             </a:r>
           </a:p>
         </p:txBody>
@@ -8727,7 +9005,7 @@
           <p:cNvPr id="8" name="Content-Placeholder-11-8">
             <a:extLst xmlns:a="http://schemas.openxmlformats.org/drawingml/2006/main">
               <a:ext uri="{FF2B5EF4-FFF2-40B4-BE49-F238E27FC236}">
-                <a16:creationId xmlns:a16="http://schemas.microsoft.com/office/drawing/2014/main" id="{D333D1FD-6523-4E83-9E14-35AA3CBAF838}"/>
+                <a16:creationId xmlns:a16="http://schemas.microsoft.com/office/drawing/2014/main" id="{E26BA08C-C535-4C2F-B639-763332F61631}"/>
               </a:ext>
             </a:extLst>
           </p:cNvPr>
@@ -8774,7 +9052,7 @@
                 <a:ea typeface="Arial"/>
                 <a:cs typeface="Arial"/>
               </a:rPr>
-              <a:t>A 0.90 nonweapon FPR requires local box labels, recalibration, and no automatic detector block.</a:t>
+              <a:t>A 0.90 nonweapon FPR requires local box labels, recalibration, and no detector-only block.</a:t>
             </a:r>
           </a:p>
         </p:txBody>
@@ -8784,7 +9062,7 @@
           <p:cNvPr id="9" name="Content-Placeholder-9-9">
             <a:extLst xmlns:a="http://schemas.openxmlformats.org/drawingml/2006/main">
               <a:ext uri="{FF2B5EF4-FFF2-40B4-BE49-F238E27FC236}">
-                <a16:creationId xmlns:a16="http://schemas.microsoft.com/office/drawing/2014/main" id="{F7CE5CF1-A6B9-42FB-BA09-3180D1CCB189}"/>
+                <a16:creationId xmlns:a16="http://schemas.microsoft.com/office/drawing/2014/main" id="{B795A035-8A08-4159-8AEC-D7164356B544}"/>
               </a:ext>
             </a:extLst>
           </p:cNvPr>
@@ -8841,7 +9119,7 @@
           <p:cNvPr id="10" name="Content-Placeholder-9-10">
             <a:extLst xmlns:a="http://schemas.openxmlformats.org/drawingml/2006/main">
               <a:ext uri="{FF2B5EF4-FFF2-40B4-BE49-F238E27FC236}">
-                <a16:creationId xmlns:a16="http://schemas.microsoft.com/office/drawing/2014/main" id="{416BA693-705C-4371-A2A2-C67FC27D5F2D}"/>
+                <a16:creationId xmlns:a16="http://schemas.microsoft.com/office/drawing/2014/main" id="{624B7F04-4CAD-4281-B6D8-EA76A46B93FD}"/>
               </a:ext>
             </a:extLst>
           </p:cNvPr>
@@ -8898,7 +9176,7 @@
           <p:cNvPr id="11" name="Content-Placeholder-9-11">
             <a:extLst xmlns:a="http://schemas.openxmlformats.org/drawingml/2006/main">
               <a:ext uri="{FF2B5EF4-FFF2-40B4-BE49-F238E27FC236}">
-                <a16:creationId xmlns:a16="http://schemas.microsoft.com/office/drawing/2014/main" id="{E49EDFAC-66A2-4B16-A207-5A32D7A2E905}"/>
+                <a16:creationId xmlns:a16="http://schemas.microsoft.com/office/drawing/2014/main" id="{4E2886AA-4795-4FED-B304-EBCD067F5098}"/>
               </a:ext>
             </a:extLst>
           </p:cNvPr>
@@ -8955,7 +9233,7 @@
           <p:cNvPr id="12" name="Content-Placeholder-15-12">
             <a:extLst xmlns:a="http://schemas.openxmlformats.org/drawingml/2006/main">
               <a:ext uri="{FF2B5EF4-FFF2-40B4-BE49-F238E27FC236}">
-                <a16:creationId xmlns:a16="http://schemas.microsoft.com/office/drawing/2014/main" id="{ECCA9D32-D77F-47D1-83BB-F927EA7719ED}"/>
+                <a16:creationId xmlns:a16="http://schemas.microsoft.com/office/drawing/2014/main" id="{00C384F5-E45C-4713-BBBE-C74240699B0A}"/>
               </a:ext>
             </a:extLst>
           </p:cNvPr>
@@ -9002,7 +9280,7 @@
                 <a:ea typeface="Arial"/>
                 <a:cs typeface="Arial"/>
               </a:rPr>
-              <a:t>GO / NO-GO</a:t>
+              <a:t>THREE GAPS</a:t>
             </a:r>
           </a:p>
           <a:p xmlns:a="http://schemas.openxmlformats.org/drawingml/2006/main">
@@ -9029,7 +9307,7 @@
                 <a:ea typeface="Arial"/>
                 <a:cs typeface="Arial"/>
               </a:rPr>
-              <a:t>Current controls limit damage, but they do not remove the uncertainty created by synthetic sources, detector noise, and incomplete end-to-end latency evidence.</a:t>
+              <a:t>Before a pilot, we need to address source-biased data, noisy detections, and missing full-pipeline performance measurements.</a:t>
             </a:r>
           </a:p>
         </p:txBody>
@@ -9039,7 +9317,7 @@
           <p:cNvPr id="13" name="">
             <a:extLst xmlns:a="http://schemas.openxmlformats.org/drawingml/2006/main">
               <a:ext uri="{FF2B5EF4-FFF2-40B4-BE49-F238E27FC236}">
-                <a16:creationId xmlns:a16="http://schemas.microsoft.com/office/drawing/2014/main" id="{16555EE5-4FF4-48F8-9257-961A8D746AF8}"/>
+                <a16:creationId xmlns:a16="http://schemas.microsoft.com/office/drawing/2014/main" id="{88E7EB1C-9786-47C6-A701-66FEF4EADC09}"/>
               </a:ext>
             </a:extLst>
           </p:cNvPr>
@@ -9072,7 +9350,7 @@
           <p:cNvPr id="14" name="">
             <a:extLst xmlns:a="http://schemas.openxmlformats.org/drawingml/2006/main">
               <a:ext uri="{FF2B5EF4-FFF2-40B4-BE49-F238E27FC236}">
-                <a16:creationId xmlns:a16="http://schemas.microsoft.com/office/drawing/2014/main" id="{D0B2AB40-26B5-4E88-99FB-7F2526262476}"/>
+                <a16:creationId xmlns:a16="http://schemas.microsoft.com/office/drawing/2014/main" id="{CB3B17B9-59C0-4796-A651-5C6B541CBC8E}"/>
               </a:ext>
             </a:extLst>
           </p:cNvPr>
@@ -9128,7 +9406,7 @@
           <p:cNvPr id="15" name="">
             <a:extLst xmlns:a="http://schemas.openxmlformats.org/drawingml/2006/main">
               <a:ext uri="{FF2B5EF4-FFF2-40B4-BE49-F238E27FC236}">
-                <a16:creationId xmlns:a16="http://schemas.microsoft.com/office/drawing/2014/main" id="{E06A5A83-30E0-412C-82D7-FC7010959931}"/>
+                <a16:creationId xmlns:a16="http://schemas.microsoft.com/office/drawing/2014/main" id="{ECD09ED3-971A-4BF6-AB49-791362D3C2BF}"/>
               </a:ext>
             </a:extLst>
           </p:cNvPr>
@@ -9182,7 +9460,7 @@
     </p:spTree>
     <p:extLst>
       <p:ext uri="{BB962C8B-B14F-4D97-AF65-F5344CB8AC3E}">
-        <p14:creationId xmlns:p14="http://schemas.microsoft.com/office/powerpoint/2010/main" val="1405416972"/>
+        <p14:creationId xmlns:p14="http://schemas.microsoft.com/office/powerpoint/2010/main" val="1591119216"/>
       </p:ext>
     </p:extLst>
   </p:cSld>
@@ -9213,7 +9491,7 @@
           <p:cNvPr id="19" name="Slide-Number-Placeholder-3-2">
             <a:extLst xmlns:a="http://schemas.openxmlformats.org/drawingml/2006/main">
               <a:ext uri="{FF2B5EF4-FFF2-40B4-BE49-F238E27FC236}">
-                <a16:creationId xmlns:a16="http://schemas.microsoft.com/office/drawing/2014/main" id="{CFD57DE0-2CDC-4279-B635-9F0B3D03E12D}"/>
+                <a16:creationId xmlns:a16="http://schemas.microsoft.com/office/drawing/2014/main" id="{D059433F-93C9-4AC2-B7D1-B344872416AC}"/>
               </a:ext>
             </a:extLst>
           </p:cNvPr>
@@ -9256,7 +9534,7 @@
           <p:cNvPr id="2" name="Title-10-3">
             <a:extLst xmlns:a="http://schemas.openxmlformats.org/drawingml/2006/main">
               <a:ext uri="{FF2B5EF4-FFF2-40B4-BE49-F238E27FC236}">
-                <a16:creationId xmlns:a16="http://schemas.microsoft.com/office/drawing/2014/main" id="{979E04D4-8CFD-4110-8219-1CB3E79D15F0}"/>
+                <a16:creationId xmlns:a16="http://schemas.microsoft.com/office/drawing/2014/main" id="{8711BFCB-4042-4435-84D6-F26F23FAA8A5}"/>
               </a:ext>
             </a:extLst>
           </p:cNvPr>
@@ -9303,7 +9581,7 @@
                 <a:ea typeface="Arial"/>
                 <a:cs typeface="Arial"/>
               </a:rPr>
-              <a:t>A recommended 10-week path to MVP</a:t>
+              <a:t>What we would do next: a 10-week plan</a:t>
             </a:r>
           </a:p>
         </p:txBody>
@@ -9335,7 +9613,7 @@
           <p:cNvPr id="4" name="Google-Shape-2260-p159-5">
             <a:extLst xmlns:a="http://schemas.openxmlformats.org/drawingml/2006/main">
               <a:ext uri="{FF2B5EF4-FFF2-40B4-BE49-F238E27FC236}">
-                <a16:creationId xmlns:a16="http://schemas.microsoft.com/office/drawing/2014/main" id="{C1941A94-614F-450C-BED6-474F2D5A80E0}"/>
+                <a16:creationId xmlns:a16="http://schemas.microsoft.com/office/drawing/2014/main" id="{075A86D7-D426-438D-BFEF-9BA320944906}"/>
               </a:ext>
             </a:extLst>
           </p:cNvPr>
@@ -9362,7 +9640,7 @@
           <p:cNvPr id="5" name="Google-Shape-2261-p159-6">
             <a:extLst xmlns:a="http://schemas.openxmlformats.org/drawingml/2006/main">
               <a:ext uri="{FF2B5EF4-FFF2-40B4-BE49-F238E27FC236}">
-                <a16:creationId xmlns:a16="http://schemas.microsoft.com/office/drawing/2014/main" id="{B2236396-C62A-4C5B-B649-09026DC31A91}"/>
+                <a16:creationId xmlns:a16="http://schemas.microsoft.com/office/drawing/2014/main" id="{F0BBEA85-5663-4F7D-803D-D37588BD67CD}"/>
               </a:ext>
             </a:extLst>
           </p:cNvPr>
@@ -9389,7 +9667,7 @@
           <p:cNvPr id="6" name="Google-Shape-2262-p159-7">
             <a:extLst xmlns:a="http://schemas.openxmlformats.org/drawingml/2006/main">
               <a:ext uri="{FF2B5EF4-FFF2-40B4-BE49-F238E27FC236}">
-                <a16:creationId xmlns:a16="http://schemas.microsoft.com/office/drawing/2014/main" id="{F5AA4027-6241-4CB2-8DAA-236AA1ED5A3D}"/>
+                <a16:creationId xmlns:a16="http://schemas.microsoft.com/office/drawing/2014/main" id="{B0EF4872-3298-4CE5-AF73-DB0EAAA830C9}"/>
               </a:ext>
             </a:extLst>
           </p:cNvPr>
@@ -9416,7 +9694,7 @@
           <p:cNvPr id="7" name="Rounded-Rectangle-19-8">
             <a:extLst xmlns:a="http://schemas.openxmlformats.org/drawingml/2006/main">
               <a:ext uri="{FF2B5EF4-FFF2-40B4-BE49-F238E27FC236}">
-                <a16:creationId xmlns:a16="http://schemas.microsoft.com/office/drawing/2014/main" id="{3F9B01D7-5F2B-42CA-BA74-3CBA1BBCCEC8}"/>
+                <a16:creationId xmlns:a16="http://schemas.microsoft.com/office/drawing/2014/main" id="{BB2A7DE5-A933-42CD-986A-79A5595A1D66}"/>
               </a:ext>
             </a:extLst>
           </p:cNvPr>
@@ -9445,7 +9723,7 @@
           <p:cNvPr id="8" name="Content-Placeholder-8-9">
             <a:extLst xmlns:a="http://schemas.openxmlformats.org/drawingml/2006/main">
               <a:ext uri="{FF2B5EF4-FFF2-40B4-BE49-F238E27FC236}">
-                <a16:creationId xmlns:a16="http://schemas.microsoft.com/office/drawing/2014/main" id="{38B12070-9B3B-4F69-90CD-EED1A071F750}"/>
+                <a16:creationId xmlns:a16="http://schemas.microsoft.com/office/drawing/2014/main" id="{E3A5387A-F3E9-4827-B2EC-C61CA5E5DC39}"/>
               </a:ext>
             </a:extLst>
           </p:cNvPr>
@@ -9519,7 +9797,7 @@
                 <a:ea typeface="Arial"/>
                 <a:cs typeface="Arial"/>
               </a:rPr>
-              <a:t>Resource: data lead, policy reviewer, 2 annotators. Curate ≥1,000 real ads; lock a campaign-grouped independent holdout.</a:t>
+              <a:t>A data lead, policy reviewer, and 2 annotators curate ≥1,000 real ads and lock a campaign-grouped independent holdout.</a:t>
             </a:r>
           </a:p>
         </p:txBody>
@@ -9529,7 +9807,7 @@
           <p:cNvPr id="9" name="Rounded-Rectangle-21-10">
             <a:extLst xmlns:a="http://schemas.openxmlformats.org/drawingml/2006/main">
               <a:ext uri="{FF2B5EF4-FFF2-40B4-BE49-F238E27FC236}">
-                <a16:creationId xmlns:a16="http://schemas.microsoft.com/office/drawing/2014/main" id="{04F6D4D7-BF60-4F63-8BAF-4D5EEE9DB16C}"/>
+                <a16:creationId xmlns:a16="http://schemas.microsoft.com/office/drawing/2014/main" id="{017F1FE7-3348-44D1-AE9A-F10395F20AFB}"/>
               </a:ext>
             </a:extLst>
           </p:cNvPr>
@@ -9558,7 +9836,7 @@
           <p:cNvPr id="10" name="Content-Placeholder-8-11">
             <a:extLst xmlns:a="http://schemas.openxmlformats.org/drawingml/2006/main">
               <a:ext uri="{FF2B5EF4-FFF2-40B4-BE49-F238E27FC236}">
-                <a16:creationId xmlns:a16="http://schemas.microsoft.com/office/drawing/2014/main" id="{514025AB-34FB-464C-803D-378F3F24E9E4}"/>
+                <a16:creationId xmlns:a16="http://schemas.microsoft.com/office/drawing/2014/main" id="{1E90D100-81D2-4F84-BC4E-69EC5DA5143A}"/>
               </a:ext>
             </a:extLst>
           </p:cNvPr>
@@ -9632,7 +9910,7 @@
                 <a:ea typeface="Arial"/>
                 <a:cs typeface="Arial"/>
               </a:rPr>
-              <a:t>Resource: 1 ML engineer, reviewer, CPU/GPU test capacity. Gate: &gt;0.95 recall per restricted class and &lt;2% Safe crossings.</a:t>
+              <a:t>1 ML engineer and a reviewer tune against two gates: &gt;0.95 recall per restricted class and &lt;2% Safe crossings.</a:t>
             </a:r>
           </a:p>
         </p:txBody>
@@ -9642,7 +9920,7 @@
           <p:cNvPr id="11" name="Rounded-Rectangle-23-12">
             <a:extLst xmlns:a="http://schemas.openxmlformats.org/drawingml/2006/main">
               <a:ext uri="{FF2B5EF4-FFF2-40B4-BE49-F238E27FC236}">
-                <a16:creationId xmlns:a16="http://schemas.microsoft.com/office/drawing/2014/main" id="{73741FC4-C217-4B0B-9F52-CBB0F9E46A24}"/>
+                <a16:creationId xmlns:a16="http://schemas.microsoft.com/office/drawing/2014/main" id="{16A64825-749B-47D2-BAD3-B0FAE866CE2A}"/>
               </a:ext>
             </a:extLst>
           </p:cNvPr>
@@ -9671,7 +9949,7 @@
           <p:cNvPr id="12" name="Content-Placeholder-8-13">
             <a:extLst xmlns:a="http://schemas.openxmlformats.org/drawingml/2006/main">
               <a:ext uri="{FF2B5EF4-FFF2-40B4-BE49-F238E27FC236}">
-                <a16:creationId xmlns:a16="http://schemas.microsoft.com/office/drawing/2014/main" id="{B2D7EE3B-00D9-4BDD-B351-89401FB86189}"/>
+                <a16:creationId xmlns:a16="http://schemas.microsoft.com/office/drawing/2014/main" id="{8F0B83ED-34CB-4D27-BAE9-4F54FD601B93}"/>
               </a:ext>
             </a:extLst>
           </p:cNvPr>
@@ -9718,7 +9996,7 @@
                 <a:ea typeface="Arial"/>
                 <a:cs typeface="Arial"/>
               </a:rPr>
-              <a:t>WEEKS 7–10 · PILOT</a:t>
+              <a:t>WEEKS 7–10 · SHADOW PILOT</a:t>
             </a:r>
           </a:p>
           <a:p xmlns:a="http://schemas.openxmlformats.org/drawingml/2006/main">
@@ -9745,7 +10023,7 @@
                 <a:ea typeface="Arial"/>
                 <a:cs typeface="Arial"/>
               </a:rPr>
-              <a:t>Resource: product lead, app/MLOps engineer, reviewer rotation. Scale gate: 10 concurrent requests; measure E2E p95 and CPU/GPU/RAM.</a:t>
+              <a:t>A product lead, app/MLOps engineer, and reviewer rotation test 10 concurrent requests, end-to-end p95 latency, and resource use.</a:t>
             </a:r>
           </a:p>
         </p:txBody>
@@ -9755,7 +10033,7 @@
           <p:cNvPr id="13" name="Text-Placeholder-16-14">
             <a:extLst xmlns:a="http://schemas.openxmlformats.org/drawingml/2006/main">
               <a:ext uri="{FF2B5EF4-FFF2-40B4-BE49-F238E27FC236}">
-                <a16:creationId xmlns:a16="http://schemas.microsoft.com/office/drawing/2014/main" id="{9EBA49BF-A7C6-4CB4-AF95-DE5DDA24F611}"/>
+                <a16:creationId xmlns:a16="http://schemas.microsoft.com/office/drawing/2014/main" id="{CAE9421F-7ABC-472A-80C8-769A5B3B8689}"/>
               </a:ext>
             </a:extLst>
           </p:cNvPr>
@@ -9812,7 +10090,7 @@
           <p:cNvPr id="14" name="Text-Placeholder-16-15">
             <a:extLst xmlns:a="http://schemas.openxmlformats.org/drawingml/2006/main">
               <a:ext uri="{FF2B5EF4-FFF2-40B4-BE49-F238E27FC236}">
-                <a16:creationId xmlns:a16="http://schemas.microsoft.com/office/drawing/2014/main" id="{53DD1BB4-AA43-4976-AB6D-37E35E94D4F4}"/>
+                <a16:creationId xmlns:a16="http://schemas.microsoft.com/office/drawing/2014/main" id="{7619DD49-346B-4AEC-AD31-B9D54735B4A6}"/>
               </a:ext>
             </a:extLst>
           </p:cNvPr>
@@ -9869,7 +10147,7 @@
           <p:cNvPr id="15" name="Text-Placeholder-16-16">
             <a:extLst xmlns:a="http://schemas.openxmlformats.org/drawingml/2006/main">
               <a:ext uri="{FF2B5EF4-FFF2-40B4-BE49-F238E27FC236}">
-                <a16:creationId xmlns:a16="http://schemas.microsoft.com/office/drawing/2014/main" id="{5E9076B7-26EF-461D-957D-C9124D847A31}"/>
+                <a16:creationId xmlns:a16="http://schemas.microsoft.com/office/drawing/2014/main" id="{7F4B07AD-C787-4D95-8316-61B554F46623}"/>
               </a:ext>
             </a:extLst>
           </p:cNvPr>
@@ -9926,7 +10204,7 @@
           <p:cNvPr id="16" name="">
             <a:extLst xmlns:a="http://schemas.openxmlformats.org/drawingml/2006/main">
               <a:ext uri="{FF2B5EF4-FFF2-40B4-BE49-F238E27FC236}">
-                <a16:creationId xmlns:a16="http://schemas.microsoft.com/office/drawing/2014/main" id="{58DAFED1-2532-40B7-9776-047A9FD20625}"/>
+                <a16:creationId xmlns:a16="http://schemas.microsoft.com/office/drawing/2014/main" id="{E63E3E57-669A-4B9D-AEF1-7ACCD5C6DD66}"/>
               </a:ext>
             </a:extLst>
           </p:cNvPr>
@@ -9959,7 +10237,7 @@
           <p:cNvPr id="17" name="">
             <a:extLst xmlns:a="http://schemas.openxmlformats.org/drawingml/2006/main">
               <a:ext uri="{FF2B5EF4-FFF2-40B4-BE49-F238E27FC236}">
-                <a16:creationId xmlns:a16="http://schemas.microsoft.com/office/drawing/2014/main" id="{0359F07F-4BBC-4C96-9E9A-765323AB78C5}"/>
+                <a16:creationId xmlns:a16="http://schemas.microsoft.com/office/drawing/2014/main" id="{F39E6898-7C06-4806-B3C3-71659633095C}"/>
               </a:ext>
             </a:extLst>
           </p:cNvPr>
@@ -10015,7 +10293,7 @@
           <p:cNvPr id="18" name="">
             <a:extLst xmlns:a="http://schemas.openxmlformats.org/drawingml/2006/main">
               <a:ext uri="{FF2B5EF4-FFF2-40B4-BE49-F238E27FC236}">
-                <a16:creationId xmlns:a16="http://schemas.microsoft.com/office/drawing/2014/main" id="{D182621A-C044-4F23-B253-983211FF8EFB}"/>
+                <a16:creationId xmlns:a16="http://schemas.microsoft.com/office/drawing/2014/main" id="{E2A1A5F4-5804-4EBA-98E6-DDCA064CBEBB}"/>
               </a:ext>
             </a:extLst>
           </p:cNvPr>
@@ -10069,7 +10347,7 @@
     </p:spTree>
     <p:extLst>
       <p:ext uri="{BB962C8B-B14F-4D97-AF65-F5344CB8AC3E}">
-        <p14:creationId xmlns:p14="http://schemas.microsoft.com/office/powerpoint/2010/main" val="873006293"/>
+        <p14:creationId xmlns:p14="http://schemas.microsoft.com/office/powerpoint/2010/main" val="1993691787"/>
       </p:ext>
     </p:extLst>
   </p:cSld>
@@ -10100,7 +10378,7 @@
           <p:cNvPr id="13" name="Google-Shape-532-p58-2">
             <a:extLst xmlns:a="http://schemas.openxmlformats.org/drawingml/2006/main">
               <a:ext uri="{FF2B5EF4-FFF2-40B4-BE49-F238E27FC236}">
-                <a16:creationId xmlns:a16="http://schemas.microsoft.com/office/drawing/2014/main" id="{1E1DFBFF-5D5F-497C-B9B7-57AA6FEA71C5}"/>
+                <a16:creationId xmlns:a16="http://schemas.microsoft.com/office/drawing/2014/main" id="{A89C8B22-465D-4B49-90F7-3A5FE97DA91F}"/>
               </a:ext>
             </a:extLst>
           </p:cNvPr>
@@ -10145,7 +10423,7 @@
           <p:cNvPr id="2" name="Google-Shape-533-p58-3">
             <a:extLst xmlns:a="http://schemas.openxmlformats.org/drawingml/2006/main">
               <a:ext uri="{FF2B5EF4-FFF2-40B4-BE49-F238E27FC236}">
-                <a16:creationId xmlns:a16="http://schemas.microsoft.com/office/drawing/2014/main" id="{21296441-F2AE-4EC8-8396-098CB90DC39E}"/>
+                <a16:creationId xmlns:a16="http://schemas.microsoft.com/office/drawing/2014/main" id="{26FD5E02-2EDF-408D-956A-95B0F459F742}"/>
               </a:ext>
             </a:extLst>
           </p:cNvPr>
@@ -10192,8 +10470,8 @@
                 <a:ea typeface="Arial"/>
                 <a:cs typeface="Arial"/>
               </a:rPr>
-              <a:t>Four presenters,
-one evidence chain</a:t>
+              <a:t>Team and
+presentation plan</a:t>
             </a:r>
           </a:p>
         </p:txBody>
@@ -10203,7 +10481,7 @@
           <p:cNvPr id="3" name="Rounded-Rectangle-6-4">
             <a:extLst xmlns:a="http://schemas.openxmlformats.org/drawingml/2006/main">
               <a:ext uri="{FF2B5EF4-FFF2-40B4-BE49-F238E27FC236}">
-                <a16:creationId xmlns:a16="http://schemas.microsoft.com/office/drawing/2014/main" id="{D56A62E6-1197-4452-ABE9-80936823C3D5}"/>
+                <a16:creationId xmlns:a16="http://schemas.microsoft.com/office/drawing/2014/main" id="{00586AF2-D0F7-4D44-BC63-FAC16001E9B1}"/>
               </a:ext>
             </a:extLst>
           </p:cNvPr>
@@ -10232,7 +10510,7 @@
           <p:cNvPr id="4" name="Content-Placeholder-10-5">
             <a:extLst xmlns:a="http://schemas.openxmlformats.org/drawingml/2006/main">
               <a:ext uri="{FF2B5EF4-FFF2-40B4-BE49-F238E27FC236}">
-                <a16:creationId xmlns:a16="http://schemas.microsoft.com/office/drawing/2014/main" id="{4237A103-4DEF-411F-9D5A-F4A945C5F507}"/>
+                <a16:creationId xmlns:a16="http://schemas.microsoft.com/office/drawing/2014/main" id="{303939A1-6859-4EE5-919F-627C96081BD8}"/>
               </a:ext>
             </a:extLst>
           </p:cNvPr>
@@ -10306,7 +10584,7 @@
                 <a:ea typeface="Arial"/>
                 <a:cs typeface="Arial"/>
               </a:rPr>
-              <a:t>Team · data profile · EDA · class and failure analysis</a:t>
+              <a:t>Team · data · EDA · error analysis</a:t>
             </a:r>
           </a:p>
         </p:txBody>
@@ -10316,7 +10594,7 @@
           <p:cNvPr id="5" name="Rounded-Rectangle-8-6">
             <a:extLst xmlns:a="http://schemas.openxmlformats.org/drawingml/2006/main">
               <a:ext uri="{FF2B5EF4-FFF2-40B4-BE49-F238E27FC236}">
-                <a16:creationId xmlns:a16="http://schemas.microsoft.com/office/drawing/2014/main" id="{11557B5C-6262-461B-AB7E-B489C2FFFEA5}"/>
+                <a16:creationId xmlns:a16="http://schemas.microsoft.com/office/drawing/2014/main" id="{91884788-B953-457D-B9ED-43527F6ABBC1}"/>
               </a:ext>
             </a:extLst>
           </p:cNvPr>
@@ -10345,7 +10623,7 @@
           <p:cNvPr id="6" name="Content-Placeholder-10-7">
             <a:extLst xmlns:a="http://schemas.openxmlformats.org/drawingml/2006/main">
               <a:ext uri="{FF2B5EF4-FFF2-40B4-BE49-F238E27FC236}">
-                <a16:creationId xmlns:a16="http://schemas.microsoft.com/office/drawing/2014/main" id="{7A8CC163-A8B5-4422-9F94-914DC71D011E}"/>
+                <a16:creationId xmlns:a16="http://schemas.microsoft.com/office/drawing/2014/main" id="{4AD2B4B5-9CE4-4C47-AAC0-74ACE46BD31E}"/>
               </a:ext>
             </a:extLst>
           </p:cNvPr>
@@ -10419,7 +10697,7 @@
                 <a:ea typeface="Arial"/>
                 <a:cs typeface="Arial"/>
               </a:rPr>
-              <a:t>Executive summary · problem · formal results · MVP gate</a:t>
+              <a:t>Opening · problem · formal results · recommendation</a:t>
             </a:r>
           </a:p>
         </p:txBody>
@@ -10429,7 +10707,7 @@
           <p:cNvPr id="7" name="Rounded-Rectangle-1-8">
             <a:extLst xmlns:a="http://schemas.openxmlformats.org/drawingml/2006/main">
               <a:ext uri="{FF2B5EF4-FFF2-40B4-BE49-F238E27FC236}">
-                <a16:creationId xmlns:a16="http://schemas.microsoft.com/office/drawing/2014/main" id="{50667E81-596C-4007-9D09-6277EB841D77}"/>
+                <a16:creationId xmlns:a16="http://schemas.microsoft.com/office/drawing/2014/main" id="{D181EF54-8BE2-4877-94A8-00BADD9374B4}"/>
               </a:ext>
             </a:extLst>
           </p:cNvPr>
@@ -10458,7 +10736,7 @@
           <p:cNvPr id="8" name="Content-Placeholder-10-9">
             <a:extLst xmlns:a="http://schemas.openxmlformats.org/drawingml/2006/main">
               <a:ext uri="{FF2B5EF4-FFF2-40B4-BE49-F238E27FC236}">
-                <a16:creationId xmlns:a16="http://schemas.microsoft.com/office/drawing/2014/main" id="{631FE749-1DA6-453F-8840-24F072571D49}"/>
+                <a16:creationId xmlns:a16="http://schemas.microsoft.com/office/drawing/2014/main" id="{325D0B16-9A58-4BCB-866E-B4802577AEB7}"/>
               </a:ext>
             </a:extLst>
           </p:cNvPr>
@@ -10532,7 +10810,7 @@
                 <a:ea typeface="Arial"/>
                 <a:cs typeface="Arial"/>
               </a:rPr>
-              <a:t>Policy · architecture · audit · risks | method · literature · demo</a:t>
+              <a:t>Policy · architecture · external check · risks | method · research · app</a:t>
             </a:r>
           </a:p>
         </p:txBody>
@@ -10549,7 +10827,7 @@
         </p:xfrm>
         <a:graphic xmlns:a="http://schemas.openxmlformats.org/drawingml/2006/main">
           <a:graphicData uri="http://schemas.openxmlformats.org/drawingml/2006/chart">
-            <c:chart xmlns:r="http://schemas.openxmlformats.org/officeDocument/2006/relationships" xmlns:c="http://schemas.openxmlformats.org/drawingml/2006/chart" r:id="Ra2c0eb5ca31d4a5f"/>
+            <c:chart xmlns:r="http://schemas.openxmlformats.org/officeDocument/2006/relationships" xmlns:c="http://schemas.openxmlformats.org/drawingml/2006/chart" r:id="Rb26e8869dee74824"/>
           </a:graphicData>
         </a:graphic>
       </p:graphicFrame>
@@ -10558,7 +10836,7 @@
           <p:cNvPr id="10" name="">
             <a:extLst xmlns:a="http://schemas.openxmlformats.org/drawingml/2006/main">
               <a:ext uri="{FF2B5EF4-FFF2-40B4-BE49-F238E27FC236}">
-                <a16:creationId xmlns:a16="http://schemas.microsoft.com/office/drawing/2014/main" id="{305BA3AC-2EF5-4C39-B723-E80598C73419}"/>
+                <a16:creationId xmlns:a16="http://schemas.microsoft.com/office/drawing/2014/main" id="{2E57EA05-B212-4BF8-929A-9C623B5E21C1}"/>
               </a:ext>
             </a:extLst>
           </p:cNvPr>
@@ -10591,7 +10869,7 @@
           <p:cNvPr id="11" name="">
             <a:extLst xmlns:a="http://schemas.openxmlformats.org/drawingml/2006/main">
               <a:ext uri="{FF2B5EF4-FFF2-40B4-BE49-F238E27FC236}">
-                <a16:creationId xmlns:a16="http://schemas.microsoft.com/office/drawing/2014/main" id="{64C66347-8849-47A5-B7DD-EFC5C918B17D}"/>
+                <a16:creationId xmlns:a16="http://schemas.microsoft.com/office/drawing/2014/main" id="{1BAB18F4-F520-4052-BD98-79537BBD86B1}"/>
               </a:ext>
             </a:extLst>
           </p:cNvPr>
@@ -10647,7 +10925,7 @@
           <p:cNvPr id="12" name="">
             <a:extLst xmlns:a="http://schemas.openxmlformats.org/drawingml/2006/main">
               <a:ext uri="{FF2B5EF4-FFF2-40B4-BE49-F238E27FC236}">
-                <a16:creationId xmlns:a16="http://schemas.microsoft.com/office/drawing/2014/main" id="{2CB06EE4-7E81-4832-A54A-642E015456B3}"/>
+                <a16:creationId xmlns:a16="http://schemas.microsoft.com/office/drawing/2014/main" id="{8C9FFA04-991E-49CB-9A8B-7D9565FDDE00}"/>
               </a:ext>
             </a:extLst>
           </p:cNvPr>
@@ -10701,7 +10979,7 @@
     </p:spTree>
     <p:extLst>
       <p:ext uri="{BB962C8B-B14F-4D97-AF65-F5344CB8AC3E}">
-        <p14:creationId xmlns:p14="http://schemas.microsoft.com/office/powerpoint/2010/main" val="1370714026"/>
+        <p14:creationId xmlns:p14="http://schemas.microsoft.com/office/powerpoint/2010/main" val="77065881"/>
       </p:ext>
     </p:extLst>
   </p:cSld>
@@ -10732,7 +11010,7 @@
           <p:cNvPr id="16" name="Rounded-Rectangle-5-1">
             <a:extLst xmlns:a="http://schemas.openxmlformats.org/drawingml/2006/main">
               <a:ext uri="{FF2B5EF4-FFF2-40B4-BE49-F238E27FC236}">
-                <a16:creationId xmlns:a16="http://schemas.microsoft.com/office/drawing/2014/main" id="{A5F8E3FF-B9F0-4F1A-9DEA-C3083A7DC667}"/>
+                <a16:creationId xmlns:a16="http://schemas.microsoft.com/office/drawing/2014/main" id="{DAE42554-5A0B-4749-A04C-EB0A04C10A84}"/>
               </a:ext>
             </a:extLst>
           </p:cNvPr>
@@ -10761,7 +11039,7 @@
           <p:cNvPr id="2" name="Rounded-Rectangle-6-2">
             <a:extLst xmlns:a="http://schemas.openxmlformats.org/drawingml/2006/main">
               <a:ext uri="{FF2B5EF4-FFF2-40B4-BE49-F238E27FC236}">
-                <a16:creationId xmlns:a16="http://schemas.microsoft.com/office/drawing/2014/main" id="{EE718699-7682-4B62-9064-544B3E5B1146}"/>
+                <a16:creationId xmlns:a16="http://schemas.microsoft.com/office/drawing/2014/main" id="{6A70D334-66F0-4E13-9B06-C2F012A4C00A}"/>
               </a:ext>
             </a:extLst>
           </p:cNvPr>
@@ -10790,7 +11068,7 @@
           <p:cNvPr id="3" name="Rounded-Rectangle-7-3">
             <a:extLst xmlns:a="http://schemas.openxmlformats.org/drawingml/2006/main">
               <a:ext uri="{FF2B5EF4-FFF2-40B4-BE49-F238E27FC236}">
-                <a16:creationId xmlns:a16="http://schemas.microsoft.com/office/drawing/2014/main" id="{9ED1763A-5085-4EED-A8EA-8DE7DAC65BA2}"/>
+                <a16:creationId xmlns:a16="http://schemas.microsoft.com/office/drawing/2014/main" id="{7E2FB48F-3354-47BA-ABDC-F3E15577B928}"/>
               </a:ext>
             </a:extLst>
           </p:cNvPr>
@@ -10819,7 +11097,7 @@
           <p:cNvPr id="4" name="Slide-Number-Placeholder-1-4">
             <a:extLst xmlns:a="http://schemas.openxmlformats.org/drawingml/2006/main">
               <a:ext uri="{FF2B5EF4-FFF2-40B4-BE49-F238E27FC236}">
-                <a16:creationId xmlns:a16="http://schemas.microsoft.com/office/drawing/2014/main" id="{05AC585C-1D8E-4FED-8E0D-6330D3D127AA}"/>
+                <a16:creationId xmlns:a16="http://schemas.microsoft.com/office/drawing/2014/main" id="{175EAE2D-8A51-4BC0-83ED-58744118E81F}"/>
               </a:ext>
             </a:extLst>
           </p:cNvPr>
@@ -10862,7 +11140,7 @@
           <p:cNvPr id="5" name="Title-2-5">
             <a:extLst xmlns:a="http://schemas.openxmlformats.org/drawingml/2006/main">
               <a:ext uri="{FF2B5EF4-FFF2-40B4-BE49-F238E27FC236}">
-                <a16:creationId xmlns:a16="http://schemas.microsoft.com/office/drawing/2014/main" id="{F367B797-B3FE-4118-9173-294024B8CE47}"/>
+                <a16:creationId xmlns:a16="http://schemas.microsoft.com/office/drawing/2014/main" id="{31E37B2F-0E9B-4F8A-B4AA-BF2B868C8896}"/>
               </a:ext>
             </a:extLst>
           </p:cNvPr>
@@ -10901,15 +11179,15 @@
               </a:defRPr>
             </a:pPr>
             <a:r>
-              <a:rPr sz="3600">
-                <a:solidFill>
-                  <a:srgbClr val="000000"/>
-                </a:solidFill>
-                <a:latin typeface="Arial"/>
-                <a:ea typeface="Arial"/>
-                <a:cs typeface="Arial"/>
-              </a:rPr>
-              <a:t>Manual review fails on ambiguous creatives</a:t>
+              <a:rPr sz="3450">
+                <a:solidFill>
+                  <a:srgbClr val="000000"/>
+                </a:solidFill>
+                <a:latin typeface="Arial"/>
+                <a:ea typeface="Arial"/>
+                <a:cs typeface="Arial"/>
+              </a:rPr>
+              <a:t>Ambiguous ads are hard to review consistently</a:t>
             </a:r>
           </a:p>
         </p:txBody>
@@ -10919,7 +11197,7 @@
           <p:cNvPr id="6" name="Content-Placeholder-9-6">
             <a:extLst xmlns:a="http://schemas.openxmlformats.org/drawingml/2006/main">
               <a:ext uri="{FF2B5EF4-FFF2-40B4-BE49-F238E27FC236}">
-                <a16:creationId xmlns:a16="http://schemas.microsoft.com/office/drawing/2014/main" id="{0CBF4809-2C42-40C1-9049-4BC483474E03}"/>
+                <a16:creationId xmlns:a16="http://schemas.microsoft.com/office/drawing/2014/main" id="{9B5523F7-55F2-44AC-9356-1303043D7F2D}"/>
               </a:ext>
             </a:extLst>
           </p:cNvPr>
@@ -10939,7 +11217,7 @@
         </p:spPr>
         <p:txBody>
           <a:bodyPr xmlns:a="http://schemas.openxmlformats.org/drawingml/2006/main" lIns="91440" tIns="45720" rIns="91440" bIns="45720">
-            <a:normAutofit fontScale="99795"/>
+            <a:normAutofit fontScale="100000"/>
           </a:bodyPr>
           <a:lstStyle xmlns:a="http://schemas.openxmlformats.org/drawingml/2006/main"/>
           <a:p xmlns:a="http://schemas.openxmlformats.org/drawingml/2006/main">
@@ -10966,7 +11244,7 @@
                 <a:ea typeface="Arial"/>
                 <a:cs typeface="Arial"/>
               </a:rPr>
-              <a:t>Prioritize risky creatives before they reach broad distribution.</a:t>
+              <a:t>Move likely high-risk images to the front of the queue.</a:t>
             </a:r>
           </a:p>
         </p:txBody>
@@ -10976,7 +11254,7 @@
           <p:cNvPr id="7" name="Content-Placeholder-10-7">
             <a:extLst xmlns:a="http://schemas.openxmlformats.org/drawingml/2006/main">
               <a:ext uri="{FF2B5EF4-FFF2-40B4-BE49-F238E27FC236}">
-                <a16:creationId xmlns:a16="http://schemas.microsoft.com/office/drawing/2014/main" id="{E7992A8A-4DA2-4CD4-8E7F-D677DF7C4C41}"/>
+                <a16:creationId xmlns:a16="http://schemas.microsoft.com/office/drawing/2014/main" id="{D0C803A0-5442-4A40-BA1E-978064B973E3}"/>
               </a:ext>
             </a:extLst>
           </p:cNvPr>
@@ -11023,7 +11301,7 @@
                 <a:ea typeface="Arial"/>
                 <a:cs typeface="Arial"/>
               </a:rPr>
-              <a:t>Escalate questions that pixels alone cannot answer.</a:t>
+              <a:t>Send questions that pixels cannot answer to a reviewer.</a:t>
             </a:r>
           </a:p>
         </p:txBody>
@@ -11033,7 +11311,7 @@
           <p:cNvPr id="8" name="Content-Placeholder-11-8">
             <a:extLst xmlns:a="http://schemas.openxmlformats.org/drawingml/2006/main">
               <a:ext uri="{FF2B5EF4-FFF2-40B4-BE49-F238E27FC236}">
-                <a16:creationId xmlns:a16="http://schemas.microsoft.com/office/drawing/2014/main" id="{D506DF3D-C7D1-4DB1-9FBF-E2A760C2C76A}"/>
+                <a16:creationId xmlns:a16="http://schemas.microsoft.com/office/drawing/2014/main" id="{F629701F-77D7-4AD0-B2A6-1EBDA276E1C3}"/>
               </a:ext>
             </a:extLst>
           </p:cNvPr>
@@ -11080,7 +11358,7 @@
                 <a:ea typeface="Arial"/>
                 <a:cs typeface="Arial"/>
               </a:rPr>
-              <a:t>Apply the same evidence path to every uploaded image.</a:t>
+              <a:t>Apply the same first-pass review to every image.</a:t>
             </a:r>
           </a:p>
         </p:txBody>
@@ -11090,7 +11368,7 @@
           <p:cNvPr id="9" name="Content-Placeholder-9-9">
             <a:extLst xmlns:a="http://schemas.openxmlformats.org/drawingml/2006/main">
               <a:ext uri="{FF2B5EF4-FFF2-40B4-BE49-F238E27FC236}">
-                <a16:creationId xmlns:a16="http://schemas.microsoft.com/office/drawing/2014/main" id="{3669736E-C90C-40EF-89E4-2636F38AE310}"/>
+                <a16:creationId xmlns:a16="http://schemas.microsoft.com/office/drawing/2014/main" id="{BCFC6A8B-D8FF-4E8B-B399-BDA10FE88483}"/>
               </a:ext>
             </a:extLst>
           </p:cNvPr>
@@ -11129,7 +11407,7 @@
               </a:defRPr>
             </a:pPr>
             <a:r>
-              <a:rPr sz="3150" b="1">
+              <a:rPr sz="3000" b="1">
                 <a:solidFill>
                   <a:srgbClr val="3D8DFF"/>
                 </a:solidFill>
@@ -11137,7 +11415,7 @@
                 <a:ea typeface="Arial"/>
                 <a:cs typeface="Arial"/>
               </a:rPr>
-              <a:t>SPEED</a:t>
+              <a:t>PRIORITY</a:t>
             </a:r>
           </a:p>
         </p:txBody>
@@ -11147,7 +11425,7 @@
           <p:cNvPr id="10" name="Content-Placeholder-9-10">
             <a:extLst xmlns:a="http://schemas.openxmlformats.org/drawingml/2006/main">
               <a:ext uri="{FF2B5EF4-FFF2-40B4-BE49-F238E27FC236}">
-                <a16:creationId xmlns:a16="http://schemas.microsoft.com/office/drawing/2014/main" id="{6B8B7E2A-5BC6-4FA5-91AE-2AFEA64C8653}"/>
+                <a16:creationId xmlns:a16="http://schemas.microsoft.com/office/drawing/2014/main" id="{B72BF75E-5D4D-40D0-9B1F-46982A13FACA}"/>
               </a:ext>
             </a:extLst>
           </p:cNvPr>
@@ -11204,7 +11482,7 @@
           <p:cNvPr id="11" name="Content-Placeholder-9-11">
             <a:extLst xmlns:a="http://schemas.openxmlformats.org/drawingml/2006/main">
               <a:ext uri="{FF2B5EF4-FFF2-40B4-BE49-F238E27FC236}">
-                <a16:creationId xmlns:a16="http://schemas.microsoft.com/office/drawing/2014/main" id="{864FB5ED-4312-4BA4-B0CE-8FA3E287298C}"/>
+                <a16:creationId xmlns:a16="http://schemas.microsoft.com/office/drawing/2014/main" id="{DA697907-FB72-4382-8B6A-38E1C3011D09}"/>
               </a:ext>
             </a:extLst>
           </p:cNvPr>
@@ -11261,7 +11539,7 @@
           <p:cNvPr id="12" name="Content-Placeholder-15-12">
             <a:extLst xmlns:a="http://schemas.openxmlformats.org/drawingml/2006/main">
               <a:ext uri="{FF2B5EF4-FFF2-40B4-BE49-F238E27FC236}">
-                <a16:creationId xmlns:a16="http://schemas.microsoft.com/office/drawing/2014/main" id="{E5F75979-D15B-41A5-AF8C-D84C4BB5592A}"/>
+                <a16:creationId xmlns:a16="http://schemas.microsoft.com/office/drawing/2014/main" id="{BF978855-255F-4564-B551-1D7FF9670A17}"/>
               </a:ext>
             </a:extLst>
           </p:cNvPr>
@@ -11335,7 +11613,7 @@
                 <a:ea typeface="Arial"/>
                 <a:cs typeface="Arial"/>
               </a:rPr>
-              <a:t>An ad image can contain obvious objects, subtle text, or misleading context. A review queue needs fast, consistent triage while preserving a human gate for uncertain cases.</a:t>
+              <a:t>An image may contain an obvious object, small text, or context that is easy to miss. Our prototype helps reviewers sort cases consistently and sends uncertain cases to a person.</a:t>
             </a:r>
           </a:p>
         </p:txBody>
@@ -11345,7 +11623,7 @@
           <p:cNvPr id="13" name="">
             <a:extLst xmlns:a="http://schemas.openxmlformats.org/drawingml/2006/main">
               <a:ext uri="{FF2B5EF4-FFF2-40B4-BE49-F238E27FC236}">
-                <a16:creationId xmlns:a16="http://schemas.microsoft.com/office/drawing/2014/main" id="{F5061AC9-06EA-414A-B391-E5A30FF4AC09}"/>
+                <a16:creationId xmlns:a16="http://schemas.microsoft.com/office/drawing/2014/main" id="{9E730BE5-3182-4F7C-8139-CED2A38E13A3}"/>
               </a:ext>
             </a:extLst>
           </p:cNvPr>
@@ -11378,7 +11656,7 @@
           <p:cNvPr id="14" name="">
             <a:extLst xmlns:a="http://schemas.openxmlformats.org/drawingml/2006/main">
               <a:ext uri="{FF2B5EF4-FFF2-40B4-BE49-F238E27FC236}">
-                <a16:creationId xmlns:a16="http://schemas.microsoft.com/office/drawing/2014/main" id="{B448D4A8-6996-4613-B85F-B9654236C6F1}"/>
+                <a16:creationId xmlns:a16="http://schemas.microsoft.com/office/drawing/2014/main" id="{784B9FE4-DA55-48A8-9254-BC8011BCBCE9}"/>
               </a:ext>
             </a:extLst>
           </p:cNvPr>
@@ -11434,7 +11712,7 @@
           <p:cNvPr id="15" name="">
             <a:extLst xmlns:a="http://schemas.openxmlformats.org/drawingml/2006/main">
               <a:ext uri="{FF2B5EF4-FFF2-40B4-BE49-F238E27FC236}">
-                <a16:creationId xmlns:a16="http://schemas.microsoft.com/office/drawing/2014/main" id="{9DCAC392-0B84-4F3E-AEC8-312090C63998}"/>
+                <a16:creationId xmlns:a16="http://schemas.microsoft.com/office/drawing/2014/main" id="{89CFF82A-262B-4E60-BCFC-07A75BAA46AC}"/>
               </a:ext>
             </a:extLst>
           </p:cNvPr>
@@ -11488,7 +11766,7 @@
     </p:spTree>
     <p:extLst>
       <p:ext uri="{BB962C8B-B14F-4D97-AF65-F5344CB8AC3E}">
-        <p14:creationId xmlns:p14="http://schemas.microsoft.com/office/powerpoint/2010/main" val="2035231461"/>
+        <p14:creationId xmlns:p14="http://schemas.microsoft.com/office/powerpoint/2010/main" val="2079465468"/>
       </p:ext>
     </p:extLst>
   </p:cSld>
@@ -11519,7 +11797,7 @@
           <p:cNvPr id="19" name="Slide-Number-Placeholder-3-2">
             <a:extLst xmlns:a="http://schemas.openxmlformats.org/drawingml/2006/main">
               <a:ext uri="{FF2B5EF4-FFF2-40B4-BE49-F238E27FC236}">
-                <a16:creationId xmlns:a16="http://schemas.microsoft.com/office/drawing/2014/main" id="{D50AF337-1C1A-4B24-B411-9764B70A4182}"/>
+                <a16:creationId xmlns:a16="http://schemas.microsoft.com/office/drawing/2014/main" id="{5D54924A-73A9-4B76-A4C4-F5ADCA285A02}"/>
               </a:ext>
             </a:extLst>
           </p:cNvPr>
@@ -11562,7 +11840,7 @@
           <p:cNvPr id="2" name="Title-10-3">
             <a:extLst xmlns:a="http://schemas.openxmlformats.org/drawingml/2006/main">
               <a:ext uri="{FF2B5EF4-FFF2-40B4-BE49-F238E27FC236}">
-                <a16:creationId xmlns:a16="http://schemas.microsoft.com/office/drawing/2014/main" id="{1D554B22-549D-4A86-880F-475350733B12}"/>
+                <a16:creationId xmlns:a16="http://schemas.microsoft.com/office/drawing/2014/main" id="{5D49B424-2704-4404-9D8E-D8F1B6CD85F4}"/>
               </a:ext>
             </a:extLst>
           </p:cNvPr>
@@ -11641,7 +11919,7 @@
           <p:cNvPr id="4" name="Google-Shape-2260-p159-5">
             <a:extLst xmlns:a="http://schemas.openxmlformats.org/drawingml/2006/main">
               <a:ext uri="{FF2B5EF4-FFF2-40B4-BE49-F238E27FC236}">
-                <a16:creationId xmlns:a16="http://schemas.microsoft.com/office/drawing/2014/main" id="{80FED5AD-425A-4EC5-852B-2767BDAFD25C}"/>
+                <a16:creationId xmlns:a16="http://schemas.microsoft.com/office/drawing/2014/main" id="{F4CE9FBD-C396-4862-ACEC-4086A1FAC97A}"/>
               </a:ext>
             </a:extLst>
           </p:cNvPr>
@@ -11668,7 +11946,7 @@
           <p:cNvPr id="5" name="Google-Shape-2261-p159-6">
             <a:extLst xmlns:a="http://schemas.openxmlformats.org/drawingml/2006/main">
               <a:ext uri="{FF2B5EF4-FFF2-40B4-BE49-F238E27FC236}">
-                <a16:creationId xmlns:a16="http://schemas.microsoft.com/office/drawing/2014/main" id="{BFAC1385-14FB-4E58-B5F4-3E524A2BE593}"/>
+                <a16:creationId xmlns:a16="http://schemas.microsoft.com/office/drawing/2014/main" id="{FF9D494D-948F-45EA-938F-BD6933797213}"/>
               </a:ext>
             </a:extLst>
           </p:cNvPr>
@@ -11695,7 +11973,7 @@
           <p:cNvPr id="6" name="Google-Shape-2262-p159-7">
             <a:extLst xmlns:a="http://schemas.openxmlformats.org/drawingml/2006/main">
               <a:ext uri="{FF2B5EF4-FFF2-40B4-BE49-F238E27FC236}">
-                <a16:creationId xmlns:a16="http://schemas.microsoft.com/office/drawing/2014/main" id="{60452A17-AF1D-4373-B4FE-A3038528AE84}"/>
+                <a16:creationId xmlns:a16="http://schemas.microsoft.com/office/drawing/2014/main" id="{F75DEECE-1B5C-477D-9253-3200F67ED641}"/>
               </a:ext>
             </a:extLst>
           </p:cNvPr>
@@ -11722,7 +12000,7 @@
           <p:cNvPr id="7" name="Rounded-Rectangle-19-8">
             <a:extLst xmlns:a="http://schemas.openxmlformats.org/drawingml/2006/main">
               <a:ext uri="{FF2B5EF4-FFF2-40B4-BE49-F238E27FC236}">
-                <a16:creationId xmlns:a16="http://schemas.microsoft.com/office/drawing/2014/main" id="{F7CF8366-A2D1-4068-A768-4A0D822F4378}"/>
+                <a16:creationId xmlns:a16="http://schemas.microsoft.com/office/drawing/2014/main" id="{07419737-A807-4923-97EF-DC637F7DBA37}"/>
               </a:ext>
             </a:extLst>
           </p:cNvPr>
@@ -11751,7 +12029,7 @@
           <p:cNvPr id="8" name="Content-Placeholder-8-9">
             <a:extLst xmlns:a="http://schemas.openxmlformats.org/drawingml/2006/main">
               <a:ext uri="{FF2B5EF4-FFF2-40B4-BE49-F238E27FC236}">
-                <a16:creationId xmlns:a16="http://schemas.microsoft.com/office/drawing/2014/main" id="{97575B20-A755-4290-A446-BAB8A22957D7}"/>
+                <a16:creationId xmlns:a16="http://schemas.microsoft.com/office/drawing/2014/main" id="{C348D9C5-5425-4F5B-96C6-F269B36AB1AB}"/>
               </a:ext>
             </a:extLst>
           </p:cNvPr>
@@ -11835,7 +12113,7 @@
           <p:cNvPr id="9" name="Rounded-Rectangle-21-10">
             <a:extLst xmlns:a="http://schemas.openxmlformats.org/drawingml/2006/main">
               <a:ext uri="{FF2B5EF4-FFF2-40B4-BE49-F238E27FC236}">
-                <a16:creationId xmlns:a16="http://schemas.microsoft.com/office/drawing/2014/main" id="{AA5EF935-9830-4E10-8A9D-E848BACA1858}"/>
+                <a16:creationId xmlns:a16="http://schemas.microsoft.com/office/drawing/2014/main" id="{998D251E-51B5-47BD-BD68-3ADE8E2AC807}"/>
               </a:ext>
             </a:extLst>
           </p:cNvPr>
@@ -11864,7 +12142,7 @@
           <p:cNvPr id="10" name="Content-Placeholder-8-11">
             <a:extLst xmlns:a="http://schemas.openxmlformats.org/drawingml/2006/main">
               <a:ext uri="{FF2B5EF4-FFF2-40B4-BE49-F238E27FC236}">
-                <a16:creationId xmlns:a16="http://schemas.microsoft.com/office/drawing/2014/main" id="{8012DAC7-E006-4C69-8F9C-1DA03212DC3D}"/>
+                <a16:creationId xmlns:a16="http://schemas.microsoft.com/office/drawing/2014/main" id="{74272118-7A3E-4B6D-BC3A-610CA10A8D17}"/>
               </a:ext>
             </a:extLst>
           </p:cNvPr>
@@ -11948,7 +12226,7 @@
           <p:cNvPr id="11" name="Rounded-Rectangle-23-12">
             <a:extLst xmlns:a="http://schemas.openxmlformats.org/drawingml/2006/main">
               <a:ext uri="{FF2B5EF4-FFF2-40B4-BE49-F238E27FC236}">
-                <a16:creationId xmlns:a16="http://schemas.microsoft.com/office/drawing/2014/main" id="{C281A7CE-4DCD-4580-90EF-1E0AAB1F9195}"/>
+                <a16:creationId xmlns:a16="http://schemas.microsoft.com/office/drawing/2014/main" id="{1E07852F-A65F-4A53-9827-3727265CF7D8}"/>
               </a:ext>
             </a:extLst>
           </p:cNvPr>
@@ -11977,7 +12255,7 @@
           <p:cNvPr id="12" name="Content-Placeholder-8-13">
             <a:extLst xmlns:a="http://schemas.openxmlformats.org/drawingml/2006/main">
               <a:ext uri="{FF2B5EF4-FFF2-40B4-BE49-F238E27FC236}">
-                <a16:creationId xmlns:a16="http://schemas.microsoft.com/office/drawing/2014/main" id="{3896A365-2814-4D58-BAD1-08B91E07E32B}"/>
+                <a16:creationId xmlns:a16="http://schemas.microsoft.com/office/drawing/2014/main" id="{B03F856D-6277-4DA7-9D10-D6C5205972D4}"/>
               </a:ext>
             </a:extLst>
           </p:cNvPr>
@@ -12061,7 +12339,7 @@
           <p:cNvPr id="13" name="Text-Placeholder-16-14">
             <a:extLst xmlns:a="http://schemas.openxmlformats.org/drawingml/2006/main">
               <a:ext uri="{FF2B5EF4-FFF2-40B4-BE49-F238E27FC236}">
-                <a16:creationId xmlns:a16="http://schemas.microsoft.com/office/drawing/2014/main" id="{0BE4934B-1C02-44DE-8542-EFD373868FEB}"/>
+                <a16:creationId xmlns:a16="http://schemas.microsoft.com/office/drawing/2014/main" id="{59D9027D-2E37-4900-8496-D08B674FE885}"/>
               </a:ext>
             </a:extLst>
           </p:cNvPr>
@@ -12100,7 +12378,7 @@
               </a:defRPr>
             </a:pPr>
             <a:r>
-              <a:rPr sz="1800" b="1">
+              <a:rPr sz="1650" b="1">
                 <a:solidFill>
                   <a:srgbClr val="3D8DFF"/>
                 </a:solidFill>
@@ -12108,7 +12386,7 @@
                 <a:ea typeface="Arial"/>
                 <a:cs typeface="Arial"/>
               </a:rPr>
-              <a:t>TRIAGED</a:t>
+              <a:t>POLICY ROUTES</a:t>
             </a:r>
           </a:p>
         </p:txBody>
@@ -12118,7 +12396,7 @@
           <p:cNvPr id="14" name="Text-Placeholder-16-15">
             <a:extLst xmlns:a="http://schemas.openxmlformats.org/drawingml/2006/main">
               <a:ext uri="{FF2B5EF4-FFF2-40B4-BE49-F238E27FC236}">
-                <a16:creationId xmlns:a16="http://schemas.microsoft.com/office/drawing/2014/main" id="{600CE159-3C15-4774-9249-929BB95C2CA1}"/>
+                <a16:creationId xmlns:a16="http://schemas.microsoft.com/office/drawing/2014/main" id="{1596F2EA-3D45-4448-9A32-D8C486E3B53F}"/>
               </a:ext>
             </a:extLst>
           </p:cNvPr>
@@ -12157,7 +12435,7 @@
               </a:defRPr>
             </a:pPr>
             <a:r>
-              <a:rPr sz="1800" b="1">
+              <a:rPr sz="1650" b="1">
                 <a:solidFill>
                   <a:srgbClr val="3D8DFF"/>
                 </a:solidFill>
@@ -12165,7 +12443,7 @@
                 <a:ea typeface="Arial"/>
                 <a:cs typeface="Arial"/>
               </a:rPr>
-              <a:t>MODELLED</a:t>
+              <a:t>MODEL PREDICTS</a:t>
             </a:r>
           </a:p>
         </p:txBody>
@@ -12175,7 +12453,7 @@
           <p:cNvPr id="15" name="Text-Placeholder-16-16">
             <a:extLst xmlns:a="http://schemas.openxmlformats.org/drawingml/2006/main">
               <a:ext uri="{FF2B5EF4-FFF2-40B4-BE49-F238E27FC236}">
-                <a16:creationId xmlns:a16="http://schemas.microsoft.com/office/drawing/2014/main" id="{EEAE7DEE-EF95-4F80-969F-95EE4C0F82C2}"/>
+                <a16:creationId xmlns:a16="http://schemas.microsoft.com/office/drawing/2014/main" id="{AE7884E6-FB93-4EE4-BE8D-3907E9742423}"/>
               </a:ext>
             </a:extLst>
           </p:cNvPr>
@@ -12214,7 +12492,7 @@
               </a:defRPr>
             </a:pPr>
             <a:r>
-              <a:rPr sz="1800" b="1">
+              <a:rPr sz="1650" b="1">
                 <a:solidFill>
                   <a:srgbClr val="D9485F"/>
                 </a:solidFill>
@@ -12222,7 +12500,7 @@
                 <a:ea typeface="Arial"/>
                 <a:cs typeface="Arial"/>
               </a:rPr>
-              <a:t>HUMAN / FUTURE</a:t>
+              <a:t>REVIEWER / FUTURE</a:t>
             </a:r>
           </a:p>
         </p:txBody>
@@ -12232,7 +12510,7 @@
           <p:cNvPr id="16" name="">
             <a:extLst xmlns:a="http://schemas.openxmlformats.org/drawingml/2006/main">
               <a:ext uri="{FF2B5EF4-FFF2-40B4-BE49-F238E27FC236}">
-                <a16:creationId xmlns:a16="http://schemas.microsoft.com/office/drawing/2014/main" id="{2B29F14A-E3D4-4D55-A20A-392595041784}"/>
+                <a16:creationId xmlns:a16="http://schemas.microsoft.com/office/drawing/2014/main" id="{80736A13-56E9-404D-8EDA-930114A902BF}"/>
               </a:ext>
             </a:extLst>
           </p:cNvPr>
@@ -12265,7 +12543,7 @@
           <p:cNvPr id="17" name="">
             <a:extLst xmlns:a="http://schemas.openxmlformats.org/drawingml/2006/main">
               <a:ext uri="{FF2B5EF4-FFF2-40B4-BE49-F238E27FC236}">
-                <a16:creationId xmlns:a16="http://schemas.microsoft.com/office/drawing/2014/main" id="{EC410046-1AFC-440D-8B99-BD1760360C43}"/>
+                <a16:creationId xmlns:a16="http://schemas.microsoft.com/office/drawing/2014/main" id="{695AA60E-F76A-4174-BF41-B895E97C70FA}"/>
               </a:ext>
             </a:extLst>
           </p:cNvPr>
@@ -12321,7 +12599,7 @@
           <p:cNvPr id="18" name="">
             <a:extLst xmlns:a="http://schemas.openxmlformats.org/drawingml/2006/main">
               <a:ext uri="{FF2B5EF4-FFF2-40B4-BE49-F238E27FC236}">
-                <a16:creationId xmlns:a16="http://schemas.microsoft.com/office/drawing/2014/main" id="{10415FCF-3CD5-4EE2-A652-A99DCCB32034}"/>
+                <a16:creationId xmlns:a16="http://schemas.microsoft.com/office/drawing/2014/main" id="{FE01900B-CCA4-4191-B066-A3667ED5C163}"/>
               </a:ext>
             </a:extLst>
           </p:cNvPr>
@@ -12375,7 +12653,7 @@
     </p:spTree>
     <p:extLst>
       <p:ext uri="{BB962C8B-B14F-4D97-AF65-F5344CB8AC3E}">
-        <p14:creationId xmlns:p14="http://schemas.microsoft.com/office/powerpoint/2010/main" val="2043380641"/>
+        <p14:creationId xmlns:p14="http://schemas.microsoft.com/office/powerpoint/2010/main" val="1211122542"/>
       </p:ext>
     </p:extLst>
   </p:cSld>
@@ -12406,7 +12684,7 @@
           <p:cNvPr id="13" name="Google-Shape-532-p58-2">
             <a:extLst xmlns:a="http://schemas.openxmlformats.org/drawingml/2006/main">
               <a:ext uri="{FF2B5EF4-FFF2-40B4-BE49-F238E27FC236}">
-                <a16:creationId xmlns:a16="http://schemas.microsoft.com/office/drawing/2014/main" id="{C90133CC-1548-4FD4-B86E-1D1D7D62399F}"/>
+                <a16:creationId xmlns:a16="http://schemas.microsoft.com/office/drawing/2014/main" id="{420478B4-8784-4729-BA16-36320F8EC80B}"/>
               </a:ext>
             </a:extLst>
           </p:cNvPr>
@@ -12451,7 +12729,7 @@
           <p:cNvPr id="2" name="Google-Shape-533-p58-3">
             <a:extLst xmlns:a="http://schemas.openxmlformats.org/drawingml/2006/main">
               <a:ext uri="{FF2B5EF4-FFF2-40B4-BE49-F238E27FC236}">
-                <a16:creationId xmlns:a16="http://schemas.microsoft.com/office/drawing/2014/main" id="{61C91C58-5B89-4B7F-A7CD-D2F45DE47C53}"/>
+                <a16:creationId xmlns:a16="http://schemas.microsoft.com/office/drawing/2014/main" id="{82D1716B-C7C5-4BC2-B469-4FB81A5D4696}"/>
               </a:ext>
             </a:extLst>
           </p:cNvPr>
@@ -12509,7 +12787,7 @@
           <p:cNvPr id="3" name="Rounded-Rectangle-6-4">
             <a:extLst xmlns:a="http://schemas.openxmlformats.org/drawingml/2006/main">
               <a:ext uri="{FF2B5EF4-FFF2-40B4-BE49-F238E27FC236}">
-                <a16:creationId xmlns:a16="http://schemas.microsoft.com/office/drawing/2014/main" id="{B82276E7-C05D-444E-AB43-0ADB074FB28B}"/>
+                <a16:creationId xmlns:a16="http://schemas.microsoft.com/office/drawing/2014/main" id="{2C046478-30A9-4B6D-A15C-50C0A118DDBA}"/>
               </a:ext>
             </a:extLst>
           </p:cNvPr>
@@ -12538,7 +12816,7 @@
           <p:cNvPr id="4" name="Content-Placeholder-10-5">
             <a:extLst xmlns:a="http://schemas.openxmlformats.org/drawingml/2006/main">
               <a:ext uri="{FF2B5EF4-FFF2-40B4-BE49-F238E27FC236}">
-                <a16:creationId xmlns:a16="http://schemas.microsoft.com/office/drawing/2014/main" id="{202E084A-78E7-4F0D-84EB-5DD8CB3124E8}"/>
+                <a16:creationId xmlns:a16="http://schemas.microsoft.com/office/drawing/2014/main" id="{0CC69E5F-A94A-4DEB-AAC9-B50C0080D664}"/>
               </a:ext>
             </a:extLst>
           </p:cNvPr>
@@ -12622,7 +12900,7 @@
           <p:cNvPr id="5" name="Rounded-Rectangle-8-6">
             <a:extLst xmlns:a="http://schemas.openxmlformats.org/drawingml/2006/main">
               <a:ext uri="{FF2B5EF4-FFF2-40B4-BE49-F238E27FC236}">
-                <a16:creationId xmlns:a16="http://schemas.microsoft.com/office/drawing/2014/main" id="{A0F8CF34-D614-4B28-AC0C-4A97978D5369}"/>
+                <a16:creationId xmlns:a16="http://schemas.microsoft.com/office/drawing/2014/main" id="{276B0E82-6CFD-493A-A1E0-D428923B3770}"/>
               </a:ext>
             </a:extLst>
           </p:cNvPr>
@@ -12651,7 +12929,7 @@
           <p:cNvPr id="6" name="Content-Placeholder-10-7">
             <a:extLst xmlns:a="http://schemas.openxmlformats.org/drawingml/2006/main">
               <a:ext uri="{FF2B5EF4-FFF2-40B4-BE49-F238E27FC236}">
-                <a16:creationId xmlns:a16="http://schemas.microsoft.com/office/drawing/2014/main" id="{06C025D7-1FA3-4889-95D4-E6C8459103A8}"/>
+                <a16:creationId xmlns:a16="http://schemas.microsoft.com/office/drawing/2014/main" id="{65BFB276-EC82-486A-99EB-5AADCCE4EBD9}"/>
               </a:ext>
             </a:extLst>
           </p:cNvPr>
@@ -12698,7 +12976,7 @@
                 <a:ea typeface="Arial"/>
                 <a:cs typeface="Arial"/>
               </a:rPr>
-              <a:t>48 / 12 / 12 per class</a:t>
+              <a:t>288 JPEG images</a:t>
             </a:r>
           </a:p>
           <a:p xmlns:a="http://schemas.openxmlformats.org/drawingml/2006/main">
@@ -12725,7 +13003,7 @@
                 <a:ea typeface="Arial"/>
                 <a:cs typeface="Arial"/>
               </a:rPr>
-              <a:t>Train · validation · untouched test. Total pilot size: 288 images.</a:t>
+              <a:t>48 / 12 / 12 per class for train · validation · final test.</a:t>
             </a:r>
           </a:p>
         </p:txBody>
@@ -12735,7 +13013,7 @@
           <p:cNvPr id="7" name="Rounded-Rectangle-1-8">
             <a:extLst xmlns:a="http://schemas.openxmlformats.org/drawingml/2006/main">
               <a:ext uri="{FF2B5EF4-FFF2-40B4-BE49-F238E27FC236}">
-                <a16:creationId xmlns:a16="http://schemas.microsoft.com/office/drawing/2014/main" id="{CBB50125-4C1F-4609-8904-AEE55C18D497}"/>
+                <a16:creationId xmlns:a16="http://schemas.microsoft.com/office/drawing/2014/main" id="{BAC34795-3BA7-40BC-9C96-046F802AF2B3}"/>
               </a:ext>
             </a:extLst>
           </p:cNvPr>
@@ -12764,7 +13042,7 @@
           <p:cNvPr id="8" name="Content-Placeholder-10-9">
             <a:extLst xmlns:a="http://schemas.openxmlformats.org/drawingml/2006/main">
               <a:ext uri="{FF2B5EF4-FFF2-40B4-BE49-F238E27FC236}">
-                <a16:creationId xmlns:a16="http://schemas.microsoft.com/office/drawing/2014/main" id="{BC8E15B5-0DE0-489F-B714-A857AAE4604F}"/>
+                <a16:creationId xmlns:a16="http://schemas.microsoft.com/office/drawing/2014/main" id="{505C17C4-50B9-47C3-AEBD-CDAA461BE15C}"/>
               </a:ext>
             </a:extLst>
           </p:cNvPr>
@@ -12811,7 +13089,7 @@
                 <a:ea typeface="Arial"/>
                 <a:cs typeface="Arial"/>
               </a:rPr>
-              <a:t>Source-confounded</a:t>
+              <a:t>Source shortcut risk</a:t>
             </a:r>
           </a:p>
           <a:p xmlns:a="http://schemas.openxmlformats.org/drawingml/2006/main">
@@ -12838,7 +13116,7 @@
                 <a:ea typeface="Arial"/>
                 <a:cs typeface="Arial"/>
               </a:rPr>
-              <a:t>Safe and finance are synthetic; both weapon classes come from Weapons Set 1.</a:t>
+              <a:t>ADautoGen supplies Safe; our builder supplies Finance; Weapons Set 1 supplies both weapon classes.</a:t>
             </a:r>
           </a:p>
         </p:txBody>
@@ -12855,7 +13133,7 @@
         </p:xfrm>
         <a:graphic xmlns:a="http://schemas.openxmlformats.org/drawingml/2006/main">
           <a:graphicData uri="http://schemas.openxmlformats.org/drawingml/2006/chart">
-            <c:chart xmlns:r="http://schemas.openxmlformats.org/officeDocument/2006/relationships" xmlns:c="http://schemas.openxmlformats.org/drawingml/2006/chart" r:id="R8d1a23f8dc044883"/>
+            <c:chart xmlns:r="http://schemas.openxmlformats.org/officeDocument/2006/relationships" xmlns:c="http://schemas.openxmlformats.org/drawingml/2006/chart" r:id="R2a62e380847646ab"/>
           </a:graphicData>
         </a:graphic>
       </p:graphicFrame>
@@ -12864,7 +13142,7 @@
           <p:cNvPr id="10" name="">
             <a:extLst xmlns:a="http://schemas.openxmlformats.org/drawingml/2006/main">
               <a:ext uri="{FF2B5EF4-FFF2-40B4-BE49-F238E27FC236}">
-                <a16:creationId xmlns:a16="http://schemas.microsoft.com/office/drawing/2014/main" id="{1A44C262-BBFE-4402-8F63-E9816357EEA4}"/>
+                <a16:creationId xmlns:a16="http://schemas.microsoft.com/office/drawing/2014/main" id="{6CB5CBBB-1040-4F99-B987-3068B2F31046}"/>
               </a:ext>
             </a:extLst>
           </p:cNvPr>
@@ -12897,7 +13175,7 @@
           <p:cNvPr id="11" name="">
             <a:extLst xmlns:a="http://schemas.openxmlformats.org/drawingml/2006/main">
               <a:ext uri="{FF2B5EF4-FFF2-40B4-BE49-F238E27FC236}">
-                <a16:creationId xmlns:a16="http://schemas.microsoft.com/office/drawing/2014/main" id="{49D72261-AFE8-4FB9-B061-7FEDEFDAC9EC}"/>
+                <a16:creationId xmlns:a16="http://schemas.microsoft.com/office/drawing/2014/main" id="{2BBE0985-0B86-4A46-AD8A-6E3D2049A63E}"/>
               </a:ext>
             </a:extLst>
           </p:cNvPr>
@@ -12953,7 +13231,7 @@
           <p:cNvPr id="12" name="">
             <a:extLst xmlns:a="http://schemas.openxmlformats.org/drawingml/2006/main">
               <a:ext uri="{FF2B5EF4-FFF2-40B4-BE49-F238E27FC236}">
-                <a16:creationId xmlns:a16="http://schemas.microsoft.com/office/drawing/2014/main" id="{6ABB698D-A1A1-4F9D-A6D3-BC8E00F7339D}"/>
+                <a16:creationId xmlns:a16="http://schemas.microsoft.com/office/drawing/2014/main" id="{13155605-2E8D-406D-8C6D-629772737490}"/>
               </a:ext>
             </a:extLst>
           </p:cNvPr>
@@ -13007,7 +13285,7 @@
     </p:spTree>
     <p:extLst>
       <p:ext uri="{BB962C8B-B14F-4D97-AF65-F5344CB8AC3E}">
-        <p14:creationId xmlns:p14="http://schemas.microsoft.com/office/powerpoint/2010/main" val="219656987"/>
+        <p14:creationId xmlns:p14="http://schemas.microsoft.com/office/powerpoint/2010/main" val="1094719716"/>
       </p:ext>
     </p:extLst>
   </p:cSld>
@@ -13038,7 +13316,7 @@
           <p:cNvPr id="9" name="Google-Shape-532-p58-2">
             <a:extLst xmlns:a="http://schemas.openxmlformats.org/drawingml/2006/main">
               <a:ext uri="{FF2B5EF4-FFF2-40B4-BE49-F238E27FC236}">
-                <a16:creationId xmlns:a16="http://schemas.microsoft.com/office/drawing/2014/main" id="{A6C42AAB-8908-4E22-A27D-5CB50FE7F080}"/>
+                <a16:creationId xmlns:a16="http://schemas.microsoft.com/office/drawing/2014/main" id="{C7E58A6A-A34F-4E00-A804-31D597984DA6}"/>
               </a:ext>
             </a:extLst>
           </p:cNvPr>
@@ -13083,7 +13361,7 @@
           <p:cNvPr id="2" name="Google-Shape-533-p58-3">
             <a:extLst xmlns:a="http://schemas.openxmlformats.org/drawingml/2006/main">
               <a:ext uri="{FF2B5EF4-FFF2-40B4-BE49-F238E27FC236}">
-                <a16:creationId xmlns:a16="http://schemas.microsoft.com/office/drawing/2014/main" id="{1EEB4045-BEA8-40F8-B648-59578FF649D5}"/>
+                <a16:creationId xmlns:a16="http://schemas.microsoft.com/office/drawing/2014/main" id="{B544DF54-46F0-4E17-81BA-D513FD867A33}"/>
               </a:ext>
             </a:extLst>
           </p:cNvPr>
@@ -13122,16 +13400,16 @@
               </a:defRPr>
             </a:pPr>
             <a:r>
-              <a:rPr sz="3600">
-                <a:solidFill>
-                  <a:srgbClr val="000000"/>
-                </a:solidFill>
-                <a:latin typeface="Arial"/>
-                <a:ea typeface="Arial"/>
-                <a:cs typeface="Arial"/>
-              </a:rPr>
-              <a:t>Source style
-predicts labels</a:t>
+              <a:rPr sz="3450">
+                <a:solidFill>
+                  <a:srgbClr val="000000"/>
+                </a:solidFill>
+                <a:latin typeface="Arial"/>
+                <a:ea typeface="Arial"/>
+                <a:cs typeface="Arial"/>
+              </a:rPr>
+              <a:t>The classes look different
+for reasons unrelated to policy</a:t>
             </a:r>
           </a:p>
         </p:txBody>
@@ -13141,7 +13419,7 @@
           <p:cNvPr id="3" name="Picture-3-4-backing">
             <a:extLst xmlns:a="http://schemas.openxmlformats.org/drawingml/2006/main">
               <a:ext uri="{FF2B5EF4-FFF2-40B4-BE49-F238E27FC236}">
-                <a16:creationId xmlns:a16="http://schemas.microsoft.com/office/drawing/2014/main" id="{03E2FC4E-4810-477F-B532-D0C9FA6A08D2}"/>
+                <a16:creationId xmlns:a16="http://schemas.microsoft.com/office/drawing/2014/main" id="{C038387F-BED7-44FA-9FF0-3BC299A48FEA}"/>
               </a:ext>
             </a:extLst>
           </p:cNvPr>
@@ -13180,7 +13458,7 @@
           <p:nvPr/>
         </p:nvPicPr>
         <p:blipFill>
-          <a:blip xmlns:r="http://schemas.openxmlformats.org/officeDocument/2006/relationships" xmlns:a="http://schemas.openxmlformats.org/drawingml/2006/main" r:embed="Rd4284e2e6b264e49"/>
+          <a:blip xmlns:r="http://schemas.openxmlformats.org/officeDocument/2006/relationships" xmlns:a="http://schemas.openxmlformats.org/drawingml/2006/main" r:embed="Re54c90783a5c40a3"/>
           <a:stretch xmlns:a="http://schemas.openxmlformats.org/drawingml/2006/main"/>
         </p:blipFill>
         <p:spPr>
@@ -13198,7 +13476,7 @@
           <p:cNvPr id="5" name="Google-Shape-534-p58-5">
             <a:extLst xmlns:a="http://schemas.openxmlformats.org/drawingml/2006/main">
               <a:ext uri="{FF2B5EF4-FFF2-40B4-BE49-F238E27FC236}">
-                <a16:creationId xmlns:a16="http://schemas.microsoft.com/office/drawing/2014/main" id="{76AC7757-E7FA-481F-98D0-1A181647D2C5}"/>
+                <a16:creationId xmlns:a16="http://schemas.microsoft.com/office/drawing/2014/main" id="{210CDB9A-E119-4ED5-95DF-27DC0BCD0CA4}"/>
               </a:ext>
             </a:extLst>
           </p:cNvPr>
@@ -13272,10 +13550,8 @@
                 <a:ea typeface="Arial"/>
                 <a:cs typeface="Arial"/>
               </a:rPr>
-              <a:t>Safe: generated product scenes
-Weapons: isolated objects
-Finance: repeated synthetic templates
-Risk: the classifier may learn where the image came from instead of what policy concept it contains.</a:t>
+              <a:t>Safe images look like generated product scenes. Weapon images are often isolated objects. Finance images reuse synthetic layouts.
+Risk: the classifier may learn visual source style instead of the intended policy category.</a:t>
             </a:r>
           </a:p>
         </p:txBody>
@@ -13285,7 +13561,7 @@
           <p:cNvPr id="6" name="">
             <a:extLst xmlns:a="http://schemas.openxmlformats.org/drawingml/2006/main">
               <a:ext uri="{FF2B5EF4-FFF2-40B4-BE49-F238E27FC236}">
-                <a16:creationId xmlns:a16="http://schemas.microsoft.com/office/drawing/2014/main" id="{03E9EF31-9DEA-4119-9DDF-9AD399D87FF6}"/>
+                <a16:creationId xmlns:a16="http://schemas.microsoft.com/office/drawing/2014/main" id="{1B59C69A-6673-4935-B73F-14EFD3FE1660}"/>
               </a:ext>
             </a:extLst>
           </p:cNvPr>
@@ -13318,7 +13594,7 @@
           <p:cNvPr id="7" name="">
             <a:extLst xmlns:a="http://schemas.openxmlformats.org/drawingml/2006/main">
               <a:ext uri="{FF2B5EF4-FFF2-40B4-BE49-F238E27FC236}">
-                <a16:creationId xmlns:a16="http://schemas.microsoft.com/office/drawing/2014/main" id="{D23B0C2A-A244-4D81-9D38-F2F0BBD4B280}"/>
+                <a16:creationId xmlns:a16="http://schemas.microsoft.com/office/drawing/2014/main" id="{0B06F86D-322E-4CE6-A8B6-A7945DE28C1C}"/>
               </a:ext>
             </a:extLst>
           </p:cNvPr>
@@ -13374,7 +13650,7 @@
           <p:cNvPr id="8" name="">
             <a:extLst xmlns:a="http://schemas.openxmlformats.org/drawingml/2006/main">
               <a:ext uri="{FF2B5EF4-FFF2-40B4-BE49-F238E27FC236}">
-                <a16:creationId xmlns:a16="http://schemas.microsoft.com/office/drawing/2014/main" id="{2AE190C5-6FC4-4680-9DF5-A69F2BD64DA5}"/>
+                <a16:creationId xmlns:a16="http://schemas.microsoft.com/office/drawing/2014/main" id="{DA13FF86-A386-4056-938B-1CBA28205055}"/>
               </a:ext>
             </a:extLst>
           </p:cNvPr>
@@ -13428,7 +13704,7 @@
     </p:spTree>
     <p:extLst>
       <p:ext uri="{BB962C8B-B14F-4D97-AF65-F5344CB8AC3E}">
-        <p14:creationId xmlns:p14="http://schemas.microsoft.com/office/powerpoint/2010/main" val="1751384376"/>
+        <p14:creationId xmlns:p14="http://schemas.microsoft.com/office/powerpoint/2010/main" val="2105083111"/>
       </p:ext>
     </p:extLst>
   </p:cSld>
@@ -13459,7 +13735,7 @@
           <p:cNvPr id="21" name="Slide-Number-Placeholder-3-2">
             <a:extLst xmlns:a="http://schemas.openxmlformats.org/drawingml/2006/main">
               <a:ext uri="{FF2B5EF4-FFF2-40B4-BE49-F238E27FC236}">
-                <a16:creationId xmlns:a16="http://schemas.microsoft.com/office/drawing/2014/main" id="{492A7788-F0D0-4BE3-9FDA-D4FAB57BE6BD}"/>
+                <a16:creationId xmlns:a16="http://schemas.microsoft.com/office/drawing/2014/main" id="{06C87779-34A3-4EDB-A24A-6190656DB0E5}"/>
               </a:ext>
             </a:extLst>
           </p:cNvPr>
@@ -13502,7 +13778,7 @@
           <p:cNvPr id="2" name="Title-10-3">
             <a:extLst xmlns:a="http://schemas.openxmlformats.org/drawingml/2006/main">
               <a:ext uri="{FF2B5EF4-FFF2-40B4-BE49-F238E27FC236}">
-                <a16:creationId xmlns:a16="http://schemas.microsoft.com/office/drawing/2014/main" id="{40A5D12F-C475-4399-8F45-15D8D6D1328F}"/>
+                <a16:creationId xmlns:a16="http://schemas.microsoft.com/office/drawing/2014/main" id="{9880C525-9604-4052-A700-60B6D0979CFC}"/>
               </a:ext>
             </a:extLst>
           </p:cNvPr>
@@ -13549,7 +13825,7 @@
                 <a:ea typeface="Arial"/>
                 <a:cs typeface="Arial"/>
               </a:rPr>
-              <a:t>Separate evidence streams before policy</a:t>
+              <a:t>How the system reaches a decision</a:t>
             </a:r>
           </a:p>
         </p:txBody>
@@ -13581,7 +13857,7 @@
           <p:cNvPr id="4" name="Google-Shape-2260-p159-5">
             <a:extLst xmlns:a="http://schemas.openxmlformats.org/drawingml/2006/main">
               <a:ext uri="{FF2B5EF4-FFF2-40B4-BE49-F238E27FC236}">
-                <a16:creationId xmlns:a16="http://schemas.microsoft.com/office/drawing/2014/main" id="{EE526163-155D-4A80-A39C-5CD4DE91A391}"/>
+                <a16:creationId xmlns:a16="http://schemas.microsoft.com/office/drawing/2014/main" id="{90D7DED0-8BB0-4C74-BA95-DEFF9ECEADF6}"/>
               </a:ext>
             </a:extLst>
           </p:cNvPr>
@@ -13608,7 +13884,7 @@
           <p:cNvPr id="5" name="Google-Shape-2261-p159-6">
             <a:extLst xmlns:a="http://schemas.openxmlformats.org/drawingml/2006/main">
               <a:ext uri="{FF2B5EF4-FFF2-40B4-BE49-F238E27FC236}">
-                <a16:creationId xmlns:a16="http://schemas.microsoft.com/office/drawing/2014/main" id="{9E8D3AE2-12F2-4A53-B91E-7D7311D168A0}"/>
+                <a16:creationId xmlns:a16="http://schemas.microsoft.com/office/drawing/2014/main" id="{0B28EC32-01F4-4B16-B8EB-FF03FED2F231}"/>
               </a:ext>
             </a:extLst>
           </p:cNvPr>
@@ -13635,7 +13911,7 @@
           <p:cNvPr id="6" name="Google-Shape-2262-p159-7">
             <a:extLst xmlns:a="http://schemas.openxmlformats.org/drawingml/2006/main">
               <a:ext uri="{FF2B5EF4-FFF2-40B4-BE49-F238E27FC236}">
-                <a16:creationId xmlns:a16="http://schemas.microsoft.com/office/drawing/2014/main" id="{4BA17101-5A88-4B97-AE28-730B75A53322}"/>
+                <a16:creationId xmlns:a16="http://schemas.microsoft.com/office/drawing/2014/main" id="{59BD4D46-0335-4BAE-B2E7-9B0605DBF705}"/>
               </a:ext>
             </a:extLst>
           </p:cNvPr>
@@ -13662,7 +13938,7 @@
           <p:cNvPr id="7" name="Rounded-Rectangle-19-8">
             <a:extLst xmlns:a="http://schemas.openxmlformats.org/drawingml/2006/main">
               <a:ext uri="{FF2B5EF4-FFF2-40B4-BE49-F238E27FC236}">
-                <a16:creationId xmlns:a16="http://schemas.microsoft.com/office/drawing/2014/main" id="{F2FA311E-545F-45BB-AADA-8A46F3CED524}"/>
+                <a16:creationId xmlns:a16="http://schemas.microsoft.com/office/drawing/2014/main" id="{C11075F9-1BF5-4D33-9184-AEF27FB4C569}"/>
               </a:ext>
             </a:extLst>
           </p:cNvPr>
@@ -13691,7 +13967,7 @@
           <p:cNvPr id="8" name="Content-Placeholder-8-9">
             <a:extLst xmlns:a="http://schemas.openxmlformats.org/drawingml/2006/main">
               <a:ext uri="{FF2B5EF4-FFF2-40B4-BE49-F238E27FC236}">
-                <a16:creationId xmlns:a16="http://schemas.microsoft.com/office/drawing/2014/main" id="{5992E6D6-7D8B-4A76-B6F9-33DE4E06E0FD}"/>
+                <a16:creationId xmlns:a16="http://schemas.microsoft.com/office/drawing/2014/main" id="{2A9B1F0D-11AD-4BBC-B205-E85FF4283D45}"/>
               </a:ext>
             </a:extLst>
           </p:cNvPr>
@@ -13738,7 +14014,7 @@
                 <a:ea typeface="Arial"/>
                 <a:cs typeface="Arial"/>
               </a:rPr>
-              <a:t>1 · SEE</a:t>
+              <a:t>1 · ANALYZE</a:t>
             </a:r>
           </a:p>
           <a:p xmlns:a="http://schemas.openxmlformats.org/drawingml/2006/main">
@@ -13765,7 +14041,7 @@
                 <a:ea typeface="Arial"/>
                 <a:cs typeface="Arial"/>
               </a:rPr>
-              <a:t>Frozen ViT scores the whole image. Grounding DINO Tiny proposes weapon and explosive object evidence.</a:t>
+              <a:t>PyTorch and timm run a frozen ViT. Grounding DINO and Tesseract add optional object and text evidence.</a:t>
             </a:r>
           </a:p>
         </p:txBody>
@@ -13775,7 +14051,7 @@
           <p:cNvPr id="9" name="Rounded-Rectangle-21-10">
             <a:extLst xmlns:a="http://schemas.openxmlformats.org/drawingml/2006/main">
               <a:ext uri="{FF2B5EF4-FFF2-40B4-BE49-F238E27FC236}">
-                <a16:creationId xmlns:a16="http://schemas.microsoft.com/office/drawing/2014/main" id="{888C7F37-8FF8-449A-9942-A41E9C5B06C8}"/>
+                <a16:creationId xmlns:a16="http://schemas.microsoft.com/office/drawing/2014/main" id="{744ECA0E-BE97-4B3C-A112-73078C556497}"/>
               </a:ext>
             </a:extLst>
           </p:cNvPr>
@@ -13804,7 +14080,7 @@
           <p:cNvPr id="10" name="Content-Placeholder-8-11">
             <a:extLst xmlns:a="http://schemas.openxmlformats.org/drawingml/2006/main">
               <a:ext uri="{FF2B5EF4-FFF2-40B4-BE49-F238E27FC236}">
-                <a16:creationId xmlns:a16="http://schemas.microsoft.com/office/drawing/2014/main" id="{7E6884A1-B942-4B78-8D09-9AAEF5378867}"/>
+                <a16:creationId xmlns:a16="http://schemas.microsoft.com/office/drawing/2014/main" id="{C75F2355-D5F6-4951-BFB1-CBDDE6017401}"/>
               </a:ext>
             </a:extLst>
           </p:cNvPr>
@@ -13851,7 +14127,7 @@
                 <a:ea typeface="Arial"/>
                 <a:cs typeface="Arial"/>
               </a:rPr>
-              <a:t>2 · READ</a:t>
+              <a:t>2 · REVIEW</a:t>
             </a:r>
           </a:p>
           <a:p xmlns:a="http://schemas.openxmlformats.org/drawingml/2006/main">
@@ -13878,7 +14154,7 @@
                 <a:ea typeface="Arial"/>
                 <a:cs typeface="Arial"/>
               </a:rPr>
-              <a:t>Tesseract extracts visible text. Classifier, detector, and OCR evidence remain separately inspectable.</a:t>
+              <a:t>FastAPI coordinates the services. Streamlit shows scores, boxes, text, timing, and the uploaded case.</a:t>
             </a:r>
           </a:p>
         </p:txBody>
@@ -13888,7 +14164,7 @@
           <p:cNvPr id="11" name="Rounded-Rectangle-23-12">
             <a:extLst xmlns:a="http://schemas.openxmlformats.org/drawingml/2006/main">
               <a:ext uri="{FF2B5EF4-FFF2-40B4-BE49-F238E27FC236}">
-                <a16:creationId xmlns:a16="http://schemas.microsoft.com/office/drawing/2014/main" id="{F8C89788-6D0D-4BC0-AF2B-27BCFA4639F1}"/>
+                <a16:creationId xmlns:a16="http://schemas.microsoft.com/office/drawing/2014/main" id="{DD779268-7278-4E82-AF49-9D8E2020186E}"/>
               </a:ext>
             </a:extLst>
           </p:cNvPr>
@@ -13917,7 +14193,7 @@
           <p:cNvPr id="12" name="Content-Placeholder-8-13">
             <a:extLst xmlns:a="http://schemas.openxmlformats.org/drawingml/2006/main">
               <a:ext uri="{FF2B5EF4-FFF2-40B4-BE49-F238E27FC236}">
-                <a16:creationId xmlns:a16="http://schemas.microsoft.com/office/drawing/2014/main" id="{B9AFF51F-D9DD-4D3F-A4D0-3945AAE6E618}"/>
+                <a16:creationId xmlns:a16="http://schemas.microsoft.com/office/drawing/2014/main" id="{200CB0BC-676B-4C82-A343-47085210AADF}"/>
               </a:ext>
             </a:extLst>
           </p:cNvPr>
@@ -13991,7 +14267,7 @@
                 <a:ea typeface="Arial"/>
                 <a:cs typeface="Arial"/>
               </a:rPr>
-              <a:t>A versioned YAML policy returns APPROVE, REVIEW, or BLOCK with reasons and an audit trail.</a:t>
+              <a:t>A versioned YAML policy returns APPROVE, REVIEW, or BLOCK and saves a JSON audit record. Runs locally on CPU.</a:t>
             </a:r>
           </a:p>
         </p:txBody>
@@ -14001,7 +14277,7 @@
           <p:cNvPr id="13" name="Text-Placeholder-16-14">
             <a:extLst xmlns:a="http://schemas.openxmlformats.org/drawingml/2006/main">
               <a:ext uri="{FF2B5EF4-FFF2-40B4-BE49-F238E27FC236}">
-                <a16:creationId xmlns:a16="http://schemas.microsoft.com/office/drawing/2014/main" id="{8AC0718B-CEA9-413B-A8FA-DF9D930A1494}"/>
+                <a16:creationId xmlns:a16="http://schemas.microsoft.com/office/drawing/2014/main" id="{2F879EEB-C630-462C-95DB-2AFE4835C262}"/>
               </a:ext>
             </a:extLst>
           </p:cNvPr>
@@ -14040,7 +14316,7 @@
               </a:defRPr>
             </a:pPr>
             <a:r>
-              <a:rPr sz="1800" b="1">
+              <a:rPr sz="1650" b="1">
                 <a:solidFill>
                   <a:srgbClr val="3D8DFF"/>
                 </a:solidFill>
@@ -14048,7 +14324,7 @@
                 <a:ea typeface="Arial"/>
                 <a:cs typeface="Arial"/>
               </a:rPr>
-              <a:t>EVIDENCE</a:t>
+              <a:t>LOCAL APPLICATION</a:t>
             </a:r>
           </a:p>
         </p:txBody>
@@ -14058,7 +14334,7 @@
           <p:cNvPr id="14" name="Text-Placeholder-16-15">
             <a:extLst xmlns:a="http://schemas.openxmlformats.org/drawingml/2006/main">
               <a:ext uri="{FF2B5EF4-FFF2-40B4-BE49-F238E27FC236}">
-                <a16:creationId xmlns:a16="http://schemas.microsoft.com/office/drawing/2014/main" id="{69D2FF20-7F39-4443-836A-2B84DC7A6A36}"/>
+                <a16:creationId xmlns:a16="http://schemas.microsoft.com/office/drawing/2014/main" id="{8B71B1DE-16CD-4474-B65E-B9E6811A1112}"/>
               </a:ext>
             </a:extLst>
           </p:cNvPr>
@@ -14105,7 +14381,7 @@
                 <a:ea typeface="Arial"/>
                 <a:cs typeface="Arial"/>
               </a:rPr>
-              <a:t>INPUT + VISION</a:t>
+              <a:t>MODELS</a:t>
             </a:r>
           </a:p>
         </p:txBody>
@@ -14115,7 +14391,7 @@
           <p:cNvPr id="15" name="Text-Placeholder-16-16">
             <a:extLst xmlns:a="http://schemas.openxmlformats.org/drawingml/2006/main">
               <a:ext uri="{FF2B5EF4-FFF2-40B4-BE49-F238E27FC236}">
-                <a16:creationId xmlns:a16="http://schemas.microsoft.com/office/drawing/2014/main" id="{7D96C9DF-6E09-4C5D-8E01-8C2580C54DF5}"/>
+                <a16:creationId xmlns:a16="http://schemas.microsoft.com/office/drawing/2014/main" id="{3B9B8A9E-1803-4EF0-8EE8-8C11326763B2}"/>
               </a:ext>
             </a:extLst>
           </p:cNvPr>
@@ -14154,7 +14430,7 @@
               </a:defRPr>
             </a:pPr>
             <a:r>
-              <a:rPr sz="1800" b="1">
+              <a:rPr sz="1650" b="1">
                 <a:solidFill>
                   <a:srgbClr val="3D8DFF"/>
                 </a:solidFill>
@@ -14162,7 +14438,7 @@
                 <a:ea typeface="Arial"/>
                 <a:cs typeface="Arial"/>
               </a:rPr>
-              <a:t>VERDICT</a:t>
+              <a:t>POLICY + AUDIT</a:t>
             </a:r>
           </a:p>
         </p:txBody>
@@ -14224,7 +14500,7 @@
           <p:cNvPr id="18" name="">
             <a:extLst xmlns:a="http://schemas.openxmlformats.org/drawingml/2006/main">
               <a:ext uri="{FF2B5EF4-FFF2-40B4-BE49-F238E27FC236}">
-                <a16:creationId xmlns:a16="http://schemas.microsoft.com/office/drawing/2014/main" id="{82C00E89-285A-42CB-8364-8273CE058C36}"/>
+                <a16:creationId xmlns:a16="http://schemas.microsoft.com/office/drawing/2014/main" id="{5801E086-6FEC-411E-BED5-61A8A7B31283}"/>
               </a:ext>
             </a:extLst>
           </p:cNvPr>
@@ -14257,7 +14533,7 @@
           <p:cNvPr id="19" name="">
             <a:extLst xmlns:a="http://schemas.openxmlformats.org/drawingml/2006/main">
               <a:ext uri="{FF2B5EF4-FFF2-40B4-BE49-F238E27FC236}">
-                <a16:creationId xmlns:a16="http://schemas.microsoft.com/office/drawing/2014/main" id="{DF95CA54-118A-4D0C-B3CE-3B28656EC2DA}"/>
+                <a16:creationId xmlns:a16="http://schemas.microsoft.com/office/drawing/2014/main" id="{9BAEE79A-8E1C-4BD9-BB0A-F9D74259C9CF}"/>
               </a:ext>
             </a:extLst>
           </p:cNvPr>
@@ -14313,7 +14589,7 @@
           <p:cNvPr id="20" name="">
             <a:extLst xmlns:a="http://schemas.openxmlformats.org/drawingml/2006/main">
               <a:ext uri="{FF2B5EF4-FFF2-40B4-BE49-F238E27FC236}">
-                <a16:creationId xmlns:a16="http://schemas.microsoft.com/office/drawing/2014/main" id="{8E23FFEE-365D-49FE-AF0A-7F428E6C463E}"/>
+                <a16:creationId xmlns:a16="http://schemas.microsoft.com/office/drawing/2014/main" id="{E1FAF456-7154-439D-8ACC-A116B39417A4}"/>
               </a:ext>
             </a:extLst>
           </p:cNvPr>
@@ -14367,7 +14643,7 @@
     </p:spTree>
     <p:extLst>
       <p:ext uri="{BB962C8B-B14F-4D97-AF65-F5344CB8AC3E}">
-        <p14:creationId xmlns:p14="http://schemas.microsoft.com/office/powerpoint/2010/main" val="1891414314"/>
+        <p14:creationId xmlns:p14="http://schemas.microsoft.com/office/powerpoint/2010/main" val="196151150"/>
       </p:ext>
     </p:extLst>
   </p:cSld>
@@ -14398,7 +14674,7 @@
           <p:cNvPr id="10" name="Google-Shape-532-p58-2">
             <a:extLst xmlns:a="http://schemas.openxmlformats.org/drawingml/2006/main">
               <a:ext uri="{FF2B5EF4-FFF2-40B4-BE49-F238E27FC236}">
-                <a16:creationId xmlns:a16="http://schemas.microsoft.com/office/drawing/2014/main" id="{378AF5C7-0DF6-4EF0-9778-CCAC486B1E84}"/>
+                <a16:creationId xmlns:a16="http://schemas.microsoft.com/office/drawing/2014/main" id="{4B84A4A2-0609-4E44-BEA1-A7C1E296E01D}"/>
               </a:ext>
             </a:extLst>
           </p:cNvPr>
@@ -14443,7 +14719,7 @@
           <p:cNvPr id="2" name="Google-Shape-533-p58-3">
             <a:extLst xmlns:a="http://schemas.openxmlformats.org/drawingml/2006/main">
               <a:ext uri="{FF2B5EF4-FFF2-40B4-BE49-F238E27FC236}">
-                <a16:creationId xmlns:a16="http://schemas.microsoft.com/office/drawing/2014/main" id="{F23A0ECF-1369-4667-9606-3EAF8EB774D6}"/>
+                <a16:creationId xmlns:a16="http://schemas.microsoft.com/office/drawing/2014/main" id="{B39F2D23-AC70-4664-B1D7-455FD9506472}"/>
               </a:ext>
             </a:extLst>
           </p:cNvPr>
@@ -14490,8 +14766,8 @@
                 <a:ea typeface="Arial"/>
                 <a:cs typeface="Arial"/>
               </a:rPr>
-              <a:t>Test evidence
-stayed untouched</a:t>
+              <a:t>We kept the test set
+out of training and tuning</a:t>
             </a:r>
           </a:p>
         </p:txBody>
@@ -14501,7 +14777,7 @@
           <p:cNvPr id="3" name="Picture-3-4-backing">
             <a:extLst xmlns:a="http://schemas.openxmlformats.org/drawingml/2006/main">
               <a:ext uri="{FF2B5EF4-FFF2-40B4-BE49-F238E27FC236}">
-                <a16:creationId xmlns:a16="http://schemas.microsoft.com/office/drawing/2014/main" id="{42C7955F-D34A-4430-88D6-D46A702B019E}"/>
+                <a16:creationId xmlns:a16="http://schemas.microsoft.com/office/drawing/2014/main" id="{24041C95-EDFF-4405-9C46-C7D0DA8D5665}"/>
               </a:ext>
             </a:extLst>
           </p:cNvPr>
@@ -14540,7 +14816,7 @@
           <p:nvPr/>
         </p:nvPicPr>
         <p:blipFill>
-          <a:blip xmlns:r="http://schemas.openxmlformats.org/officeDocument/2006/relationships" xmlns:a="http://schemas.openxmlformats.org/drawingml/2006/main" r:embed="R2dd938a2baf749c6"/>
+          <a:blip xmlns:r="http://schemas.openxmlformats.org/officeDocument/2006/relationships" xmlns:a="http://schemas.openxmlformats.org/drawingml/2006/main" r:embed="R1e71ea8177634ecc"/>
           <a:stretch xmlns:a="http://schemas.openxmlformats.org/drawingml/2006/main"/>
         </p:blipFill>
         <p:spPr>
@@ -14558,7 +14834,7 @@
           <p:cNvPr id="5" name="Google-Shape-534-p58-5">
             <a:extLst xmlns:a="http://schemas.openxmlformats.org/drawingml/2006/main">
               <a:ext uri="{FF2B5EF4-FFF2-40B4-BE49-F238E27FC236}">
-                <a16:creationId xmlns:a16="http://schemas.microsoft.com/office/drawing/2014/main" id="{6505D684-E930-4A09-AFA9-8A1B919101CF}"/>
+                <a16:creationId xmlns:a16="http://schemas.microsoft.com/office/drawing/2014/main" id="{8BD1745E-AF2A-4166-BCB0-20DF73D69117}"/>
               </a:ext>
             </a:extLst>
           </p:cNvPr>
@@ -14632,10 +14908,10 @@
                 <a:ea typeface="Arial"/>
                 <a:cs typeface="Arial"/>
               </a:rPr>
-              <a:t>1  Freeze ViT and ResNet-50 backbones
+              <a:t>1  Freeze ViT and ResNet-50 because the dataset is small
 2  Fit logistic heads on train embeddings
-3  Tune thresholds on validation only
-4  Open the 48-image test once
+3  Select thresholds on validation only
+4  Run one final evaluation on 48 test images
 5  Benchmark warm batch-1 CPU</a:t>
             </a:r>
           </a:p>
@@ -14646,7 +14922,7 @@
           <p:cNvPr id="6" name="">
             <a:extLst xmlns:a="http://schemas.openxmlformats.org/drawingml/2006/main">
               <a:ext uri="{FF2B5EF4-FFF2-40B4-BE49-F238E27FC236}">
-                <a16:creationId xmlns:a16="http://schemas.microsoft.com/office/drawing/2014/main" id="{D8D09C23-3B25-4D92-AA60-480223923AC3}"/>
+                <a16:creationId xmlns:a16="http://schemas.microsoft.com/office/drawing/2014/main" id="{21DBAA0B-09CA-4DA4-8DA2-6CBF71877EE1}"/>
               </a:ext>
             </a:extLst>
           </p:cNvPr>
@@ -14694,7 +14970,7 @@
                 <a:ea typeface="Arial"/>
                 <a:cs typeface="Arial"/>
               </a:rPr>
-              <a:t>RECALL red · PRECISION blue · selected t=0.173</a:t>
+              <a:t>Selected t=0.173 on validation · recall 1.00 · precision 1.00</a:t>
             </a:r>
           </a:p>
         </p:txBody>
@@ -14704,7 +14980,7 @@
           <p:cNvPr id="7" name="">
             <a:extLst xmlns:a="http://schemas.openxmlformats.org/drawingml/2006/main">
               <a:ext uri="{FF2B5EF4-FFF2-40B4-BE49-F238E27FC236}">
-                <a16:creationId xmlns:a16="http://schemas.microsoft.com/office/drawing/2014/main" id="{B30FBDE0-C4AC-4AE6-9F41-EBD468B857EB}"/>
+                <a16:creationId xmlns:a16="http://schemas.microsoft.com/office/drawing/2014/main" id="{2A11A9F0-2DA7-4029-9412-93331E4428C1}"/>
               </a:ext>
             </a:extLst>
           </p:cNvPr>
@@ -14737,7 +15013,7 @@
           <p:cNvPr id="8" name="">
             <a:extLst xmlns:a="http://schemas.openxmlformats.org/drawingml/2006/main">
               <a:ext uri="{FF2B5EF4-FFF2-40B4-BE49-F238E27FC236}">
-                <a16:creationId xmlns:a16="http://schemas.microsoft.com/office/drawing/2014/main" id="{36C11F60-2A0F-4D67-9233-FE06A3FE72EE}"/>
+                <a16:creationId xmlns:a16="http://schemas.microsoft.com/office/drawing/2014/main" id="{70D2B64F-E578-40BE-BC47-E970691D76BB}"/>
               </a:ext>
             </a:extLst>
           </p:cNvPr>
@@ -14793,7 +15069,7 @@
           <p:cNvPr id="9" name="">
             <a:extLst xmlns:a="http://schemas.openxmlformats.org/drawingml/2006/main">
               <a:ext uri="{FF2B5EF4-FFF2-40B4-BE49-F238E27FC236}">
-                <a16:creationId xmlns:a16="http://schemas.microsoft.com/office/drawing/2014/main" id="{8AB9A85B-4228-4EB8-95B5-07959A7B9E00}"/>
+                <a16:creationId xmlns:a16="http://schemas.microsoft.com/office/drawing/2014/main" id="{6EA33F36-BAC9-4294-9BDC-5E1833E00DCF}"/>
               </a:ext>
             </a:extLst>
           </p:cNvPr>
@@ -14847,7 +15123,7 @@
     </p:spTree>
     <p:extLst>
       <p:ext uri="{BB962C8B-B14F-4D97-AF65-F5344CB8AC3E}">
-        <p14:creationId xmlns:p14="http://schemas.microsoft.com/office/powerpoint/2010/main" val="1266141350"/>
+        <p14:creationId xmlns:p14="http://schemas.microsoft.com/office/powerpoint/2010/main" val="463216346"/>
       </p:ext>
     </p:extLst>
   </p:cSld>
@@ -14878,7 +15154,7 @@
           <p:cNvPr id="16" name="Rounded-Rectangle-5-1">
             <a:extLst xmlns:a="http://schemas.openxmlformats.org/drawingml/2006/main">
               <a:ext uri="{FF2B5EF4-FFF2-40B4-BE49-F238E27FC236}">
-                <a16:creationId xmlns:a16="http://schemas.microsoft.com/office/drawing/2014/main" id="{67B17B46-D034-4AD6-886A-D318DA0FFE42}"/>
+                <a16:creationId xmlns:a16="http://schemas.microsoft.com/office/drawing/2014/main" id="{4ED1D401-D021-43A8-8A9F-0464B6F86B9C}"/>
               </a:ext>
             </a:extLst>
           </p:cNvPr>
@@ -14907,7 +15183,7 @@
           <p:cNvPr id="2" name="Rounded-Rectangle-6-2">
             <a:extLst xmlns:a="http://schemas.openxmlformats.org/drawingml/2006/main">
               <a:ext uri="{FF2B5EF4-FFF2-40B4-BE49-F238E27FC236}">
-                <a16:creationId xmlns:a16="http://schemas.microsoft.com/office/drawing/2014/main" id="{C0AEF33E-D807-4BED-B94C-8BB1A3D2CD69}"/>
+                <a16:creationId xmlns:a16="http://schemas.microsoft.com/office/drawing/2014/main" id="{0A97139F-07A3-4C97-89AB-ED06B685D3AF}"/>
               </a:ext>
             </a:extLst>
           </p:cNvPr>
@@ -14936,7 +15212,7 @@
           <p:cNvPr id="3" name="Rounded-Rectangle-7-3">
             <a:extLst xmlns:a="http://schemas.openxmlformats.org/drawingml/2006/main">
               <a:ext uri="{FF2B5EF4-FFF2-40B4-BE49-F238E27FC236}">
-                <a16:creationId xmlns:a16="http://schemas.microsoft.com/office/drawing/2014/main" id="{D626C81B-655A-4614-8D3F-88B3D2293572}"/>
+                <a16:creationId xmlns:a16="http://schemas.microsoft.com/office/drawing/2014/main" id="{BDA20544-F5EC-4DAB-A400-B73A606A7AF5}"/>
               </a:ext>
             </a:extLst>
           </p:cNvPr>
@@ -14965,7 +15241,7 @@
           <p:cNvPr id="4" name="Slide-Number-Placeholder-1-4">
             <a:extLst xmlns:a="http://schemas.openxmlformats.org/drawingml/2006/main">
               <a:ext uri="{FF2B5EF4-FFF2-40B4-BE49-F238E27FC236}">
-                <a16:creationId xmlns:a16="http://schemas.microsoft.com/office/drawing/2014/main" id="{9FCF4EEE-86A9-4767-9DD9-B5750494D390}"/>
+                <a16:creationId xmlns:a16="http://schemas.microsoft.com/office/drawing/2014/main" id="{4629BDE5-59C9-436E-9D22-4C06A0E20684}"/>
               </a:ext>
             </a:extLst>
           </p:cNvPr>
@@ -15008,7 +15284,7 @@
           <p:cNvPr id="5" name="Title-2-5">
             <a:extLst xmlns:a="http://schemas.openxmlformats.org/drawingml/2006/main">
               <a:ext uri="{FF2B5EF4-FFF2-40B4-BE49-F238E27FC236}">
-                <a16:creationId xmlns:a16="http://schemas.microsoft.com/office/drawing/2014/main" id="{6B4360DC-5281-4BE4-9A2A-4817100BCE67}"/>
+                <a16:creationId xmlns:a16="http://schemas.microsoft.com/office/drawing/2014/main" id="{7809433D-8BD9-457D-A64D-A5C4E53F00AE}"/>
               </a:ext>
             </a:extLst>
           </p:cNvPr>
@@ -15055,7 +15331,7 @@
                 <a:ea typeface="Arial"/>
                 <a:cs typeface="Arial"/>
               </a:rPr>
-              <a:t>Research supports components, not claims</a:t>
+              <a:t>What prior research contributed</a:t>
             </a:r>
           </a:p>
         </p:txBody>
@@ -15065,7 +15341,7 @@
           <p:cNvPr id="6" name="Content-Placeholder-9-6">
             <a:extLst xmlns:a="http://schemas.openxmlformats.org/drawingml/2006/main">
               <a:ext uri="{FF2B5EF4-FFF2-40B4-BE49-F238E27FC236}">
-                <a16:creationId xmlns:a16="http://schemas.microsoft.com/office/drawing/2014/main" id="{3C368817-8A48-491A-B31B-83E03C166E1B}"/>
+                <a16:creationId xmlns:a16="http://schemas.microsoft.com/office/drawing/2014/main" id="{E51E75A7-E615-4409-BB56-E11669CA6473}"/>
               </a:ext>
             </a:extLst>
           </p:cNvPr>
@@ -15112,7 +15388,7 @@
                 <a:ea typeface="Arial"/>
                 <a:cs typeface="Arial"/>
               </a:rPr>
-              <a:t>Patch attention supplies a transferable whole-image representation.</a:t>
+              <a:t>Dosovitskiy et al. (2021): transferable whole-image features.</a:t>
             </a:r>
           </a:p>
         </p:txBody>
@@ -15122,7 +15398,7 @@
           <p:cNvPr id="7" name="Content-Placeholder-10-7">
             <a:extLst xmlns:a="http://schemas.openxmlformats.org/drawingml/2006/main">
               <a:ext uri="{FF2B5EF4-FFF2-40B4-BE49-F238E27FC236}">
-                <a16:creationId xmlns:a16="http://schemas.microsoft.com/office/drawing/2014/main" id="{BC674C9E-FAFA-411A-BDED-716690A9DAE7}"/>
+                <a16:creationId xmlns:a16="http://schemas.microsoft.com/office/drawing/2014/main" id="{B3896282-08A2-4E2E-8460-04BD0A1F64D4}"/>
               </a:ext>
             </a:extLst>
           </p:cNvPr>
@@ -15169,7 +15445,7 @@
                 <a:ea typeface="Arial"/>
                 <a:cs typeface="Arial"/>
               </a:rPr>
-              <a:t>Visible words add evidence; explicit policy rules keep the final action inspectable.</a:t>
+              <a:t>Tesseract OCR + YAML rules: text evidence and traceable decisions.</a:t>
             </a:r>
           </a:p>
         </p:txBody>
@@ -15179,7 +15455,7 @@
           <p:cNvPr id="8" name="Content-Placeholder-11-8">
             <a:extLst xmlns:a="http://schemas.openxmlformats.org/drawingml/2006/main">
               <a:ext uri="{FF2B5EF4-FFF2-40B4-BE49-F238E27FC236}">
-                <a16:creationId xmlns:a16="http://schemas.microsoft.com/office/drawing/2014/main" id="{881BF35F-9705-444E-93B7-6B3755BABBE8}"/>
+                <a16:creationId xmlns:a16="http://schemas.microsoft.com/office/drawing/2014/main" id="{4BBF0BAD-E833-4A4E-BBAB-7D951EADE4FF}"/>
               </a:ext>
             </a:extLst>
           </p:cNvPr>
@@ -15226,7 +15502,7 @@
                 <a:ea typeface="Arial"/>
                 <a:cs typeface="Arial"/>
               </a:rPr>
-              <a:t>Text-conditioned detection localizes open-vocabulary object cues.</a:t>
+              <a:t>Liu et al. (2023): open-vocabulary object localization.</a:t>
             </a:r>
           </a:p>
         </p:txBody>
@@ -15236,7 +15512,7 @@
           <p:cNvPr id="9" name="Content-Placeholder-9-9">
             <a:extLst xmlns:a="http://schemas.openxmlformats.org/drawingml/2006/main">
               <a:ext uri="{FF2B5EF4-FFF2-40B4-BE49-F238E27FC236}">
-                <a16:creationId xmlns:a16="http://schemas.microsoft.com/office/drawing/2014/main" id="{8ECCC9F2-A83C-406E-91E7-8EF55CFD3612}"/>
+                <a16:creationId xmlns:a16="http://schemas.microsoft.com/office/drawing/2014/main" id="{BCF9D82C-7B6A-4D32-97B9-197B016458C9}"/>
               </a:ext>
             </a:extLst>
           </p:cNvPr>
@@ -15293,7 +15569,7 @@
           <p:cNvPr id="10" name="Content-Placeholder-9-10">
             <a:extLst xmlns:a="http://schemas.openxmlformats.org/drawingml/2006/main">
               <a:ext uri="{FF2B5EF4-FFF2-40B4-BE49-F238E27FC236}">
-                <a16:creationId xmlns:a16="http://schemas.microsoft.com/office/drawing/2014/main" id="{36418CDE-5A9D-412E-B476-D8B5BE380443}"/>
+                <a16:creationId xmlns:a16="http://schemas.microsoft.com/office/drawing/2014/main" id="{C3A54908-2433-4A51-AA2C-427E078ACB16}"/>
               </a:ext>
             </a:extLst>
           </p:cNvPr>
@@ -15350,7 +15626,7 @@
           <p:cNvPr id="11" name="Content-Placeholder-9-11">
             <a:extLst xmlns:a="http://schemas.openxmlformats.org/drawingml/2006/main">
               <a:ext uri="{FF2B5EF4-FFF2-40B4-BE49-F238E27FC236}">
-                <a16:creationId xmlns:a16="http://schemas.microsoft.com/office/drawing/2014/main" id="{C3E8E421-07D9-4FC6-AD32-328663AEB161}"/>
+                <a16:creationId xmlns:a16="http://schemas.microsoft.com/office/drawing/2014/main" id="{30F312F3-BE3E-4970-95D1-8B7EC0890132}"/>
               </a:ext>
             </a:extLst>
           </p:cNvPr>
@@ -15407,7 +15683,7 @@
           <p:cNvPr id="12" name="Content-Placeholder-15-12">
             <a:extLst xmlns:a="http://schemas.openxmlformats.org/drawingml/2006/main">
               <a:ext uri="{FF2B5EF4-FFF2-40B4-BE49-F238E27FC236}">
-                <a16:creationId xmlns:a16="http://schemas.microsoft.com/office/drawing/2014/main" id="{D0D29CD6-853B-4C1D-80D9-4635A351F85E}"/>
+                <a16:creationId xmlns:a16="http://schemas.microsoft.com/office/drawing/2014/main" id="{8BAC18B2-2BFF-4C81-8731-67B7319F6A26}"/>
               </a:ext>
             </a:extLst>
           </p:cNvPr>
@@ -15454,7 +15730,7 @@
                 <a:ea typeface="Arial"/>
                 <a:cs typeface="Arial"/>
               </a:rPr>
-              <a:t>LITERATURE BOUNDARY</a:t>
+              <a:t>LITERATURE + BENCHMARKS</a:t>
             </a:r>
           </a:p>
           <a:p xmlns:a="http://schemas.openxmlformats.org/drawingml/2006/main">
@@ -15481,7 +15757,7 @@
                 <a:ea typeface="Arial"/>
                 <a:cs typeface="Arial"/>
               </a:rPr>
-              <a:t>Papers and model cards explain why each component is plausible. Only this project’s saved evaluation can support claims about this pilot.</a:t>
+              <a:t>Prior work informed our model choices. No outside benchmark is directly comparable to this four-label policy task, so we evaluate against the proposal targets and our saved results.</a:t>
             </a:r>
           </a:p>
         </p:txBody>
@@ -15491,7 +15767,7 @@
           <p:cNvPr id="13" name="">
             <a:extLst xmlns:a="http://schemas.openxmlformats.org/drawingml/2006/main">
               <a:ext uri="{FF2B5EF4-FFF2-40B4-BE49-F238E27FC236}">
-                <a16:creationId xmlns:a16="http://schemas.microsoft.com/office/drawing/2014/main" id="{8365CEDB-B8B4-42E0-8EAE-0D1CEA385067}"/>
+                <a16:creationId xmlns:a16="http://schemas.microsoft.com/office/drawing/2014/main" id="{98D58462-AC25-45D4-9B63-BF29C140CFF4}"/>
               </a:ext>
             </a:extLst>
           </p:cNvPr>
@@ -15524,7 +15800,7 @@
           <p:cNvPr id="14" name="">
             <a:extLst xmlns:a="http://schemas.openxmlformats.org/drawingml/2006/main">
               <a:ext uri="{FF2B5EF4-FFF2-40B4-BE49-F238E27FC236}">
-                <a16:creationId xmlns:a16="http://schemas.microsoft.com/office/drawing/2014/main" id="{5885B10E-36B2-4C33-9D2E-0D7791EA0E62}"/>
+                <a16:creationId xmlns:a16="http://schemas.microsoft.com/office/drawing/2014/main" id="{2554E7E8-1DA5-42EC-BBC3-0CFAE833C3BF}"/>
               </a:ext>
             </a:extLst>
           </p:cNvPr>
@@ -15580,7 +15856,7 @@
           <p:cNvPr id="15" name="">
             <a:extLst xmlns:a="http://schemas.openxmlformats.org/drawingml/2006/main">
               <a:ext uri="{FF2B5EF4-FFF2-40B4-BE49-F238E27FC236}">
-                <a16:creationId xmlns:a16="http://schemas.microsoft.com/office/drawing/2014/main" id="{9A1A6F92-F081-4697-860E-847846CB9588}"/>
+                <a16:creationId xmlns:a16="http://schemas.microsoft.com/office/drawing/2014/main" id="{227BB061-D2D8-4B15-AF4F-CA78A9D8371C}"/>
               </a:ext>
             </a:extLst>
           </p:cNvPr>
@@ -15634,7 +15910,7 @@
     </p:spTree>
     <p:extLst>
       <p:ext uri="{BB962C8B-B14F-4D97-AF65-F5344CB8AC3E}">
-        <p14:creationId xmlns:p14="http://schemas.microsoft.com/office/powerpoint/2010/main" val="1315555050"/>
+        <p14:creationId xmlns:p14="http://schemas.microsoft.com/office/powerpoint/2010/main" val="954202193"/>
       </p:ext>
     </p:extLst>
   </p:cSld>
@@ -15642,9 +15918,9 @@
 </file>
 
 <file path=ppt/theme/theme1.xml><?xml version="1.0" encoding="utf-8"?>
-<a:theme xmlns:a="http://schemas.openxmlformats.org/drawingml/2006/main" name="ChatGPT">
+<a:theme xmlns:a="http://schemas.openxmlformats.org/drawingml/2006/main" name="Ad Safety Project">
   <a:themeElements>
-    <a:clrScheme name="ChatGPT">
+    <a:clrScheme name="Ad Safety Project">
       <a:dk1>
         <a:srgbClr val="000000"/>
       </a:dk1>
@@ -15694,7 +15970,7 @@
         <a:cs typeface="Calibri"/>
       </a:minorFont>
     </a:fontScheme>
-    <a:fmtScheme name="ChatGPT">
+    <a:fmtScheme name="Ad Safety Project">
       <a:fillStyleLst>
         <a:solidFill>
           <a:schemeClr val="phClr"/>

</xml_diff>